<commit_message>
Geschichte 8: Raster an Gruppenpuzzle angepasst (Anzahl, Bildung, Vorrechte, Pflichten, Mitbestimmung)
Co-Authored-By: Claude Sonnet 5.5 <noreply@anthropic.com>
Claude-Session: https://claude.ai/code/session_01CtRuNVyt8v9M882BKEmgNb
</commit_message>
<xml_diff>
--- a/Geschichte_8/Absolutismus_Wiederholung/Praesentation_Absolutismus_Wiederholung.pptx
+++ b/Geschichte_8/Absolutismus_Wiederholung/Praesentation_Absolutismus_Wiederholung.pptx
@@ -1216,7 +1216,7 @@
           <a:p>
             <a:r>
               <a:rPr lang="en-US" dirty="0"/>
-              <a:t>Ansage: „Hefte zu. Ihr schreibt noch nichts auf. Meldet euch.“ Tabelle (Stand | Anteil | Rechte | Pflichten | Mitbestimmung) bereits leer an der Tafel. Nach dem gemeinsamen Ausfüllen: „Jetzt schreibt ihr ab: die Tabelle. Mit Lineal.“ Lösungen siehe Tafelskript. Hinweis zur Mitbestimmung: Die Generalstände (je 1 Stimme pro Stand) wurden von 1614 bis 1789 nicht einberufen – unter Ludwig XIV. gab es praktisch keine Mitbestimmung.</a:t>
+              <a:t>Ansage: „Hefte zu. Ihr schreibt noch nichts auf. Meldet euch.“ Raster aus dem Gruppenpuzzle (Stand | Anzahl | Bildung | Vorrechte | Pflichten) plus Spalte Mitbestimmung bereits leer an der Tafel. Nach dem gemeinsamen Ausfüllen: „Jetzt schreibt ihr ab: die Tabelle. Mit Lineal.“ Lösungen siehe Tafelskript. Hinweis zur Mitbestimmung: Die Generalstände (je 1 Stimme pro Stand) wurden von 1614 bis 1789 nicht einberufen – unter Ludwig XIV. gab es praktisch keine Mitbestimmung.</a:t>
             </a:r>
             <a:endParaRPr lang="en-US" dirty="0"/>
           </a:p>
@@ -3521,7 +3521,7 @@
                 <a:ea typeface="Calibri" pitchFamily="34" charset="-122"/>
                 <a:cs typeface="Calibri" pitchFamily="34" charset="-120"/>
               </a:rPr>
-              <a:t>Rechte · Pflichten · Anzahl (Anteil der Stände) · Mitbestimmung</a:t>
+              <a:t>Vorrechte · Pflichten · Anzahl · Mitbestimmung (dazu: Bildung)</a:t>
             </a:r>
             <a:endParaRPr lang="en-US" sz="1900" dirty="0"/>
           </a:p>
@@ -8036,7 +8036,7 @@
         <p:spPr>
           <a:xfrm>
             <a:off x="548640" y="3209544"/>
-            <a:ext cx="2011680" cy="411480"/>
+            <a:ext cx="1554480" cy="411480"/>
           </a:xfrm>
           <a:prstGeom prst="roundRect">
             <a:avLst>
@@ -8058,7 +8058,7 @@
         <p:spPr>
           <a:xfrm>
             <a:off x="548640" y="3209544"/>
-            <a:ext cx="2011680" cy="411480"/>
+            <a:ext cx="1554480" cy="411480"/>
           </a:xfrm>
           <a:prstGeom prst="rect">
             <a:avLst/>
@@ -8096,8 +8096,8 @@
         </p:nvSpPr>
         <p:spPr>
           <a:xfrm>
-            <a:off x="2651760" y="3209544"/>
-            <a:ext cx="1371600" cy="411480"/>
+            <a:off x="2194560" y="3209544"/>
+            <a:ext cx="1097280" cy="411480"/>
           </a:xfrm>
           <a:prstGeom prst="roundRect">
             <a:avLst>
@@ -8118,8 +8118,8 @@
         </p:nvSpPr>
         <p:spPr>
           <a:xfrm>
-            <a:off x="2651760" y="3209544"/>
-            <a:ext cx="1371600" cy="411480"/>
+            <a:off x="2194560" y="3209544"/>
+            <a:ext cx="1097280" cy="411480"/>
           </a:xfrm>
           <a:prstGeom prst="rect">
             <a:avLst/>
@@ -8143,7 +8143,7 @@
                 <a:ea typeface="Calibri" pitchFamily="34" charset="-122"/>
                 <a:cs typeface="Calibri" pitchFamily="34" charset="-120"/>
               </a:rPr>
-              <a:t>Anteil</a:t>
+              <a:t>Anzahl</a:t>
             </a:r>
             <a:endParaRPr lang="en-US" sz="1700" dirty="0"/>
           </a:p>
@@ -8157,8 +8157,8 @@
         </p:nvSpPr>
         <p:spPr>
           <a:xfrm>
-            <a:off x="4114800" y="3209544"/>
-            <a:ext cx="2560320" cy="411480"/>
+            <a:off x="3383280" y="3209544"/>
+            <a:ext cx="1645920" cy="411480"/>
           </a:xfrm>
           <a:prstGeom prst="roundRect">
             <a:avLst>
@@ -8179,8 +8179,8 @@
         </p:nvSpPr>
         <p:spPr>
           <a:xfrm>
-            <a:off x="4114800" y="3209544"/>
-            <a:ext cx="2560320" cy="411480"/>
+            <a:off x="3383280" y="3209544"/>
+            <a:ext cx="1645920" cy="411480"/>
           </a:xfrm>
           <a:prstGeom prst="rect">
             <a:avLst/>
@@ -8204,7 +8204,7 @@
                 <a:ea typeface="Calibri" pitchFamily="34" charset="-122"/>
                 <a:cs typeface="Calibri" pitchFamily="34" charset="-120"/>
               </a:rPr>
-              <a:t>Rechte</a:t>
+              <a:t>Bildung</a:t>
             </a:r>
             <a:endParaRPr lang="en-US" sz="1700" dirty="0"/>
           </a:p>
@@ -8218,8 +8218,8 @@
         </p:nvSpPr>
         <p:spPr>
           <a:xfrm>
-            <a:off x="6766560" y="3209544"/>
-            <a:ext cx="2560320" cy="411480"/>
+            <a:off x="5120640" y="3209544"/>
+            <a:ext cx="2103120" cy="411480"/>
           </a:xfrm>
           <a:prstGeom prst="roundRect">
             <a:avLst>
@@ -8240,8 +8240,8 @@
         </p:nvSpPr>
         <p:spPr>
           <a:xfrm>
-            <a:off x="6766560" y="3209544"/>
-            <a:ext cx="2560320" cy="411480"/>
+            <a:off x="5120640" y="3209544"/>
+            <a:ext cx="2103120" cy="411480"/>
           </a:xfrm>
           <a:prstGeom prst="rect">
             <a:avLst/>
@@ -8265,7 +8265,7 @@
                 <a:ea typeface="Calibri" pitchFamily="34" charset="-122"/>
                 <a:cs typeface="Calibri" pitchFamily="34" charset="-120"/>
               </a:rPr>
-              <a:t>Pflichten</a:t>
+              <a:t>Vorrechte</a:t>
             </a:r>
             <a:endParaRPr lang="en-US" sz="1700" dirty="0"/>
           </a:p>
@@ -8279,8 +8279,8 @@
         </p:nvSpPr>
         <p:spPr>
           <a:xfrm>
-            <a:off x="9418320" y="3209544"/>
-            <a:ext cx="2148840" cy="411480"/>
+            <a:off x="7315200" y="3209544"/>
+            <a:ext cx="2103120" cy="411480"/>
           </a:xfrm>
           <a:prstGeom prst="roundRect">
             <a:avLst>
@@ -8301,8 +8301,8 @@
         </p:nvSpPr>
         <p:spPr>
           <a:xfrm>
-            <a:off x="9418320" y="3209544"/>
-            <a:ext cx="2148840" cy="411480"/>
+            <a:off x="7315200" y="3209544"/>
+            <a:ext cx="2103120" cy="411480"/>
           </a:xfrm>
           <a:prstGeom prst="rect">
             <a:avLst/>
@@ -8326,7 +8326,7 @@
                 <a:ea typeface="Calibri" pitchFamily="34" charset="-122"/>
                 <a:cs typeface="Calibri" pitchFamily="34" charset="-120"/>
               </a:rPr>
-              <a:t>Mitbestimmung</a:t>
+              <a:t>Pflichten</a:t>
             </a:r>
             <a:endParaRPr lang="en-US" sz="1700" dirty="0"/>
           </a:p>
@@ -8340,8 +8340,69 @@
         </p:nvSpPr>
         <p:spPr>
           <a:xfrm>
+            <a:off x="9509760" y="3209544"/>
+            <a:ext cx="2057400" cy="411480"/>
+          </a:xfrm>
+          <a:prstGeom prst="roundRect">
+            <a:avLst>
+              <a:gd name="adj" fmla="val 11111"/>
+            </a:avLst>
+          </a:prstGeom>
+          <a:solidFill>
+            <a:srgbClr val="1E2761"/>
+          </a:solidFill>
+          <a:ln/>
+        </p:spPr>
+      </p:sp>
+      <p:sp>
+        <p:nvSpPr>
+          <p:cNvPr id="30" name="Text 27"/>
+          <p:cNvSpPr txBox="1"/>
+          <p:nvPr/>
+        </p:nvSpPr>
+        <p:spPr>
+          <a:xfrm>
+            <a:off x="9509760" y="3209544"/>
+            <a:ext cx="2057400" cy="411480"/>
+          </a:xfrm>
+          <a:prstGeom prst="rect">
+            <a:avLst/>
+          </a:prstGeom>
+          <a:noFill/>
+          <a:ln/>
+        </p:spPr>
+        <p:txBody>
+          <a:bodyPr wrap="square" lIns="0" tIns="0" rIns="0" bIns="0" rtlCol="0" anchor="ctr"/>
+          <a:lstStyle/>
+          <a:p>
+            <a:pPr algn="ctr" indent="0" marL="0">
+              <a:buNone/>
+            </a:pPr>
+            <a:r>
+              <a:rPr lang="en-US" sz="1700" b="1" dirty="0">
+                <a:solidFill>
+                  <a:srgbClr val="FFFFFF"/>
+                </a:solidFill>
+                <a:latin typeface="Calibri" pitchFamily="34" charset="0"/>
+                <a:ea typeface="Calibri" pitchFamily="34" charset="-122"/>
+                <a:cs typeface="Calibri" pitchFamily="34" charset="-120"/>
+              </a:rPr>
+              <a:t>Mitbestimmung</a:t>
+            </a:r>
+            <a:endParaRPr lang="en-US" sz="1700" dirty="0"/>
+          </a:p>
+        </p:txBody>
+      </p:sp>
+      <p:sp>
+        <p:nvSpPr>
+          <p:cNvPr id="31" name="Shape 28"/>
+          <p:cNvSpPr/>
+          <p:nvPr/>
+        </p:nvSpPr>
+        <p:spPr>
+          <a:xfrm>
             <a:off x="548640" y="3694176"/>
-            <a:ext cx="2011680" cy="585216"/>
+            <a:ext cx="1554480" cy="585216"/>
           </a:xfrm>
           <a:prstGeom prst="roundRect">
             <a:avLst>
@@ -8356,14 +8417,14 @@
       </p:sp>
       <p:sp>
         <p:nvSpPr>
-          <p:cNvPr id="30" name="Text 27"/>
+          <p:cNvPr id="32" name="Text 29"/>
           <p:cNvSpPr txBox="1"/>
           <p:nvPr/>
         </p:nvSpPr>
         <p:spPr>
           <a:xfrm>
             <a:off x="548640" y="3694176"/>
-            <a:ext cx="2011680" cy="585216"/>
+            <a:ext cx="1554480" cy="585216"/>
           </a:xfrm>
           <a:prstGeom prst="rect">
             <a:avLst/>
@@ -8395,14 +8456,14 @@
       </p:sp>
       <p:sp>
         <p:nvSpPr>
-          <p:cNvPr id="31" name="Shape 28"/>
+          <p:cNvPr id="33" name="Shape 30"/>
           <p:cNvSpPr/>
           <p:nvPr/>
         </p:nvSpPr>
         <p:spPr>
           <a:xfrm>
-            <a:off x="2651760" y="3694176"/>
-            <a:ext cx="1371600" cy="585216"/>
+            <a:off x="2194560" y="3694176"/>
+            <a:ext cx="1097280" cy="585216"/>
           </a:xfrm>
           <a:prstGeom prst="roundRect">
             <a:avLst>
@@ -8417,14 +8478,14 @@
       </p:sp>
       <p:sp>
         <p:nvSpPr>
-          <p:cNvPr id="32" name="Shape 29"/>
+          <p:cNvPr id="34" name="Shape 31"/>
           <p:cNvSpPr/>
           <p:nvPr/>
         </p:nvSpPr>
         <p:spPr>
           <a:xfrm>
-            <a:off x="4114800" y="3694176"/>
-            <a:ext cx="2560320" cy="585216"/>
+            <a:off x="3383280" y="3694176"/>
+            <a:ext cx="1645920" cy="585216"/>
           </a:xfrm>
           <a:prstGeom prst="roundRect">
             <a:avLst>
@@ -8439,14 +8500,14 @@
       </p:sp>
       <p:sp>
         <p:nvSpPr>
-          <p:cNvPr id="33" name="Shape 30"/>
+          <p:cNvPr id="35" name="Shape 32"/>
           <p:cNvSpPr/>
           <p:nvPr/>
         </p:nvSpPr>
         <p:spPr>
           <a:xfrm>
-            <a:off x="6766560" y="3694176"/>
-            <a:ext cx="2560320" cy="585216"/>
+            <a:off x="5120640" y="3694176"/>
+            <a:ext cx="2103120" cy="585216"/>
           </a:xfrm>
           <a:prstGeom prst="roundRect">
             <a:avLst>
@@ -8461,14 +8522,14 @@
       </p:sp>
       <p:sp>
         <p:nvSpPr>
-          <p:cNvPr id="34" name="Shape 31"/>
+          <p:cNvPr id="36" name="Shape 33"/>
           <p:cNvSpPr/>
           <p:nvPr/>
         </p:nvSpPr>
         <p:spPr>
           <a:xfrm>
-            <a:off x="9418320" y="3694176"/>
-            <a:ext cx="2148840" cy="585216"/>
+            <a:off x="7315200" y="3694176"/>
+            <a:ext cx="2103120" cy="585216"/>
           </a:xfrm>
           <a:prstGeom prst="roundRect">
             <a:avLst>
@@ -8483,14 +8544,14 @@
       </p:sp>
       <p:sp>
         <p:nvSpPr>
-          <p:cNvPr id="35" name="Shape 32"/>
+          <p:cNvPr id="37" name="Shape 34"/>
           <p:cNvSpPr/>
           <p:nvPr/>
         </p:nvSpPr>
         <p:spPr>
           <a:xfrm>
-            <a:off x="548640" y="4352544"/>
-            <a:ext cx="2011680" cy="585216"/>
+            <a:off x="9509760" y="3694176"/>
+            <a:ext cx="2057400" cy="585216"/>
           </a:xfrm>
           <a:prstGeom prst="roundRect">
             <a:avLst>
@@ -8498,60 +8559,21 @@
             </a:avLst>
           </a:prstGeom>
           <a:solidFill>
-            <a:srgbClr val="EAF0FA"/>
-          </a:solidFill>
-          <a:ln/>
-        </p:spPr>
-      </p:sp>
-      <p:sp>
-        <p:nvSpPr>
-          <p:cNvPr id="36" name="Text 33"/>
-          <p:cNvSpPr txBox="1"/>
+            <a:srgbClr val="F4F7FD"/>
+          </a:solidFill>
+          <a:ln/>
+        </p:spPr>
+      </p:sp>
+      <p:sp>
+        <p:nvSpPr>
+          <p:cNvPr id="38" name="Shape 35"/>
+          <p:cNvSpPr/>
           <p:nvPr/>
         </p:nvSpPr>
         <p:spPr>
           <a:xfrm>
             <a:off x="548640" y="4352544"/>
-            <a:ext cx="2011680" cy="585216"/>
-          </a:xfrm>
-          <a:prstGeom prst="rect">
-            <a:avLst/>
-          </a:prstGeom>
-          <a:noFill/>
-          <a:ln/>
-        </p:spPr>
-        <p:txBody>
-          <a:bodyPr wrap="square" lIns="0" tIns="0" rIns="0" bIns="0" rtlCol="0" anchor="ctr"/>
-          <a:lstStyle/>
-          <a:p>
-            <a:pPr algn="ctr" indent="0" marL="0">
-              <a:buNone/>
-            </a:pPr>
-            <a:r>
-              <a:rPr lang="en-US" sz="1900" b="1" dirty="0">
-                <a:solidFill>
-                  <a:srgbClr val="1E2761"/>
-                </a:solidFill>
-                <a:latin typeface="Cambria" pitchFamily="34" charset="0"/>
-                <a:ea typeface="Cambria" pitchFamily="34" charset="-122"/>
-                <a:cs typeface="Cambria" pitchFamily="34" charset="-120"/>
-              </a:rPr>
-              <a:t>2. Stand</a:t>
-            </a:r>
-            <a:endParaRPr lang="en-US" sz="1900" dirty="0"/>
-          </a:p>
-        </p:txBody>
-      </p:sp>
-      <p:sp>
-        <p:nvSpPr>
-          <p:cNvPr id="37" name="Shape 34"/>
-          <p:cNvSpPr/>
-          <p:nvPr/>
-        </p:nvSpPr>
-        <p:spPr>
-          <a:xfrm>
-            <a:off x="2651760" y="4352544"/>
-            <a:ext cx="1371600" cy="585216"/>
+            <a:ext cx="1554480" cy="585216"/>
           </a:xfrm>
           <a:prstGeom prst="roundRect">
             <a:avLst>
@@ -8559,21 +8581,60 @@
             </a:avLst>
           </a:prstGeom>
           <a:solidFill>
-            <a:srgbClr val="F4F7FD"/>
-          </a:solidFill>
-          <a:ln/>
-        </p:spPr>
-      </p:sp>
-      <p:sp>
-        <p:nvSpPr>
-          <p:cNvPr id="38" name="Shape 35"/>
+            <a:srgbClr val="EAF0FA"/>
+          </a:solidFill>
+          <a:ln/>
+        </p:spPr>
+      </p:sp>
+      <p:sp>
+        <p:nvSpPr>
+          <p:cNvPr id="39" name="Text 36"/>
+          <p:cNvSpPr txBox="1"/>
+          <p:nvPr/>
+        </p:nvSpPr>
+        <p:spPr>
+          <a:xfrm>
+            <a:off x="548640" y="4352544"/>
+            <a:ext cx="1554480" cy="585216"/>
+          </a:xfrm>
+          <a:prstGeom prst="rect">
+            <a:avLst/>
+          </a:prstGeom>
+          <a:noFill/>
+          <a:ln/>
+        </p:spPr>
+        <p:txBody>
+          <a:bodyPr wrap="square" lIns="0" tIns="0" rIns="0" bIns="0" rtlCol="0" anchor="ctr"/>
+          <a:lstStyle/>
+          <a:p>
+            <a:pPr algn="ctr" indent="0" marL="0">
+              <a:buNone/>
+            </a:pPr>
+            <a:r>
+              <a:rPr lang="en-US" sz="1900" b="1" dirty="0">
+                <a:solidFill>
+                  <a:srgbClr val="1E2761"/>
+                </a:solidFill>
+                <a:latin typeface="Cambria" pitchFamily="34" charset="0"/>
+                <a:ea typeface="Cambria" pitchFamily="34" charset="-122"/>
+                <a:cs typeface="Cambria" pitchFamily="34" charset="-120"/>
+              </a:rPr>
+              <a:t>2. Stand</a:t>
+            </a:r>
+            <a:endParaRPr lang="en-US" sz="1900" dirty="0"/>
+          </a:p>
+        </p:txBody>
+      </p:sp>
+      <p:sp>
+        <p:nvSpPr>
+          <p:cNvPr id="40" name="Shape 37"/>
           <p:cNvSpPr/>
           <p:nvPr/>
         </p:nvSpPr>
         <p:spPr>
           <a:xfrm>
-            <a:off x="4114800" y="4352544"/>
-            <a:ext cx="2560320" cy="585216"/>
+            <a:off x="2194560" y="4352544"/>
+            <a:ext cx="1097280" cy="585216"/>
           </a:xfrm>
           <a:prstGeom prst="roundRect">
             <a:avLst>
@@ -8588,14 +8649,14 @@
       </p:sp>
       <p:sp>
         <p:nvSpPr>
-          <p:cNvPr id="39" name="Shape 36"/>
+          <p:cNvPr id="41" name="Shape 38"/>
           <p:cNvSpPr/>
           <p:nvPr/>
         </p:nvSpPr>
         <p:spPr>
           <a:xfrm>
-            <a:off x="6766560" y="4352544"/>
-            <a:ext cx="2560320" cy="585216"/>
+            <a:off x="3383280" y="4352544"/>
+            <a:ext cx="1645920" cy="585216"/>
           </a:xfrm>
           <a:prstGeom prst="roundRect">
             <a:avLst>
@@ -8610,14 +8671,14 @@
       </p:sp>
       <p:sp>
         <p:nvSpPr>
-          <p:cNvPr id="40" name="Shape 37"/>
+          <p:cNvPr id="42" name="Shape 39"/>
           <p:cNvSpPr/>
           <p:nvPr/>
         </p:nvSpPr>
         <p:spPr>
           <a:xfrm>
-            <a:off x="9418320" y="4352544"/>
-            <a:ext cx="2148840" cy="585216"/>
+            <a:off x="5120640" y="4352544"/>
+            <a:ext cx="2103120" cy="585216"/>
           </a:xfrm>
           <a:prstGeom prst="roundRect">
             <a:avLst>
@@ -8632,14 +8693,14 @@
       </p:sp>
       <p:sp>
         <p:nvSpPr>
-          <p:cNvPr id="41" name="Shape 38"/>
+          <p:cNvPr id="43" name="Shape 40"/>
           <p:cNvSpPr/>
           <p:nvPr/>
         </p:nvSpPr>
         <p:spPr>
           <a:xfrm>
-            <a:off x="548640" y="5010912"/>
-            <a:ext cx="2011680" cy="585216"/>
+            <a:off x="7315200" y="4352544"/>
+            <a:ext cx="2103120" cy="585216"/>
           </a:xfrm>
           <a:prstGeom prst="roundRect">
             <a:avLst>
@@ -8647,60 +8708,21 @@
             </a:avLst>
           </a:prstGeom>
           <a:solidFill>
-            <a:srgbClr val="EAF0FA"/>
-          </a:solidFill>
-          <a:ln/>
-        </p:spPr>
-      </p:sp>
-      <p:sp>
-        <p:nvSpPr>
-          <p:cNvPr id="42" name="Text 39"/>
-          <p:cNvSpPr txBox="1"/>
-          <p:nvPr/>
-        </p:nvSpPr>
-        <p:spPr>
-          <a:xfrm>
-            <a:off x="548640" y="5010912"/>
-            <a:ext cx="2011680" cy="585216"/>
-          </a:xfrm>
-          <a:prstGeom prst="rect">
-            <a:avLst/>
-          </a:prstGeom>
-          <a:noFill/>
-          <a:ln/>
-        </p:spPr>
-        <p:txBody>
-          <a:bodyPr wrap="square" lIns="0" tIns="0" rIns="0" bIns="0" rtlCol="0" anchor="ctr"/>
-          <a:lstStyle/>
-          <a:p>
-            <a:pPr algn="ctr" indent="0" marL="0">
-              <a:buNone/>
-            </a:pPr>
-            <a:r>
-              <a:rPr lang="en-US" sz="1900" b="1" dirty="0">
-                <a:solidFill>
-                  <a:srgbClr val="1E2761"/>
-                </a:solidFill>
-                <a:latin typeface="Cambria" pitchFamily="34" charset="0"/>
-                <a:ea typeface="Cambria" pitchFamily="34" charset="-122"/>
-                <a:cs typeface="Cambria" pitchFamily="34" charset="-120"/>
-              </a:rPr>
-              <a:t>3. Stand</a:t>
-            </a:r>
-            <a:endParaRPr lang="en-US" sz="1900" dirty="0"/>
-          </a:p>
-        </p:txBody>
-      </p:sp>
-      <p:sp>
-        <p:nvSpPr>
-          <p:cNvPr id="43" name="Shape 40"/>
+            <a:srgbClr val="F4F7FD"/>
+          </a:solidFill>
+          <a:ln/>
+        </p:spPr>
+      </p:sp>
+      <p:sp>
+        <p:nvSpPr>
+          <p:cNvPr id="44" name="Shape 41"/>
           <p:cNvSpPr/>
           <p:nvPr/>
         </p:nvSpPr>
         <p:spPr>
           <a:xfrm>
-            <a:off x="2651760" y="5010912"/>
-            <a:ext cx="1371600" cy="585216"/>
+            <a:off x="9509760" y="4352544"/>
+            <a:ext cx="2057400" cy="585216"/>
           </a:xfrm>
           <a:prstGeom prst="roundRect">
             <a:avLst>
@@ -8715,14 +8737,14 @@
       </p:sp>
       <p:sp>
         <p:nvSpPr>
-          <p:cNvPr id="44" name="Shape 41"/>
+          <p:cNvPr id="45" name="Shape 42"/>
           <p:cNvSpPr/>
           <p:nvPr/>
         </p:nvSpPr>
         <p:spPr>
           <a:xfrm>
-            <a:off x="4114800" y="5010912"/>
-            <a:ext cx="2560320" cy="585216"/>
+            <a:off x="548640" y="5010912"/>
+            <a:ext cx="1554480" cy="585216"/>
           </a:xfrm>
           <a:prstGeom prst="roundRect">
             <a:avLst>
@@ -8730,21 +8752,60 @@
             </a:avLst>
           </a:prstGeom>
           <a:solidFill>
-            <a:srgbClr val="F4F7FD"/>
-          </a:solidFill>
-          <a:ln/>
-        </p:spPr>
-      </p:sp>
-      <p:sp>
-        <p:nvSpPr>
-          <p:cNvPr id="45" name="Shape 42"/>
+            <a:srgbClr val="EAF0FA"/>
+          </a:solidFill>
+          <a:ln/>
+        </p:spPr>
+      </p:sp>
+      <p:sp>
+        <p:nvSpPr>
+          <p:cNvPr id="46" name="Text 43"/>
+          <p:cNvSpPr txBox="1"/>
+          <p:nvPr/>
+        </p:nvSpPr>
+        <p:spPr>
+          <a:xfrm>
+            <a:off x="548640" y="5010912"/>
+            <a:ext cx="1554480" cy="585216"/>
+          </a:xfrm>
+          <a:prstGeom prst="rect">
+            <a:avLst/>
+          </a:prstGeom>
+          <a:noFill/>
+          <a:ln/>
+        </p:spPr>
+        <p:txBody>
+          <a:bodyPr wrap="square" lIns="0" tIns="0" rIns="0" bIns="0" rtlCol="0" anchor="ctr"/>
+          <a:lstStyle/>
+          <a:p>
+            <a:pPr algn="ctr" indent="0" marL="0">
+              <a:buNone/>
+            </a:pPr>
+            <a:r>
+              <a:rPr lang="en-US" sz="1900" b="1" dirty="0">
+                <a:solidFill>
+                  <a:srgbClr val="1E2761"/>
+                </a:solidFill>
+                <a:latin typeface="Cambria" pitchFamily="34" charset="0"/>
+                <a:ea typeface="Cambria" pitchFamily="34" charset="-122"/>
+                <a:cs typeface="Cambria" pitchFamily="34" charset="-120"/>
+              </a:rPr>
+              <a:t>3. Stand</a:t>
+            </a:r>
+            <a:endParaRPr lang="en-US" sz="1900" dirty="0"/>
+          </a:p>
+        </p:txBody>
+      </p:sp>
+      <p:sp>
+        <p:nvSpPr>
+          <p:cNvPr id="47" name="Shape 44"/>
           <p:cNvSpPr/>
           <p:nvPr/>
         </p:nvSpPr>
         <p:spPr>
           <a:xfrm>
-            <a:off x="6766560" y="5010912"/>
-            <a:ext cx="2560320" cy="585216"/>
+            <a:off x="2194560" y="5010912"/>
+            <a:ext cx="1097280" cy="585216"/>
           </a:xfrm>
           <a:prstGeom prst="roundRect">
             <a:avLst>
@@ -8759,14 +8820,80 @@
       </p:sp>
       <p:sp>
         <p:nvSpPr>
-          <p:cNvPr id="46" name="Shape 43"/>
+          <p:cNvPr id="48" name="Shape 45"/>
           <p:cNvSpPr/>
           <p:nvPr/>
         </p:nvSpPr>
         <p:spPr>
           <a:xfrm>
-            <a:off x="9418320" y="5010912"/>
-            <a:ext cx="2148840" cy="585216"/>
+            <a:off x="3383280" y="5010912"/>
+            <a:ext cx="1645920" cy="585216"/>
+          </a:xfrm>
+          <a:prstGeom prst="roundRect">
+            <a:avLst>
+              <a:gd name="adj" fmla="val 12500"/>
+            </a:avLst>
+          </a:prstGeom>
+          <a:solidFill>
+            <a:srgbClr val="F4F7FD"/>
+          </a:solidFill>
+          <a:ln/>
+        </p:spPr>
+      </p:sp>
+      <p:sp>
+        <p:nvSpPr>
+          <p:cNvPr id="49" name="Shape 46"/>
+          <p:cNvSpPr/>
+          <p:nvPr/>
+        </p:nvSpPr>
+        <p:spPr>
+          <a:xfrm>
+            <a:off x="5120640" y="5010912"/>
+            <a:ext cx="2103120" cy="585216"/>
+          </a:xfrm>
+          <a:prstGeom prst="roundRect">
+            <a:avLst>
+              <a:gd name="adj" fmla="val 12500"/>
+            </a:avLst>
+          </a:prstGeom>
+          <a:solidFill>
+            <a:srgbClr val="F4F7FD"/>
+          </a:solidFill>
+          <a:ln/>
+        </p:spPr>
+      </p:sp>
+      <p:sp>
+        <p:nvSpPr>
+          <p:cNvPr id="50" name="Shape 47"/>
+          <p:cNvSpPr/>
+          <p:nvPr/>
+        </p:nvSpPr>
+        <p:spPr>
+          <a:xfrm>
+            <a:off x="7315200" y="5010912"/>
+            <a:ext cx="2103120" cy="585216"/>
+          </a:xfrm>
+          <a:prstGeom prst="roundRect">
+            <a:avLst>
+              <a:gd name="adj" fmla="val 12500"/>
+            </a:avLst>
+          </a:prstGeom>
+          <a:solidFill>
+            <a:srgbClr val="F4F7FD"/>
+          </a:solidFill>
+          <a:ln/>
+        </p:spPr>
+      </p:sp>
+      <p:sp>
+        <p:nvSpPr>
+          <p:cNvPr id="51" name="Shape 48"/>
+          <p:cNvSpPr/>
+          <p:nvPr/>
+        </p:nvSpPr>
+        <p:spPr>
+          <a:xfrm>
+            <a:off x="9509760" y="5010912"/>
+            <a:ext cx="2057400" cy="585216"/>
           </a:xfrm>
           <a:prstGeom prst="roundRect">
             <a:avLst>

</xml_diff>

<commit_message>
Geschichte 8: Stände-Inhalte aus den Gruppenpuzzle-Texten übernommen
Co-Authored-By: Claude Sonnet 5.5 <noreply@anthropic.com>
Claude-Session: https://claude.ai/code/session_01CtRuNVyt8v9M882BKEmgNb
</commit_message>
<xml_diff>
--- a/Geschichte_8/Absolutismus_Wiederholung/Praesentation_Absolutismus_Wiederholung.pptx
+++ b/Geschichte_8/Absolutismus_Wiederholung/Praesentation_Absolutismus_Wiederholung.pptx
@@ -600,7 +600,7 @@
           <a:p>
             <a:r>
               <a:rPr lang="en-US" dirty="0"/>
-              <a:t>Ansage: „Wer drankommt, liest vor. Alle prüfen mit.“ Typische Fehler: Adel als Steuerzahler, Klerus mit Kriegsdienst, Dritter Stand mit Privilegien. Dann: „Verbessert mit Grün.“</a:t>
+              <a:t>Ansage: „Wer drankommt, liest vor. Alle prüfen mit.“ Typische Fehler: Adel als Steuerzahler, Klerus mit Wehrdienst (befreit), Dritter Stand mit Vorrechten. Dann: „Verbessert mit Grün.“</a:t>
             </a:r>
             <a:endParaRPr lang="en-US" dirty="0"/>
           </a:p>
@@ -1128,7 +1128,7 @@
           <a:p>
             <a:r>
               <a:rPr lang="en-US" dirty="0"/>
-              <a:t>Lösung: 1 absoluter · 2 Beamte · 3 Intendanten · 4 Steuerfreiheit · 5 Versailles · 6 Merkantilismus · 7 Zölle · 8 Gottesgnadentum · 9 Glaube · 10 stehendes · 11 400.000 · 12 Drittel. Nicht passend: Söldner, Generalstände. Kontrolle: „Wer drankommt, liest einen Absatz vor. Alle prüfen mit.“ Dann „Vergleicht und verbessert mit Grün.“ Schnelle machen die ★-Aufgabe (wichtigste Säule begründen).</a:t>
+              <a:t>Lösung: 1 absoluter · 2 Beamte · 3 Intendanten · 4 Steuerfreiheit · 5 Versailles · 6 Merkantilismus · 7 Zölle · 8 Gottesgnadentum · 9 Glaube · 10 stehendes · 11 400.000 · 12 Drittel. Nicht passend: Söldner, Parlament. Kontrolle: „Wer drankommt, liest einen Absatz vor. Alle prüfen mit.“ Dann „Vergleicht und verbessert mit Grün.“ Schnelle machen die ★-Aufgabe (wichtigste Säule begründen).</a:t>
             </a:r>
             <a:endParaRPr lang="en-US" dirty="0"/>
           </a:p>
@@ -1216,7 +1216,7 @@
           <a:p>
             <a:r>
               <a:rPr lang="en-US" dirty="0"/>
-              <a:t>Ansage: „Hefte zu. Ihr schreibt noch nichts auf. Meldet euch.“ Raster aus dem Gruppenpuzzle (Stand | Anzahl | Bildung | Vorrechte | Pflichten) plus Spalte Mitbestimmung bereits leer an der Tafel. Nach dem gemeinsamen Ausfüllen: „Jetzt schreibt ihr ab: die Tabelle. Mit Lineal.“ Lösungen siehe Tafelskript. Hinweis zur Mitbestimmung: Die Generalstände (je 1 Stimme pro Stand) wurden von 1614 bis 1789 nicht einberufen – unter Ludwig XIV. gab es praktisch keine Mitbestimmung.</a:t>
+              <a:t>Ansage: „Hefte zu. Ihr schreibt noch nichts auf. Meldet euch.“ Raster aus dem Gruppenpuzzle (Stand | Anzahl | Bildung | Vorrechte | Pflichten) plus Spalte Mitbestimmung bereits leer an der Tafel. Inhalte siehe Tafelskript (aus den Gruppenpuzzle-Texten). Nach dem gemeinsamen Ausfüllen: „Jetzt schreibt ihr ab: die Tabelle. Mit Lineal.“ Lösungen siehe Tafelskript. Hinweis: Der Text nennt zur Mitbestimmung des Klerus nichts.  Der Dritte Stand ist ausgeschlossen, der Adel bestimmt das politische Geschehen.</a:t>
             </a:r>
             <a:endParaRPr lang="en-US" dirty="0"/>
           </a:p>
@@ -1304,7 +1304,7 @@
           <a:p>
             <a:r>
               <a:rPr lang="en-US" dirty="0"/>
-              <a:t>Ansage: „Jetzt schreibt ihr von der Folie ab: Merksatz 3. Rahmt ihn rot ein.“ Zahlen beziehen sich auf Frankreich vor 1789. Falls im Unterricht andere Werte genannt wurden, Folie anpassen.</a:t>
+              <a:t>Ansage: „Jetzt schreibt ihr von der Folie ab: Merksatz 3. Rahmt ihn rot ein.“ Alle Zahlen stammen aus den Gruppenpuzzle-Texten. Der Text nennt zur Mitbestimmung des Klerus nichts.</a:t>
             </a:r>
             <a:endParaRPr lang="en-US" dirty="0"/>
           </a:p>
@@ -1392,7 +1392,7 @@
           <a:p>
             <a:r>
               <a:rPr lang="en-US" dirty="0"/>
-              <a:t>Ansage: „Jetzt arbeitet ihr allein. Die Aufgabe steht rechts.“ Danach 3 Schüler vorlesen lassen (verschiedene Stände): „Wer drankommt, liest vor. Alle prüfen mit.“ Kriterien stehen auf der nächsten Folie. Mögliche Antwort: „Im Absolutismus fühle ich mich als Adeliger privilegiert, weil ich keine Steuern zahlen muss und jagen darf. Dafür muss ich dem König im Krieg dienen und am Hof erscheinen.“ / „… als Bauer ausgenutzt, weil ich Steuern und Abgaben zahlen muss, aber keine Privilegien und keine Mitbestimmung habe.“</a:t>
+              <a:t>Ansage: „Jetzt arbeitet ihr allein. Die Aufgabe steht rechts.“ Danach 3 Schüler vorlesen lassen (verschiedene Stände): „Wer drankommt, liest vor. Alle prüfen mit.“ Kriterien stehen auf der nächsten Folie. Mögliche Antwort: „Im Absolutismus fühle ich mich als Adeliger privilegiert, weil ich keine Steuern zahlen muss und allein jagen darf. Dafür muss ich mich ehrenhaft verhalten und Verwaltungsaufgaben übernehmen.“ / „… als Bauer ausgenutzt, weil ich Steuern, hohe Abgaben und Pachtgebühren zahlen muss und von der Mitbestimmung ausgeschlossen bin.“</a:t>
             </a:r>
             <a:endParaRPr lang="en-US" dirty="0"/>
           </a:p>
@@ -7428,7 +7428,7 @@
                 <a:ea typeface="Cambria" pitchFamily="34" charset="-122"/>
                 <a:cs typeface="Cambria" pitchFamily="34" charset="-120"/>
               </a:rPr>
-              <a:t>Beamte · Glaube · Söldner · Merkantilismus · Gottesgnadentum · Versailles · Steuerfreiheit · Zölle · stehendes · 400.000 · Drittel · absoluter · Intendanten · Generalstände</a:t>
+              <a:t>Beamte · Glaube · Söldner · Merkantilismus · Gottesgnadentum · Versailles · Steuerfreiheit · Zölle · stehendes · 400.000 · Drittel · absoluter · Intendanten · Parlament</a:t>
             </a:r>
             <a:endParaRPr lang="en-US" sz="2000" dirty="0"/>
           </a:p>
@@ -9146,7 +9146,7 @@
                 <a:ea typeface="Cambria" pitchFamily="34" charset="-122"/>
                 <a:cs typeface="Cambria" pitchFamily="34" charset="-120"/>
               </a:rPr>
-              <a:t>Klerus (ca. 1 %)</a:t>
+              <a:t>Klerus (ca. 150 000)</a:t>
             </a:r>
             <a:pPr indent="0" marL="0">
               <a:buNone/>
@@ -9174,7 +9174,7 @@
                 <a:ea typeface="Cambria" pitchFamily="34" charset="-122"/>
                 <a:cs typeface="Cambria" pitchFamily="34" charset="-120"/>
               </a:rPr>
-              <a:t>Adel (ca. 2 %)</a:t>
+              <a:t>Adel (ca. 500 000)</a:t>
             </a:r>
             <a:pPr indent="0" marL="0">
               <a:buNone/>
@@ -9202,7 +9202,7 @@
                 <a:ea typeface="Cambria" pitchFamily="34" charset="-122"/>
                 <a:cs typeface="Cambria" pitchFamily="34" charset="-120"/>
               </a:rPr>
-              <a:t>Dritter Stand (ca. 97 %)</a:t>
+              <a:t>Dritter Stand (ca. 20 000 000)</a:t>
             </a:r>
             <a:pPr indent="0" marL="0">
               <a:buNone/>
@@ -9216,7 +9216,7 @@
                 <a:ea typeface="Cambria" pitchFamily="34" charset="-122"/>
                 <a:cs typeface="Cambria" pitchFamily="34" charset="-120"/>
               </a:rPr>
-              <a:t>. Rechte und Pflichten sind </a:t>
+              <a:t>. Klerus und Adel haben </a:t>
             </a:r>
             <a:pPr indent="0" marL="0">
               <a:buNone/>
@@ -9230,7 +9230,7 @@
                 <a:ea typeface="Cambria" pitchFamily="34" charset="-122"/>
                 <a:cs typeface="Cambria" pitchFamily="34" charset="-120"/>
               </a:rPr>
-              <a:t>ungleich</a:t>
+              <a:t>Vorrechte</a:t>
             </a:r>
             <a:pPr indent="0" marL="0">
               <a:buNone/>
@@ -9244,7 +9244,7 @@
                 <a:ea typeface="Cambria" pitchFamily="34" charset="-122"/>
                 <a:cs typeface="Cambria" pitchFamily="34" charset="-120"/>
               </a:rPr>
-              <a:t> verteilt. Im Absolutismus hatten die Stände </a:t>
+              <a:t>. Der Dritte Stand zahlt </a:t>
             </a:r>
             <a:pPr indent="0" marL="0">
               <a:buNone/>
@@ -9258,7 +9258,35 @@
                 <a:ea typeface="Cambria" pitchFamily="34" charset="-122"/>
                 <a:cs typeface="Cambria" pitchFamily="34" charset="-120"/>
               </a:rPr>
-              <a:t>keine Mitbestimmung</a:t>
+              <a:t>Steuern und Abgaben</a:t>
+            </a:r>
+            <a:pPr indent="0" marL="0">
+              <a:buNone/>
+            </a:pPr>
+            <a:r>
+              <a:rPr lang="en-US" sz="2000" dirty="0">
+                <a:solidFill>
+                  <a:srgbClr val="1E2761"/>
+                </a:solidFill>
+                <a:latin typeface="Cambria" pitchFamily="34" charset="0"/>
+                <a:ea typeface="Cambria" pitchFamily="34" charset="-122"/>
+                <a:cs typeface="Cambria" pitchFamily="34" charset="-120"/>
+              </a:rPr>
+              <a:t> und ist von der </a:t>
+            </a:r>
+            <a:pPr indent="0" marL="0">
+              <a:buNone/>
+            </a:pPr>
+            <a:r>
+              <a:rPr lang="en-US" sz="2000" b="1" dirty="0">
+                <a:solidFill>
+                  <a:srgbClr val="1E2761"/>
+                </a:solidFill>
+                <a:latin typeface="Cambria" pitchFamily="34" charset="0"/>
+                <a:ea typeface="Cambria" pitchFamily="34" charset="-122"/>
+                <a:cs typeface="Cambria" pitchFamily="34" charset="-120"/>
+              </a:rPr>
+              <a:t>politischen Mitbestimmung ausgeschlossen</a:t>
             </a:r>
             <a:pPr indent="0" marL="0">
               <a:buNone/>
@@ -9347,7 +9375,7 @@
                 <a:ea typeface="Cambria" pitchFamily="34" charset="-122"/>
                 <a:cs typeface="Cambria" pitchFamily="34" charset="-120"/>
               </a:rPr>
-              <a:t>Klerus, Adel: </a:t>
+              <a:t>Adel: </a:t>
             </a:r>
             <a:pPr indent="0" marL="0">
               <a:buNone/>
@@ -9361,7 +9389,7 @@
                 <a:ea typeface="Cambria" pitchFamily="34" charset="-122"/>
                 <a:cs typeface="Cambria" pitchFamily="34" charset="-120"/>
               </a:rPr>
-              <a:t>Privilegien</a:t>
+              <a:t>Jagdrecht</a:t>
             </a:r>
             <a:pPr indent="0" marL="0">
               <a:buNone/>
@@ -9375,7 +9403,7 @@
                 <a:ea typeface="Cambria" pitchFamily="34" charset="-122"/>
                 <a:cs typeface="Cambria" pitchFamily="34" charset="-120"/>
               </a:rPr>
-              <a:t> · Dritter Stand: </a:t>
+              <a:t> · Klerus: </a:t>
             </a:r>
             <a:pPr indent="0" marL="0">
               <a:buNone/>
@@ -9389,7 +9417,35 @@
                 <a:ea typeface="Cambria" pitchFamily="34" charset="-122"/>
                 <a:cs typeface="Cambria" pitchFamily="34" charset="-120"/>
               </a:rPr>
-              <a:t>Steuern, Abgaben</a:t>
+              <a:t>Kirchenzehnt</a:t>
+            </a:r>
+            <a:pPr indent="0" marL="0">
+              <a:buNone/>
+            </a:pPr>
+            <a:r>
+              <a:rPr lang="en-US" sz="1900" dirty="0">
+                <a:solidFill>
+                  <a:srgbClr val="1E2761"/>
+                </a:solidFill>
+                <a:latin typeface="Cambria" pitchFamily="34" charset="0"/>
+                <a:ea typeface="Cambria" pitchFamily="34" charset="-122"/>
+                <a:cs typeface="Cambria" pitchFamily="34" charset="-120"/>
+              </a:rPr>
+              <a:t> · 3. Stand: </a:t>
+            </a:r>
+            <a:pPr indent="0" marL="0">
+              <a:buNone/>
+            </a:pPr>
+            <a:r>
+              <a:rPr lang="en-US" sz="1900" b="1" dirty="0">
+                <a:solidFill>
+                  <a:srgbClr val="1E2761"/>
+                </a:solidFill>
+                <a:latin typeface="Cambria" pitchFamily="34" charset="0"/>
+                <a:ea typeface="Cambria" pitchFamily="34" charset="-122"/>
+                <a:cs typeface="Cambria" pitchFamily="34" charset="-120"/>
+              </a:rPr>
+              <a:t>Abgaben</a:t>
             </a:r>
             <a:endParaRPr lang="en-US" sz="1900" dirty="0"/>
           </a:p>
@@ -9589,7 +9645,7 @@
                 <a:ea typeface="Calibri" pitchFamily="34" charset="-122"/>
                 <a:cs typeface="Calibri" pitchFamily="34" charset="-120"/>
               </a:rPr>
-              <a:t>Wer zahlt Steuern, wer hat Privilegien? </a:t>
+              <a:t>Wer zahlt, wer ist ausgeschlossen? </a:t>
             </a:r>
             <a:pPr indent="0" marL="0">
               <a:buNone/>
@@ -9603,7 +9659,7 @@
                 <a:ea typeface="Calibri" pitchFamily="34" charset="-122"/>
                 <a:cs typeface="Calibri" pitchFamily="34" charset="-120"/>
               </a:rPr>
-              <a:t>Anzahl und Lasten passen nicht zusammen.</a:t>
+              <a:t>Wenige Menschen haben die Vorrechte, viele tragen die Last.</a:t>
             </a:r>
             <a:endParaRPr lang="en-US" sz="1900" dirty="0"/>
           </a:p>
@@ -10563,7 +10619,7 @@
                 <a:ea typeface="Cambria" pitchFamily="34" charset="-122"/>
                 <a:cs typeface="Cambria" pitchFamily="34" charset="-120"/>
               </a:rPr>
-              <a:t>Privilegien · Steuerfreiheit · Jagdrecht · Abgaben · Frondienst · Kriegsdienst · Mitbestimmung</a:t>
+              <a:t>Vorrechte · Steuerfreiheit · Jagdrecht · Kirchenzehnt · Pachtgebühren · Mitbestimmung</a:t>
             </a:r>
             <a:endParaRPr lang="en-US" sz="1800" dirty="0"/>
           </a:p>

</xml_diff>

<commit_message>
Geschichte 8: Säulen zuerst, dann Wahr oder falsch und Rest
Co-Authored-By: Claude Sonnet 5.5 <noreply@anthropic.com>
Claude-Session: https://claude.ai/code/session_01CtRuNVyt8v9M882BKEmgNb
</commit_message>
<xml_diff>
--- a/Geschichte_8/Absolutismus_Wiederholung/Praesentation_Absolutismus_Wiederholung.pptx
+++ b/Geschichte_8/Absolutismus_Wiederholung/Praesentation_Absolutismus_Wiederholung.pptx
@@ -953,7 +953,7 @@
           <a:p>
             <a:r>
               <a:rPr lang="en-US" dirty="0"/>
-              <a:t>Ansage: „Stifte liegen. Ihr schreibt noch nichts auf. Entscheidet still und meldet euch.“ Lösung: 1 wahr (ca. 20 Mio. von gut 20,6 Mio.) · 2 falsch: Der Adel zahlte keine Steuern · 3 wahr (Säule Heer) · 4 falsch: 1685 beendete Ludwig die religiöse Toleranz (Säule Religion). Nicht lange erklären, sondern notieren, was unsicher ist. Es kommt in den folgenden Phasen.</a:t>
+              <a:t>Ansage: „Jetzt schreibt ihr von der Folie ab: Merksatz 1. Rahmt ihn rot ein.“ Danach Arbeitsblatt Lückentext verteilen. Tipp: Die Säulen sind aus dem Gruppenpuzzle bekannt – kurz fragen, wer welche Säule bearbeitet hat.</a:t>
             </a:r>
             <a:endParaRPr lang="en-US" dirty="0"/>
           </a:p>
@@ -1041,7 +1041,7 @@
           <a:p>
             <a:r>
               <a:rPr lang="en-US" dirty="0"/>
-              <a:t>Vorher: Wort „Absolutismus“ an die Tafel, gemeinsam klären: absolut = uneingeschränkt. Dann Ansage: „Jetzt schreibt ihr von der Folie ab: Merksatz 1. Rahmt ihn rot ein.“</a:t>
+              <a:t>Lösung: 1 absoluter · 2 Beamte · 3 Intendanten · 4 Steuerfreiheit · 5 Versailles · 6 Merkantilismus · 7 Zölle · 8 Gottesgnadentum · 9 Glaube · 10 stehendes · 11 400.000 · 12 Drittel. Nicht passend: Söldner, Parlament. Kontrolle: „Wer drankommt, liest einen Absatz vor. Alle prüfen mit.“ Dann „Vergleicht und verbessert mit Grün.“ Schnelle machen die ★-Aufgabe (wichtigste Säule begründen).</a:t>
             </a:r>
             <a:endParaRPr lang="en-US" dirty="0"/>
           </a:p>
@@ -1129,7 +1129,7 @@
           <a:p>
             <a:r>
               <a:rPr lang="en-US" dirty="0"/>
-              <a:t>Lösung: 1 Absolutismus (keine Kontrolle) · 2 kein Absolutismus (Parlament kann den König stoppen) · 3 Absolutismus (Beamte sind dem König zum Gehorsam verpflichtet, er kontrolliert sie) · 4 kein Absolutismus (Wahl = Demokratie, Macht ist begrenzt). Nach der Einzelarbeit: „Wer drankommt, schreibt an die Tafel. Alle prüfen mit.“ Dann: „Vergleicht und verbessert mit Grün.“</a:t>
+              <a:t>Ansage: „Stifte liegen. Ihr schreibt noch nichts auf. Entscheidet still und meldet euch.“ Lösung: 1 wahr (ca. 20 Mio. von gut 20,6 Mio.) · 2 falsch: Der Adel zahlte keine Steuern · 3 wahr (Säule Heer) · 4 falsch: 1685 beendete Ludwig die religiöse Toleranz (Säule Religion). Nicht lange erklären, sondern notieren, was unsicher ist. Es kommt in den folgenden Phasen.</a:t>
             </a:r>
             <a:endParaRPr lang="en-US" dirty="0"/>
           </a:p>
@@ -1217,7 +1217,7 @@
           <a:p>
             <a:r>
               <a:rPr lang="en-US" dirty="0"/>
-              <a:t>Ansage: „Jetzt schreibt ihr von der Folie ab: Merksatz 2. Rahmt ihn rot ein.“ Danach Arbeitsblatt Lückentext verteilen. Tipp: Die Säulen sind aus dem Gruppenpuzzle bekannt – kurz fragen, wer welche Säule bearbeitet hat.</a:t>
+              <a:t>Vorher: Wort „Absolutismus“ an die Tafel, gemeinsam klären: absolut = uneingeschränkt. Dann Ansage: „Jetzt schreibt ihr von der Folie ab: Merksatz 2. Rahmt ihn rot ein.“</a:t>
             </a:r>
             <a:endParaRPr lang="en-US" dirty="0"/>
           </a:p>
@@ -1305,7 +1305,7 @@
           <a:p>
             <a:r>
               <a:rPr lang="en-US" dirty="0"/>
-              <a:t>Lösung: 1 absoluter · 2 Beamte · 3 Intendanten · 4 Steuerfreiheit · 5 Versailles · 6 Merkantilismus · 7 Zölle · 8 Gottesgnadentum · 9 Glaube · 10 stehendes · 11 400.000 · 12 Drittel. Nicht passend: Söldner, Parlament. Kontrolle: „Wer drankommt, liest einen Absatz vor. Alle prüfen mit.“ Dann „Vergleicht und verbessert mit Grün.“ Schnelle machen die ★-Aufgabe (wichtigste Säule begründen).</a:t>
+              <a:t>Lösung: 1 Absolutismus (keine Kontrolle) · 2 kein Absolutismus (Parlament kann den König stoppen) · 3 Absolutismus (Beamte sind dem König zum Gehorsam verpflichtet, er kontrolliert sie) · 4 kein Absolutismus (Wahl = Demokratie, Macht ist begrenzt). Nach der Einzelarbeit: „Wer drankommt, schreibt an die Tafel. Alle prüfen mit.“ Dann: „Vergleicht und verbessert mit Grün.“</a:t>
             </a:r>
             <a:endParaRPr lang="en-US" dirty="0"/>
           </a:p>
@@ -3621,7 +3621,7 @@
                 <a:ea typeface="Cambria" pitchFamily="34" charset="-122"/>
                 <a:cs typeface="Cambria" pitchFamily="34" charset="-120"/>
               </a:rPr>
-              <a:t>Merksatz 1 auswendig: Was bedeutet Absolutismus?</a:t>
+              <a:t>Merksatz 2 auswendig: Was bedeutet Absolutismus?</a:t>
             </a:r>
             <a:endParaRPr lang="en-US" sz="2200" dirty="0"/>
           </a:p>
@@ -4921,7 +4921,7 @@
         <p:spPr>
           <a:xfrm>
             <a:off x="548640" y="320040"/>
-            <a:ext cx="7315200" cy="274320"/>
+            <a:ext cx="9144000" cy="274320"/>
           </a:xfrm>
           <a:prstGeom prst="rect">
             <a:avLst/>
@@ -4939,13 +4939,13 @@
             <a:r>
               <a:rPr lang="en-US" sz="1300" b="1" spc="200" kern="0" dirty="0">
                 <a:solidFill>
-                  <a:srgbClr val="5B6B8C"/>
-                </a:solidFill>
-                <a:latin typeface="Calibri" pitchFamily="34" charset="0"/>
-                <a:ea typeface="Calibri" pitchFamily="34" charset="-122"/>
-                <a:cs typeface="Calibri" pitchFamily="34" charset="-120"/>
-              </a:rPr>
-              <a:t>EINSTIEG · OHNE HEFT</a:t>
+                  <a:srgbClr val="D9534F"/>
+                </a:solidFill>
+                <a:latin typeface="Calibri" pitchFamily="34" charset="0"/>
+                <a:ea typeface="Calibri" pitchFamily="34" charset="-122"/>
+                <a:cs typeface="Calibri" pitchFamily="34" charset="-120"/>
+              </a:rPr>
+              <a:t>MERKSATZ 1 · ABSCHREIBEN UND ROT UMRAHMEN</a:t>
             </a:r>
             <a:endParaRPr lang="en-US" sz="1300" dirty="0"/>
           </a:p>
@@ -4984,7 +4984,7 @@
                 <a:ea typeface="Cambria" pitchFamily="34" charset="-122"/>
                 <a:cs typeface="Cambria" pitchFamily="34" charset="-120"/>
               </a:rPr>
-              <a:t>Wahr oder falsch?</a:t>
+              <a:t>Die fünf Säulen des Absolutismus</a:t>
             </a:r>
             <a:endParaRPr lang="en-US" sz="3400" dirty="0"/>
           </a:p>
@@ -4999,322 +4999,240 @@
         <p:spPr>
           <a:xfrm>
             <a:off x="548640" y="1417320"/>
-            <a:ext cx="11109960" cy="1655064"/>
+            <a:ext cx="11109960" cy="1828800"/>
           </a:xfrm>
           <a:prstGeom prst="roundRect">
             <a:avLst>
-              <a:gd name="adj" fmla="val 4420"/>
+              <a:gd name="adj" fmla="val 4000"/>
             </a:avLst>
           </a:prstGeom>
           <a:solidFill>
-            <a:srgbClr val="EAF0FA"/>
-          </a:solidFill>
-          <a:ln/>
-        </p:spPr>
-      </p:sp>
-      <p:sp>
-        <p:nvSpPr>
-          <p:cNvPr id="5" name="Shape 3"/>
+            <a:srgbClr val="FFFFFF"/>
+          </a:solidFill>
+          <a:ln w="38100">
+            <a:solidFill>
+              <a:srgbClr val="D9534F"/>
+            </a:solidFill>
+            <a:prstDash val="solid"/>
+          </a:ln>
+        </p:spPr>
+      </p:sp>
+      <p:sp>
+        <p:nvSpPr>
+          <p:cNvPr id="5" name="Text 3"/>
+          <p:cNvSpPr txBox="1"/>
+          <p:nvPr/>
+        </p:nvSpPr>
+        <p:spPr>
+          <a:xfrm>
+            <a:off x="868680" y="1508760"/>
+            <a:ext cx="10469880" cy="1645920"/>
+          </a:xfrm>
+          <a:prstGeom prst="rect">
+            <a:avLst/>
+          </a:prstGeom>
+          <a:noFill/>
+          <a:ln/>
+        </p:spPr>
+        <p:txBody>
+          <a:bodyPr wrap="square" lIns="0" tIns="0" rIns="0" bIns="0" rtlCol="0" anchor="ctr"/>
+          <a:lstStyle/>
+          <a:p>
+            <a:pPr indent="0" marL="0">
+              <a:buNone/>
+            </a:pPr>
+            <a:r>
+              <a:rPr lang="en-US" sz="2000" dirty="0">
+                <a:solidFill>
+                  <a:srgbClr val="1E2761"/>
+                </a:solidFill>
+                <a:latin typeface="Cambria" pitchFamily="34" charset="0"/>
+                <a:ea typeface="Cambria" pitchFamily="34" charset="-122"/>
+                <a:cs typeface="Cambria" pitchFamily="34" charset="-120"/>
+              </a:rPr>
+              <a:t>Ludwig XIV. sicherte seine Macht auf </a:t>
+            </a:r>
+            <a:pPr indent="0" marL="0">
+              <a:buNone/>
+            </a:pPr>
+            <a:r>
+              <a:rPr lang="en-US" sz="2000" b="1" dirty="0">
+                <a:solidFill>
+                  <a:srgbClr val="1E2761"/>
+                </a:solidFill>
+                <a:latin typeface="Cambria" pitchFamily="34" charset="0"/>
+                <a:ea typeface="Cambria" pitchFamily="34" charset="-122"/>
+                <a:cs typeface="Cambria" pitchFamily="34" charset="-120"/>
+              </a:rPr>
+              <a:t>fünf Säulen</a:t>
+            </a:r>
+            <a:pPr indent="0" marL="0">
+              <a:buNone/>
+            </a:pPr>
+            <a:r>
+              <a:rPr lang="en-US" sz="2000" dirty="0">
+                <a:solidFill>
+                  <a:srgbClr val="1E2761"/>
+                </a:solidFill>
+                <a:latin typeface="Cambria" pitchFamily="34" charset="0"/>
+                <a:ea typeface="Cambria" pitchFamily="34" charset="-122"/>
+                <a:cs typeface="Cambria" pitchFamily="34" charset="-120"/>
+              </a:rPr>
+              <a:t>: </a:t>
+            </a:r>
+            <a:pPr indent="0" marL="0">
+              <a:buNone/>
+            </a:pPr>
+            <a:r>
+              <a:rPr lang="en-US" sz="2000" b="1" dirty="0">
+                <a:solidFill>
+                  <a:srgbClr val="1E2761"/>
+                </a:solidFill>
+                <a:latin typeface="Cambria" pitchFamily="34" charset="0"/>
+                <a:ea typeface="Cambria" pitchFamily="34" charset="-122"/>
+                <a:cs typeface="Cambria" pitchFamily="34" charset="-120"/>
+              </a:rPr>
+              <a:t>1</a:t>
+            </a:r>
+            <a:pPr indent="0" marL="0">
+              <a:buNone/>
+            </a:pPr>
+            <a:r>
+              <a:rPr lang="en-US" sz="2000" dirty="0">
+                <a:solidFill>
+                  <a:srgbClr val="1E2761"/>
+                </a:solidFill>
+                <a:latin typeface="Cambria" pitchFamily="34" charset="0"/>
+                <a:ea typeface="Cambria" pitchFamily="34" charset="-122"/>
+                <a:cs typeface="Cambria" pitchFamily="34" charset="-120"/>
+              </a:rPr>
+              <a:t> Verwaltung und Justiz · </a:t>
+            </a:r>
+            <a:pPr indent="0" marL="0">
+              <a:buNone/>
+            </a:pPr>
+            <a:r>
+              <a:rPr lang="en-US" sz="2000" b="1" dirty="0">
+                <a:solidFill>
+                  <a:srgbClr val="1E2761"/>
+                </a:solidFill>
+                <a:latin typeface="Cambria" pitchFamily="34" charset="0"/>
+                <a:ea typeface="Cambria" pitchFamily="34" charset="-122"/>
+                <a:cs typeface="Cambria" pitchFamily="34" charset="-120"/>
+              </a:rPr>
+              <a:t>2</a:t>
+            </a:r>
+            <a:pPr indent="0" marL="0">
+              <a:buNone/>
+            </a:pPr>
+            <a:r>
+              <a:rPr lang="en-US" sz="2000" dirty="0">
+                <a:solidFill>
+                  <a:srgbClr val="1E2761"/>
+                </a:solidFill>
+                <a:latin typeface="Cambria" pitchFamily="34" charset="0"/>
+                <a:ea typeface="Cambria" pitchFamily="34" charset="-122"/>
+                <a:cs typeface="Cambria" pitchFamily="34" charset="-120"/>
+              </a:rPr>
+              <a:t> Adel und Hof von Versailles · </a:t>
+            </a:r>
+            <a:pPr indent="0" marL="0">
+              <a:buNone/>
+            </a:pPr>
+            <a:r>
+              <a:rPr lang="en-US" sz="2000" b="1" dirty="0">
+                <a:solidFill>
+                  <a:srgbClr val="1E2761"/>
+                </a:solidFill>
+                <a:latin typeface="Cambria" pitchFamily="34" charset="0"/>
+                <a:ea typeface="Cambria" pitchFamily="34" charset="-122"/>
+                <a:cs typeface="Cambria" pitchFamily="34" charset="-120"/>
+              </a:rPr>
+              <a:t>3</a:t>
+            </a:r>
+            <a:pPr indent="0" marL="0">
+              <a:buNone/>
+            </a:pPr>
+            <a:r>
+              <a:rPr lang="en-US" sz="2000" dirty="0">
+                <a:solidFill>
+                  <a:srgbClr val="1E2761"/>
+                </a:solidFill>
+                <a:latin typeface="Cambria" pitchFamily="34" charset="0"/>
+                <a:ea typeface="Cambria" pitchFamily="34" charset="-122"/>
+                <a:cs typeface="Cambria" pitchFamily="34" charset="-120"/>
+              </a:rPr>
+              <a:t> Wirtschaft (Merkantilismus) · </a:t>
+            </a:r>
+            <a:pPr indent="0" marL="0">
+              <a:buNone/>
+            </a:pPr>
+            <a:r>
+              <a:rPr lang="en-US" sz="2000" b="1" dirty="0">
+                <a:solidFill>
+                  <a:srgbClr val="1E2761"/>
+                </a:solidFill>
+                <a:latin typeface="Cambria" pitchFamily="34" charset="0"/>
+                <a:ea typeface="Cambria" pitchFamily="34" charset="-122"/>
+                <a:cs typeface="Cambria" pitchFamily="34" charset="-120"/>
+              </a:rPr>
+              <a:t>4</a:t>
+            </a:r>
+            <a:pPr indent="0" marL="0">
+              <a:buNone/>
+            </a:pPr>
+            <a:r>
+              <a:rPr lang="en-US" sz="2000" dirty="0">
+                <a:solidFill>
+                  <a:srgbClr val="1E2761"/>
+                </a:solidFill>
+                <a:latin typeface="Cambria" pitchFamily="34" charset="0"/>
+                <a:ea typeface="Cambria" pitchFamily="34" charset="-122"/>
+                <a:cs typeface="Cambria" pitchFamily="34" charset="-120"/>
+              </a:rPr>
+              <a:t> Religion (Gottesgnadentum) · </a:t>
+            </a:r>
+            <a:pPr indent="0" marL="0">
+              <a:buNone/>
+            </a:pPr>
+            <a:r>
+              <a:rPr lang="en-US" sz="2000" b="1" dirty="0">
+                <a:solidFill>
+                  <a:srgbClr val="1E2761"/>
+                </a:solidFill>
+                <a:latin typeface="Cambria" pitchFamily="34" charset="0"/>
+                <a:ea typeface="Cambria" pitchFamily="34" charset="-122"/>
+                <a:cs typeface="Cambria" pitchFamily="34" charset="-120"/>
+              </a:rPr>
+              <a:t>5</a:t>
+            </a:r>
+            <a:pPr indent="0" marL="0">
+              <a:buNone/>
+            </a:pPr>
+            <a:r>
+              <a:rPr lang="en-US" sz="2000" dirty="0">
+                <a:solidFill>
+                  <a:srgbClr val="1E2761"/>
+                </a:solidFill>
+                <a:latin typeface="Cambria" pitchFamily="34" charset="0"/>
+                <a:ea typeface="Cambria" pitchFamily="34" charset="-122"/>
+                <a:cs typeface="Cambria" pitchFamily="34" charset="-120"/>
+              </a:rPr>
+              <a:t> Heer (stehendes Heer).</a:t>
+            </a:r>
+            <a:endParaRPr lang="en-US" sz="2000" dirty="0"/>
+          </a:p>
+        </p:txBody>
+      </p:sp>
+      <p:sp>
+        <p:nvSpPr>
+          <p:cNvPr id="6" name="Shape 4"/>
           <p:cNvSpPr/>
           <p:nvPr/>
         </p:nvSpPr>
         <p:spPr>
           <a:xfrm>
-            <a:off x="731520" y="1568196"/>
-            <a:ext cx="384048" cy="384048"/>
-          </a:xfrm>
-          <a:prstGeom prst="ellipse">
-            <a:avLst/>
-          </a:prstGeom>
-          <a:solidFill>
-            <a:srgbClr val="1E2761"/>
-          </a:solidFill>
-          <a:ln/>
-        </p:spPr>
-      </p:sp>
-      <p:sp>
-        <p:nvSpPr>
-          <p:cNvPr id="6" name="Text 4"/>
-          <p:cNvSpPr txBox="1"/>
-          <p:nvPr/>
-        </p:nvSpPr>
-        <p:spPr>
-          <a:xfrm>
-            <a:off x="731520" y="1568196"/>
-            <a:ext cx="384048" cy="384048"/>
-          </a:xfrm>
-          <a:prstGeom prst="rect">
-            <a:avLst/>
-          </a:prstGeom>
-          <a:noFill/>
-          <a:ln/>
-        </p:spPr>
-        <p:txBody>
-          <a:bodyPr wrap="square" lIns="0" tIns="0" rIns="0" bIns="0" rtlCol="0" anchor="ctr"/>
-          <a:lstStyle/>
-          <a:p>
-            <a:pPr algn="ctr" indent="0" marL="0">
-              <a:buNone/>
-            </a:pPr>
-            <a:r>
-              <a:rPr lang="en-US" sz="1800" b="1" dirty="0">
-                <a:solidFill>
-                  <a:srgbClr val="FFFFFF"/>
-                </a:solidFill>
-                <a:latin typeface="Calibri" pitchFamily="34" charset="0"/>
-                <a:ea typeface="Calibri" pitchFamily="34" charset="-122"/>
-                <a:cs typeface="Calibri" pitchFamily="34" charset="-120"/>
-              </a:rPr>
-              <a:t>1</a:t>
-            </a:r>
-            <a:endParaRPr lang="en-US" sz="1800" dirty="0"/>
-          </a:p>
-        </p:txBody>
-      </p:sp>
-      <p:sp>
-        <p:nvSpPr>
-          <p:cNvPr id="7" name="Text 5"/>
-          <p:cNvSpPr txBox="1"/>
-          <p:nvPr/>
-        </p:nvSpPr>
-        <p:spPr>
-          <a:xfrm>
-            <a:off x="1280160" y="1554480"/>
-            <a:ext cx="10241280" cy="411480"/>
-          </a:xfrm>
-          <a:prstGeom prst="rect">
-            <a:avLst/>
-          </a:prstGeom>
-          <a:noFill/>
-          <a:ln/>
-        </p:spPr>
-        <p:txBody>
-          <a:bodyPr wrap="square" lIns="0" tIns="0" rIns="0" bIns="0" rtlCol="0" anchor="t"/>
-          <a:lstStyle/>
-          <a:p>
-            <a:pPr indent="0" marL="0">
-              <a:buNone/>
-            </a:pPr>
-            <a:r>
-              <a:rPr lang="en-US" sz="2100" b="1" dirty="0">
-                <a:solidFill>
-                  <a:srgbClr val="1E2761"/>
-                </a:solidFill>
-                <a:latin typeface="Calibri" pitchFamily="34" charset="0"/>
-                <a:ea typeface="Calibri" pitchFamily="34" charset="-122"/>
-                <a:cs typeface="Calibri" pitchFamily="34" charset="-120"/>
-              </a:rPr>
-              <a:t>Lies die vier Behauptungen. Entscheide still: wahr oder falsch?</a:t>
-            </a:r>
-            <a:endParaRPr lang="en-US" sz="2100" dirty="0"/>
-          </a:p>
-        </p:txBody>
-      </p:sp>
-      <p:sp>
-        <p:nvSpPr>
-          <p:cNvPr id="8" name="Shape 6"/>
-          <p:cNvSpPr/>
-          <p:nvPr/>
-        </p:nvSpPr>
-        <p:spPr>
-          <a:xfrm>
-            <a:off x="731520" y="2052828"/>
-            <a:ext cx="384048" cy="384048"/>
-          </a:xfrm>
-          <a:prstGeom prst="ellipse">
-            <a:avLst/>
-          </a:prstGeom>
-          <a:solidFill>
-            <a:srgbClr val="1E2761"/>
-          </a:solidFill>
-          <a:ln/>
-        </p:spPr>
-      </p:sp>
-      <p:sp>
-        <p:nvSpPr>
-          <p:cNvPr id="9" name="Text 7"/>
-          <p:cNvSpPr txBox="1"/>
-          <p:nvPr/>
-        </p:nvSpPr>
-        <p:spPr>
-          <a:xfrm>
-            <a:off x="731520" y="2052828"/>
-            <a:ext cx="384048" cy="384048"/>
-          </a:xfrm>
-          <a:prstGeom prst="rect">
-            <a:avLst/>
-          </a:prstGeom>
-          <a:noFill/>
-          <a:ln/>
-        </p:spPr>
-        <p:txBody>
-          <a:bodyPr wrap="square" lIns="0" tIns="0" rIns="0" bIns="0" rtlCol="0" anchor="ctr"/>
-          <a:lstStyle/>
-          <a:p>
-            <a:pPr algn="ctr" indent="0" marL="0">
-              <a:buNone/>
-            </a:pPr>
-            <a:r>
-              <a:rPr lang="en-US" sz="1800" b="1" dirty="0">
-                <a:solidFill>
-                  <a:srgbClr val="FFFFFF"/>
-                </a:solidFill>
-                <a:latin typeface="Calibri" pitchFamily="34" charset="0"/>
-                <a:ea typeface="Calibri" pitchFamily="34" charset="-122"/>
-                <a:cs typeface="Calibri" pitchFamily="34" charset="-120"/>
-              </a:rPr>
-              <a:t>2</a:t>
-            </a:r>
-            <a:endParaRPr lang="en-US" sz="1800" dirty="0"/>
-          </a:p>
-        </p:txBody>
-      </p:sp>
-      <p:sp>
-        <p:nvSpPr>
-          <p:cNvPr id="10" name="Text 8"/>
-          <p:cNvSpPr txBox="1"/>
-          <p:nvPr/>
-        </p:nvSpPr>
-        <p:spPr>
-          <a:xfrm>
-            <a:off x="1280160" y="2039112"/>
-            <a:ext cx="10241280" cy="411480"/>
-          </a:xfrm>
-          <a:prstGeom prst="rect">
-            <a:avLst/>
-          </a:prstGeom>
-          <a:noFill/>
-          <a:ln/>
-        </p:spPr>
-        <p:txBody>
-          <a:bodyPr wrap="square" lIns="0" tIns="0" rIns="0" bIns="0" rtlCol="0" anchor="t"/>
-          <a:lstStyle/>
-          <a:p>
-            <a:pPr indent="0" marL="0">
-              <a:buNone/>
-            </a:pPr>
-            <a:r>
-              <a:rPr lang="en-US" sz="2100" b="1" dirty="0">
-                <a:solidFill>
-                  <a:srgbClr val="1E2761"/>
-                </a:solidFill>
-                <a:latin typeface="Calibri" pitchFamily="34" charset="0"/>
-                <a:ea typeface="Calibri" pitchFamily="34" charset="-122"/>
-                <a:cs typeface="Calibri" pitchFamily="34" charset="-120"/>
-              </a:rPr>
-              <a:t>Melde dich: Nenne deine Entscheidung und begründe sie.</a:t>
-            </a:r>
-            <a:endParaRPr lang="en-US" sz="2100" dirty="0"/>
-          </a:p>
-        </p:txBody>
-      </p:sp>
-      <p:sp>
-        <p:nvSpPr>
-          <p:cNvPr id="11" name="Shape 9"/>
-          <p:cNvSpPr/>
-          <p:nvPr/>
-        </p:nvSpPr>
-        <p:spPr>
-          <a:xfrm>
-            <a:off x="731520" y="2537460"/>
-            <a:ext cx="384048" cy="384048"/>
-          </a:xfrm>
-          <a:prstGeom prst="ellipse">
-            <a:avLst/>
-          </a:prstGeom>
-          <a:solidFill>
-            <a:srgbClr val="1E2761"/>
-          </a:solidFill>
-          <a:ln/>
-        </p:spPr>
-      </p:sp>
-      <p:sp>
-        <p:nvSpPr>
-          <p:cNvPr id="12" name="Text 10"/>
-          <p:cNvSpPr txBox="1"/>
-          <p:nvPr/>
-        </p:nvSpPr>
-        <p:spPr>
-          <a:xfrm>
-            <a:off x="731520" y="2537460"/>
-            <a:ext cx="384048" cy="384048"/>
-          </a:xfrm>
-          <a:prstGeom prst="rect">
-            <a:avLst/>
-          </a:prstGeom>
-          <a:noFill/>
-          <a:ln/>
-        </p:spPr>
-        <p:txBody>
-          <a:bodyPr wrap="square" lIns="0" tIns="0" rIns="0" bIns="0" rtlCol="0" anchor="ctr"/>
-          <a:lstStyle/>
-          <a:p>
-            <a:pPr algn="ctr" indent="0" marL="0">
-              <a:buNone/>
-            </a:pPr>
-            <a:r>
-              <a:rPr lang="en-US" sz="1800" b="1" dirty="0">
-                <a:solidFill>
-                  <a:srgbClr val="FFFFFF"/>
-                </a:solidFill>
-                <a:latin typeface="Calibri" pitchFamily="34" charset="0"/>
-                <a:ea typeface="Calibri" pitchFamily="34" charset="-122"/>
-                <a:cs typeface="Calibri" pitchFamily="34" charset="-120"/>
-              </a:rPr>
-              <a:t>3</a:t>
-            </a:r>
-            <a:endParaRPr lang="en-US" sz="1800" dirty="0"/>
-          </a:p>
-        </p:txBody>
-      </p:sp>
-      <p:sp>
-        <p:nvSpPr>
-          <p:cNvPr id="13" name="Text 11"/>
-          <p:cNvSpPr txBox="1"/>
-          <p:nvPr/>
-        </p:nvSpPr>
-        <p:spPr>
-          <a:xfrm>
-            <a:off x="1280160" y="2523744"/>
-            <a:ext cx="10241280" cy="411480"/>
-          </a:xfrm>
-          <a:prstGeom prst="rect">
-            <a:avLst/>
-          </a:prstGeom>
-          <a:noFill/>
-          <a:ln/>
-        </p:spPr>
-        <p:txBody>
-          <a:bodyPr wrap="square" lIns="0" tIns="0" rIns="0" bIns="0" rtlCol="0" anchor="t"/>
-          <a:lstStyle/>
-          <a:p>
-            <a:pPr indent="0" marL="0">
-              <a:buNone/>
-            </a:pPr>
-            <a:r>
-              <a:rPr lang="en-US" sz="2100" b="1" dirty="0">
-                <a:solidFill>
-                  <a:srgbClr val="1E2761"/>
-                </a:solidFill>
-                <a:latin typeface="Calibri" pitchFamily="34" charset="0"/>
-                <a:ea typeface="Calibri" pitchFamily="34" charset="-122"/>
-                <a:cs typeface="Calibri" pitchFamily="34" charset="-120"/>
-              </a:rPr>
-              <a:t>Bei „falsch“: Verbessere die Aussage.</a:t>
-            </a:r>
-            <a:endParaRPr lang="en-US" sz="2100" dirty="0"/>
-          </a:p>
-        </p:txBody>
-      </p:sp>
-      <p:sp>
-        <p:nvSpPr>
-          <p:cNvPr id="14" name="Shape 12"/>
-          <p:cNvSpPr/>
-          <p:nvPr/>
-        </p:nvSpPr>
-        <p:spPr>
-          <a:xfrm>
-            <a:off x="548640" y="5897880"/>
+            <a:off x="548640" y="3383280"/>
             <a:ext cx="11109960" cy="548640"/>
           </a:xfrm>
           <a:prstGeom prst="roundRect">
@@ -5323,20 +5241,20 @@
             </a:avLst>
           </a:prstGeom>
           <a:solidFill>
-            <a:srgbClr val="1E2761"/>
-          </a:solidFill>
-          <a:ln/>
-        </p:spPr>
-      </p:sp>
-      <p:sp>
-        <p:nvSpPr>
-          <p:cNvPr id="15" name="Text 13"/>
-          <p:cNvSpPr txBox="1"/>
-          <p:nvPr/>
-        </p:nvSpPr>
-        <p:spPr>
-          <a:xfrm>
-            <a:off x="822960" y="5897880"/>
+            <a:srgbClr val="EAF0FA"/>
+          </a:solidFill>
+          <a:ln/>
+        </p:spPr>
+      </p:sp>
+      <p:sp>
+        <p:nvSpPr>
+          <p:cNvPr id="7" name="Text 5"/>
+          <p:cNvSpPr txBox="1"/>
+          <p:nvPr/>
+        </p:nvSpPr>
+        <p:spPr>
+          <a:xfrm>
+            <a:off x="822960" y="3383280"/>
             <a:ext cx="10607040" cy="548640"/>
           </a:xfrm>
           <a:prstGeom prst="rect">
@@ -5355,351 +5273,33 @@
             <a:r>
               <a:rPr lang="en-US" sz="1700" b="1" dirty="0">
                 <a:solidFill>
-                  <a:srgbClr val="FFFFFF"/>
-                </a:solidFill>
-                <a:latin typeface="Calibri" pitchFamily="34" charset="0"/>
-                <a:ea typeface="Calibri" pitchFamily="34" charset="-122"/>
-                <a:cs typeface="Calibri" pitchFamily="34" charset="-120"/>
-              </a:rPr>
-              <a:t>Zeit: </a:t>
-            </a:r>
-            <a:pPr indent="0" marL="0">
-              <a:buNone/>
-            </a:pPr>
-            <a:r>
-              <a:rPr lang="en-US" sz="1700" dirty="0">
-                <a:solidFill>
-                  <a:srgbClr val="FFFFFF"/>
-                </a:solidFill>
-                <a:latin typeface="Calibri" pitchFamily="34" charset="0"/>
-                <a:ea typeface="Calibri" pitchFamily="34" charset="-122"/>
-                <a:cs typeface="Calibri" pitchFamily="34" charset="-120"/>
-              </a:rPr>
-              <a:t>4 Minuten · gemeinsam · mündlich      </a:t>
-            </a:r>
-            <a:pPr indent="0" marL="0">
-              <a:buNone/>
-            </a:pPr>
-            <a:r>
-              <a:rPr lang="en-US" sz="1700" i="1" dirty="0">
-                <a:solidFill>
-                  <a:srgbClr val="CADCFC"/>
-                </a:solidFill>
-                <a:latin typeface="Calibri" pitchFamily="34" charset="0"/>
-                <a:ea typeface="Calibri" pitchFamily="34" charset="-122"/>
-                <a:cs typeface="Calibri" pitchFamily="34" charset="-120"/>
-              </a:rPr>
-              <a:t>Wer begründet, bekommt das Wort.</a:t>
-            </a:r>
-            <a:endParaRPr lang="en-US" sz="1700" dirty="0"/>
-          </a:p>
-        </p:txBody>
-      </p:sp>
-      <p:sp>
-        <p:nvSpPr>
-          <p:cNvPr id="16" name="Text 14"/>
-          <p:cNvSpPr txBox="1"/>
-          <p:nvPr/>
-        </p:nvSpPr>
-        <p:spPr>
-          <a:xfrm>
-            <a:off x="548640" y="6510528"/>
-            <a:ext cx="5486400" cy="228600"/>
-          </a:xfrm>
-          <a:prstGeom prst="rect">
-            <a:avLst/>
-          </a:prstGeom>
-          <a:noFill/>
-          <a:ln/>
-        </p:spPr>
-        <p:txBody>
-          <a:bodyPr wrap="square" lIns="0" tIns="0" rIns="0" bIns="0" rtlCol="0" anchor="t"/>
-          <a:lstStyle/>
-          <a:p>
-            <a:pPr indent="0" marL="0">
-              <a:buNone/>
-            </a:pPr>
-            <a:r>
-              <a:rPr lang="en-US" sz="1000" dirty="0">
-                <a:solidFill>
                   <a:srgbClr val="5B6B8C"/>
                 </a:solidFill>
                 <a:latin typeface="Calibri" pitchFamily="34" charset="0"/>
                 <a:ea typeface="Calibri" pitchFamily="34" charset="-122"/>
                 <a:cs typeface="Calibri" pitchFamily="34" charset="-120"/>
               </a:rPr>
-              <a:t>Absolutismus · Wiederholung · Geschichte 8</a:t>
-            </a:r>
-            <a:endParaRPr lang="en-US" sz="1000" dirty="0"/>
-          </a:p>
-        </p:txBody>
-      </p:sp>
-      <p:sp>
-        <p:nvSpPr>
-          <p:cNvPr id="17" name="Text 15"/>
-          <p:cNvSpPr txBox="1"/>
-          <p:nvPr/>
-        </p:nvSpPr>
-        <p:spPr>
-          <a:xfrm>
-            <a:off x="11155680" y="6510528"/>
-            <a:ext cx="457200" cy="228600"/>
-          </a:xfrm>
-          <a:prstGeom prst="rect">
-            <a:avLst/>
-          </a:prstGeom>
-          <a:noFill/>
-          <a:ln/>
-        </p:spPr>
-        <p:txBody>
-          <a:bodyPr wrap="square" lIns="0" tIns="0" rIns="0" bIns="0" rtlCol="0" anchor="t"/>
-          <a:lstStyle/>
-          <a:p>
-            <a:pPr algn="r" indent="0" marL="0">
-              <a:buNone/>
-            </a:pPr>
-            <a:r>
-              <a:rPr lang="en-US" sz="1000" dirty="0">
-                <a:solidFill>
-                  <a:srgbClr val="5B6B8C"/>
-                </a:solidFill>
-                <a:latin typeface="Calibri" pitchFamily="34" charset="0"/>
-                <a:ea typeface="Calibri" pitchFamily="34" charset="-122"/>
-                <a:cs typeface="Calibri" pitchFamily="34" charset="-120"/>
-              </a:rPr>
-              <a:t>3</a:t>
-            </a:r>
-            <a:endParaRPr lang="en-US" sz="1000" dirty="0"/>
-          </a:p>
-        </p:txBody>
-      </p:sp>
-      <p:sp>
-        <p:nvSpPr>
-          <p:cNvPr id="19" name="Shape 16"/>
-          <p:cNvSpPr/>
-          <p:nvPr/>
-        </p:nvSpPr>
-        <p:spPr>
-          <a:xfrm>
-            <a:off x="548640" y="3346704"/>
-            <a:ext cx="11109960" cy="530352"/>
-          </a:xfrm>
-          <a:prstGeom prst="roundRect">
-            <a:avLst>
-              <a:gd name="adj" fmla="val 13793"/>
-            </a:avLst>
-          </a:prstGeom>
-          <a:solidFill>
-            <a:srgbClr val="F4F7FD"/>
-          </a:solidFill>
-          <a:ln/>
-        </p:spPr>
-      </p:sp>
-      <p:sp>
-        <p:nvSpPr>
-          <p:cNvPr id="20" name="Shape 17"/>
-          <p:cNvSpPr/>
-          <p:nvPr/>
-        </p:nvSpPr>
-        <p:spPr>
-          <a:xfrm>
-            <a:off x="685800" y="3429000"/>
-            <a:ext cx="365760" cy="365760"/>
-          </a:xfrm>
-          <a:prstGeom prst="ellipse">
-            <a:avLst/>
-          </a:prstGeom>
-          <a:solidFill>
-            <a:srgbClr val="D9534F"/>
-          </a:solidFill>
-          <a:ln/>
-        </p:spPr>
-      </p:sp>
-      <p:sp>
-        <p:nvSpPr>
-          <p:cNvPr id="21" name="Text 18"/>
-          <p:cNvSpPr txBox="1"/>
-          <p:nvPr/>
-        </p:nvSpPr>
-        <p:spPr>
-          <a:xfrm>
-            <a:off x="685800" y="3429000"/>
-            <a:ext cx="365760" cy="365760"/>
-          </a:xfrm>
-          <a:prstGeom prst="rect">
-            <a:avLst/>
-          </a:prstGeom>
-          <a:noFill/>
-          <a:ln/>
-        </p:spPr>
-        <p:txBody>
-          <a:bodyPr wrap="square" lIns="0" tIns="0" rIns="0" bIns="0" rtlCol="0" anchor="ctr"/>
-          <a:lstStyle/>
-          <a:p>
-            <a:pPr algn="ctr" indent="0" marL="0">
-              <a:buNone/>
-            </a:pPr>
-            <a:r>
-              <a:rPr lang="en-US" sz="1800" b="1" dirty="0">
-                <a:solidFill>
-                  <a:srgbClr val="FFFFFF"/>
-                </a:solidFill>
-                <a:latin typeface="Calibri" pitchFamily="34" charset="0"/>
-                <a:ea typeface="Calibri" pitchFamily="34" charset="-122"/>
-                <a:cs typeface="Calibri" pitchFamily="34" charset="-120"/>
-              </a:rPr>
-              <a:t>1</a:t>
-            </a:r>
-            <a:endParaRPr lang="en-US" sz="1800" dirty="0"/>
-          </a:p>
-        </p:txBody>
-      </p:sp>
-      <p:sp>
-        <p:nvSpPr>
-          <p:cNvPr id="22" name="Text 19"/>
-          <p:cNvSpPr txBox="1"/>
-          <p:nvPr/>
-        </p:nvSpPr>
-        <p:spPr>
-          <a:xfrm>
-            <a:off x="1280160" y="3346704"/>
-            <a:ext cx="10241280" cy="530352"/>
-          </a:xfrm>
-          <a:prstGeom prst="rect">
-            <a:avLst/>
-          </a:prstGeom>
-          <a:noFill/>
-          <a:ln/>
-        </p:spPr>
-        <p:txBody>
-          <a:bodyPr wrap="square" lIns="0" tIns="0" rIns="0" bIns="0" rtlCol="0" anchor="ctr"/>
-          <a:lstStyle/>
-          <a:p>
-            <a:pPr indent="0" marL="0">
-              <a:buNone/>
-            </a:pPr>
-            <a:r>
-              <a:rPr lang="en-US" sz="2200" dirty="0">
-                <a:solidFill>
-                  <a:srgbClr val="1E2761"/>
+              <a:t>Beispiel:   </a:t>
+            </a:r>
+            <a:pPr indent="0" marL="0">
+              <a:buNone/>
+            </a:pPr>
+            <a:r>
+              <a:rPr lang="en-US" sz="1900" b="1" dirty="0">
+                <a:solidFill>
+                  <a:srgbClr val="D9534F"/>
                 </a:solidFill>
                 <a:latin typeface="Cambria" pitchFamily="34" charset="0"/>
                 <a:ea typeface="Cambria" pitchFamily="34" charset="-122"/>
                 <a:cs typeface="Cambria" pitchFamily="34" charset="-120"/>
               </a:rPr>
-              <a:t>Der Dritte Stand war mit Abstand der größte Stand.</a:t>
-            </a:r>
-            <a:endParaRPr lang="en-US" sz="2200" dirty="0"/>
-          </a:p>
-        </p:txBody>
-      </p:sp>
-      <p:sp>
-        <p:nvSpPr>
-          <p:cNvPr id="23" name="Shape 20"/>
-          <p:cNvSpPr/>
-          <p:nvPr/>
-        </p:nvSpPr>
-        <p:spPr>
-          <a:xfrm>
-            <a:off x="548640" y="3950208"/>
-            <a:ext cx="11109960" cy="530352"/>
-          </a:xfrm>
-          <a:prstGeom prst="roundRect">
-            <a:avLst>
-              <a:gd name="adj" fmla="val 13793"/>
-            </a:avLst>
-          </a:prstGeom>
-          <a:solidFill>
-            <a:srgbClr val="F4F7FD"/>
-          </a:solidFill>
-          <a:ln/>
-        </p:spPr>
-      </p:sp>
-      <p:sp>
-        <p:nvSpPr>
-          <p:cNvPr id="24" name="Shape 21"/>
-          <p:cNvSpPr/>
-          <p:nvPr/>
-        </p:nvSpPr>
-        <p:spPr>
-          <a:xfrm>
-            <a:off x="685800" y="4032504"/>
-            <a:ext cx="365760" cy="365760"/>
-          </a:xfrm>
-          <a:prstGeom prst="ellipse">
-            <a:avLst/>
-          </a:prstGeom>
-          <a:solidFill>
-            <a:srgbClr val="D9534F"/>
-          </a:solidFill>
-          <a:ln/>
-        </p:spPr>
-      </p:sp>
-      <p:sp>
-        <p:nvSpPr>
-          <p:cNvPr id="25" name="Text 22"/>
-          <p:cNvSpPr txBox="1"/>
-          <p:nvPr/>
-        </p:nvSpPr>
-        <p:spPr>
-          <a:xfrm>
-            <a:off x="685800" y="4032504"/>
-            <a:ext cx="365760" cy="365760"/>
-          </a:xfrm>
-          <a:prstGeom prst="rect">
-            <a:avLst/>
-          </a:prstGeom>
-          <a:noFill/>
-          <a:ln/>
-        </p:spPr>
-        <p:txBody>
-          <a:bodyPr wrap="square" lIns="0" tIns="0" rIns="0" bIns="0" rtlCol="0" anchor="ctr"/>
-          <a:lstStyle/>
-          <a:p>
-            <a:pPr algn="ctr" indent="0" marL="0">
-              <a:buNone/>
-            </a:pPr>
-            <a:r>
-              <a:rPr lang="en-US" sz="1800" b="1" dirty="0">
-                <a:solidFill>
-                  <a:srgbClr val="FFFFFF"/>
-                </a:solidFill>
-                <a:latin typeface="Calibri" pitchFamily="34" charset="0"/>
-                <a:ea typeface="Calibri" pitchFamily="34" charset="-122"/>
-                <a:cs typeface="Calibri" pitchFamily="34" charset="-120"/>
-              </a:rPr>
-              <a:t>2</a:t>
-            </a:r>
-            <a:endParaRPr lang="en-US" sz="1800" dirty="0"/>
-          </a:p>
-        </p:txBody>
-      </p:sp>
-      <p:sp>
-        <p:nvSpPr>
-          <p:cNvPr id="26" name="Text 23"/>
-          <p:cNvSpPr txBox="1"/>
-          <p:nvPr/>
-        </p:nvSpPr>
-        <p:spPr>
-          <a:xfrm>
-            <a:off x="1280160" y="3950208"/>
-            <a:ext cx="10241280" cy="530352"/>
-          </a:xfrm>
-          <a:prstGeom prst="rect">
-            <a:avLst/>
-          </a:prstGeom>
-          <a:noFill/>
-          <a:ln/>
-        </p:spPr>
-        <p:txBody>
-          <a:bodyPr wrap="square" lIns="0" tIns="0" rIns="0" bIns="0" rtlCol="0" anchor="ctr"/>
-          <a:lstStyle/>
-          <a:p>
-            <a:pPr indent="0" marL="0">
-              <a:buNone/>
-            </a:pPr>
-            <a:r>
-              <a:rPr lang="en-US" sz="2200" dirty="0">
+              <a:t>Verwaltung</a:t>
+            </a:r>
+            <a:pPr indent="0" marL="0">
+              <a:buNone/>
+            </a:pPr>
+            <a:r>
+              <a:rPr lang="en-US" sz="1900" dirty="0">
                 <a:solidFill>
                   <a:srgbClr val="1E2761"/>
                 </a:solidFill>
@@ -5707,239 +5307,27 @@
                 <a:ea typeface="Cambria" pitchFamily="34" charset="-122"/>
                 <a:cs typeface="Cambria" pitchFamily="34" charset="-120"/>
               </a:rPr>
-              <a:t>Der Adel musste hohe Steuern an den König zahlen.</a:t>
-            </a:r>
-            <a:endParaRPr lang="en-US" sz="2200" dirty="0"/>
-          </a:p>
-        </p:txBody>
-      </p:sp>
-      <p:sp>
-        <p:nvSpPr>
-          <p:cNvPr id="27" name="Shape 24"/>
-          <p:cNvSpPr/>
-          <p:nvPr/>
-        </p:nvSpPr>
-        <p:spPr>
-          <a:xfrm>
-            <a:off x="548640" y="4553712"/>
-            <a:ext cx="11109960" cy="530352"/>
-          </a:xfrm>
-          <a:prstGeom prst="roundRect">
-            <a:avLst>
-              <a:gd name="adj" fmla="val 13793"/>
-            </a:avLst>
-          </a:prstGeom>
-          <a:solidFill>
-            <a:srgbClr val="F4F7FD"/>
-          </a:solidFill>
-          <a:ln/>
-        </p:spPr>
-      </p:sp>
-      <p:sp>
-        <p:nvSpPr>
-          <p:cNvPr id="28" name="Shape 25"/>
-          <p:cNvSpPr/>
-          <p:nvPr/>
-        </p:nvSpPr>
-        <p:spPr>
-          <a:xfrm>
-            <a:off x="685800" y="4636008"/>
-            <a:ext cx="365760" cy="365760"/>
-          </a:xfrm>
-          <a:prstGeom prst="ellipse">
-            <a:avLst/>
-          </a:prstGeom>
-          <a:solidFill>
-            <a:srgbClr val="D9534F"/>
-          </a:solidFill>
-          <a:ln/>
-        </p:spPr>
-      </p:sp>
-      <p:sp>
-        <p:nvSpPr>
-          <p:cNvPr id="29" name="Text 26"/>
-          <p:cNvSpPr txBox="1"/>
-          <p:nvPr/>
-        </p:nvSpPr>
-        <p:spPr>
-          <a:xfrm>
-            <a:off x="685800" y="4636008"/>
-            <a:ext cx="365760" cy="365760"/>
-          </a:xfrm>
-          <a:prstGeom prst="rect">
-            <a:avLst/>
-          </a:prstGeom>
-          <a:noFill/>
-          <a:ln/>
-        </p:spPr>
-        <p:txBody>
-          <a:bodyPr wrap="square" lIns="0" tIns="0" rIns="0" bIns="0" rtlCol="0" anchor="ctr"/>
-          <a:lstStyle/>
-          <a:p>
-            <a:pPr algn="ctr" indent="0" marL="0">
-              <a:buNone/>
-            </a:pPr>
-            <a:r>
-              <a:rPr lang="en-US" sz="1800" b="1" dirty="0">
-                <a:solidFill>
-                  <a:srgbClr val="FFFFFF"/>
-                </a:solidFill>
-                <a:latin typeface="Calibri" pitchFamily="34" charset="0"/>
-                <a:ea typeface="Calibri" pitchFamily="34" charset="-122"/>
-                <a:cs typeface="Calibri" pitchFamily="34" charset="-120"/>
-              </a:rPr>
-              <a:t>3</a:t>
-            </a:r>
-            <a:endParaRPr lang="en-US" sz="1800" dirty="0"/>
-          </a:p>
-        </p:txBody>
-      </p:sp>
-      <p:sp>
-        <p:nvSpPr>
-          <p:cNvPr id="30" name="Text 27"/>
-          <p:cNvSpPr txBox="1"/>
-          <p:nvPr/>
-        </p:nvSpPr>
-        <p:spPr>
-          <a:xfrm>
-            <a:off x="1280160" y="4553712"/>
-            <a:ext cx="10241280" cy="530352"/>
-          </a:xfrm>
-          <a:prstGeom prst="rect">
-            <a:avLst/>
-          </a:prstGeom>
-          <a:noFill/>
-          <a:ln/>
-        </p:spPr>
-        <p:txBody>
-          <a:bodyPr wrap="square" lIns="0" tIns="0" rIns="0" bIns="0" rtlCol="0" anchor="ctr"/>
-          <a:lstStyle/>
-          <a:p>
-            <a:pPr indent="0" marL="0">
-              <a:buNone/>
-            </a:pPr>
-            <a:r>
-              <a:rPr lang="en-US" sz="2200" dirty="0">
-                <a:solidFill>
-                  <a:srgbClr val="1E2761"/>
+              <a:t> kontrolliert das Land · </a:t>
+            </a:r>
+            <a:pPr indent="0" marL="0">
+              <a:buNone/>
+            </a:pPr>
+            <a:r>
+              <a:rPr lang="en-US" sz="1900" b="1" dirty="0">
+                <a:solidFill>
+                  <a:srgbClr val="D9534F"/>
                 </a:solidFill>
                 <a:latin typeface="Cambria" pitchFamily="34" charset="0"/>
                 <a:ea typeface="Cambria" pitchFamily="34" charset="-122"/>
                 <a:cs typeface="Cambria" pitchFamily="34" charset="-120"/>
               </a:rPr>
-              <a:t>Ludwig XIV. verzichtete auf Söldner und baute ein stehendes Heer auf.</a:t>
-            </a:r>
-            <a:endParaRPr lang="en-US" sz="2200" dirty="0"/>
-          </a:p>
-        </p:txBody>
-      </p:sp>
-      <p:sp>
-        <p:nvSpPr>
-          <p:cNvPr id="31" name="Shape 28"/>
-          <p:cNvSpPr/>
-          <p:nvPr/>
-        </p:nvSpPr>
-        <p:spPr>
-          <a:xfrm>
-            <a:off x="548640" y="5157216"/>
-            <a:ext cx="11109960" cy="530352"/>
-          </a:xfrm>
-          <a:prstGeom prst="roundRect">
-            <a:avLst>
-              <a:gd name="adj" fmla="val 13793"/>
-            </a:avLst>
-          </a:prstGeom>
-          <a:solidFill>
-            <a:srgbClr val="F4F7FD"/>
-          </a:solidFill>
-          <a:ln/>
-        </p:spPr>
-      </p:sp>
-      <p:sp>
-        <p:nvSpPr>
-          <p:cNvPr id="32" name="Shape 29"/>
-          <p:cNvSpPr/>
-          <p:nvPr/>
-        </p:nvSpPr>
-        <p:spPr>
-          <a:xfrm>
-            <a:off x="685800" y="5239512"/>
-            <a:ext cx="365760" cy="365760"/>
-          </a:xfrm>
-          <a:prstGeom prst="ellipse">
-            <a:avLst/>
-          </a:prstGeom>
-          <a:solidFill>
-            <a:srgbClr val="D9534F"/>
-          </a:solidFill>
-          <a:ln/>
-        </p:spPr>
-      </p:sp>
-      <p:sp>
-        <p:nvSpPr>
-          <p:cNvPr id="33" name="Text 30"/>
-          <p:cNvSpPr txBox="1"/>
-          <p:nvPr/>
-        </p:nvSpPr>
-        <p:spPr>
-          <a:xfrm>
-            <a:off x="685800" y="5239512"/>
-            <a:ext cx="365760" cy="365760"/>
-          </a:xfrm>
-          <a:prstGeom prst="rect">
-            <a:avLst/>
-          </a:prstGeom>
-          <a:noFill/>
-          <a:ln/>
-        </p:spPr>
-        <p:txBody>
-          <a:bodyPr wrap="square" lIns="0" tIns="0" rIns="0" bIns="0" rtlCol="0" anchor="ctr"/>
-          <a:lstStyle/>
-          <a:p>
-            <a:pPr algn="ctr" indent="0" marL="0">
-              <a:buNone/>
-            </a:pPr>
-            <a:r>
-              <a:rPr lang="en-US" sz="1800" b="1" dirty="0">
-                <a:solidFill>
-                  <a:srgbClr val="FFFFFF"/>
-                </a:solidFill>
-                <a:latin typeface="Calibri" pitchFamily="34" charset="0"/>
-                <a:ea typeface="Calibri" pitchFamily="34" charset="-122"/>
-                <a:cs typeface="Calibri" pitchFamily="34" charset="-120"/>
-              </a:rPr>
-              <a:t>4</a:t>
-            </a:r>
-            <a:endParaRPr lang="en-US" sz="1800" dirty="0"/>
-          </a:p>
-        </p:txBody>
-      </p:sp>
-      <p:sp>
-        <p:nvSpPr>
-          <p:cNvPr id="34" name="Text 31"/>
-          <p:cNvSpPr txBox="1"/>
-          <p:nvPr/>
-        </p:nvSpPr>
-        <p:spPr>
-          <a:xfrm>
-            <a:off x="1280160" y="5157216"/>
-            <a:ext cx="10241280" cy="530352"/>
-          </a:xfrm>
-          <a:prstGeom prst="rect">
-            <a:avLst/>
-          </a:prstGeom>
-          <a:noFill/>
-          <a:ln/>
-        </p:spPr>
-        <p:txBody>
-          <a:bodyPr wrap="square" lIns="0" tIns="0" rIns="0" bIns="0" rtlCol="0" anchor="ctr"/>
-          <a:lstStyle/>
-          <a:p>
-            <a:pPr indent="0" marL="0">
-              <a:buNone/>
-            </a:pPr>
-            <a:r>
-              <a:rPr lang="en-US" sz="2200" dirty="0">
+              <a:t>Hof</a:t>
+            </a:r>
+            <a:pPr indent="0" marL="0">
+              <a:buNone/>
+            </a:pPr>
+            <a:r>
+              <a:rPr lang="en-US" sz="1900" dirty="0">
                 <a:solidFill>
                   <a:srgbClr val="1E2761"/>
                 </a:solidFill>
@@ -5947,9 +5335,502 @@
                 <a:ea typeface="Cambria" pitchFamily="34" charset="-122"/>
                 <a:cs typeface="Cambria" pitchFamily="34" charset="-120"/>
               </a:rPr>
-              <a:t>Ludwig XIV. erlaubte den Protestanten die freie Religionsausübung.</a:t>
-            </a:r>
-            <a:endParaRPr lang="en-US" sz="2200" dirty="0"/>
+              <a:t> bindet den Adel · </a:t>
+            </a:r>
+            <a:pPr indent="0" marL="0">
+              <a:buNone/>
+            </a:pPr>
+            <a:r>
+              <a:rPr lang="en-US" sz="1900" b="1" dirty="0">
+                <a:solidFill>
+                  <a:srgbClr val="D9534F"/>
+                </a:solidFill>
+                <a:latin typeface="Cambria" pitchFamily="34" charset="0"/>
+                <a:ea typeface="Cambria" pitchFamily="34" charset="-122"/>
+                <a:cs typeface="Cambria" pitchFamily="34" charset="-120"/>
+              </a:rPr>
+              <a:t>Wirtschaft</a:t>
+            </a:r>
+            <a:pPr indent="0" marL="0">
+              <a:buNone/>
+            </a:pPr>
+            <a:r>
+              <a:rPr lang="en-US" sz="1900" dirty="0">
+                <a:solidFill>
+                  <a:srgbClr val="1E2761"/>
+                </a:solidFill>
+                <a:latin typeface="Cambria" pitchFamily="34" charset="0"/>
+                <a:ea typeface="Cambria" pitchFamily="34" charset="-122"/>
+                <a:cs typeface="Cambria" pitchFamily="34" charset="-120"/>
+              </a:rPr>
+              <a:t> liefert Geld · </a:t>
+            </a:r>
+            <a:pPr indent="0" marL="0">
+              <a:buNone/>
+            </a:pPr>
+            <a:r>
+              <a:rPr lang="en-US" sz="1900" b="1" dirty="0">
+                <a:solidFill>
+                  <a:srgbClr val="D9534F"/>
+                </a:solidFill>
+                <a:latin typeface="Cambria" pitchFamily="34" charset="0"/>
+                <a:ea typeface="Cambria" pitchFamily="34" charset="-122"/>
+                <a:cs typeface="Cambria" pitchFamily="34" charset="-120"/>
+              </a:rPr>
+              <a:t>Religion</a:t>
+            </a:r>
+            <a:pPr indent="0" marL="0">
+              <a:buNone/>
+            </a:pPr>
+            <a:r>
+              <a:rPr lang="en-US" sz="1900" dirty="0">
+                <a:solidFill>
+                  <a:srgbClr val="1E2761"/>
+                </a:solidFill>
+                <a:latin typeface="Cambria" pitchFamily="34" charset="0"/>
+                <a:ea typeface="Cambria" pitchFamily="34" charset="-122"/>
+                <a:cs typeface="Cambria" pitchFamily="34" charset="-120"/>
+              </a:rPr>
+              <a:t> begründet die Macht · </a:t>
+            </a:r>
+            <a:pPr indent="0" marL="0">
+              <a:buNone/>
+            </a:pPr>
+            <a:r>
+              <a:rPr lang="en-US" sz="1900" b="1" dirty="0">
+                <a:solidFill>
+                  <a:srgbClr val="D9534F"/>
+                </a:solidFill>
+                <a:latin typeface="Cambria" pitchFamily="34" charset="0"/>
+                <a:ea typeface="Cambria" pitchFamily="34" charset="-122"/>
+                <a:cs typeface="Cambria" pitchFamily="34" charset="-120"/>
+              </a:rPr>
+              <a:t>Heer</a:t>
+            </a:r>
+            <a:pPr indent="0" marL="0">
+              <a:buNone/>
+            </a:pPr>
+            <a:r>
+              <a:rPr lang="en-US" sz="1900" dirty="0">
+                <a:solidFill>
+                  <a:srgbClr val="1E2761"/>
+                </a:solidFill>
+                <a:latin typeface="Cambria" pitchFamily="34" charset="0"/>
+                <a:ea typeface="Cambria" pitchFamily="34" charset="-122"/>
+                <a:cs typeface="Cambria" pitchFamily="34" charset="-120"/>
+              </a:rPr>
+              <a:t> setzt sie durch</a:t>
+            </a:r>
+            <a:endParaRPr lang="en-US" sz="1900" dirty="0"/>
+          </a:p>
+        </p:txBody>
+      </p:sp>
+      <p:sp>
+        <p:nvSpPr>
+          <p:cNvPr id="8" name="Shape 6"/>
+          <p:cNvSpPr/>
+          <p:nvPr/>
+        </p:nvSpPr>
+        <p:spPr>
+          <a:xfrm>
+            <a:off x="548640" y="4069080"/>
+            <a:ext cx="5440680" cy="1645920"/>
+          </a:xfrm>
+          <a:prstGeom prst="roundRect">
+            <a:avLst>
+              <a:gd name="adj" fmla="val 4444"/>
+            </a:avLst>
+          </a:prstGeom>
+          <a:solidFill>
+            <a:srgbClr val="F4F7FD"/>
+          </a:solidFill>
+          <a:ln/>
+        </p:spPr>
+      </p:sp>
+      <p:sp>
+        <p:nvSpPr>
+          <p:cNvPr id="9" name="Text 7"/>
+          <p:cNvSpPr txBox="1"/>
+          <p:nvPr/>
+        </p:nvSpPr>
+        <p:spPr>
+          <a:xfrm>
+            <a:off x="777240" y="4187952"/>
+            <a:ext cx="4983480" cy="365760"/>
+          </a:xfrm>
+          <a:prstGeom prst="rect">
+            <a:avLst/>
+          </a:prstGeom>
+          <a:noFill/>
+          <a:ln/>
+        </p:spPr>
+        <p:txBody>
+          <a:bodyPr wrap="square" lIns="0" tIns="0" rIns="0" bIns="0" rtlCol="0" anchor="t"/>
+          <a:lstStyle/>
+          <a:p>
+            <a:pPr indent="0" marL="0">
+              <a:buNone/>
+            </a:pPr>
+            <a:r>
+              <a:rPr lang="en-US" sz="1900" b="1" dirty="0">
+                <a:solidFill>
+                  <a:srgbClr val="D9534F"/>
+                </a:solidFill>
+                <a:latin typeface="Cambria" pitchFamily="34" charset="0"/>
+                <a:ea typeface="Cambria" pitchFamily="34" charset="-122"/>
+                <a:cs typeface="Cambria" pitchFamily="34" charset="-120"/>
+              </a:rPr>
+              <a:t>Wofür brauche ich das?</a:t>
+            </a:r>
+            <a:endParaRPr lang="en-US" sz="1900" dirty="0"/>
+          </a:p>
+        </p:txBody>
+      </p:sp>
+      <p:sp>
+        <p:nvSpPr>
+          <p:cNvPr id="10" name="Text 8"/>
+          <p:cNvSpPr txBox="1"/>
+          <p:nvPr/>
+        </p:nvSpPr>
+        <p:spPr>
+          <a:xfrm>
+            <a:off x="777240" y="4572000"/>
+            <a:ext cx="4983480" cy="1051560"/>
+          </a:xfrm>
+          <a:prstGeom prst="rect">
+            <a:avLst/>
+          </a:prstGeom>
+          <a:noFill/>
+          <a:ln/>
+        </p:spPr>
+        <p:txBody>
+          <a:bodyPr wrap="square" lIns="0" tIns="0" rIns="0" bIns="0" rtlCol="0" anchor="t"/>
+          <a:lstStyle/>
+          <a:p>
+            <a:pPr indent="0" marL="0">
+              <a:buNone/>
+            </a:pPr>
+            <a:r>
+              <a:rPr lang="en-US" sz="1900" dirty="0">
+                <a:solidFill>
+                  <a:srgbClr val="1E2761"/>
+                </a:solidFill>
+                <a:latin typeface="Calibri" pitchFamily="34" charset="0"/>
+                <a:ea typeface="Calibri" pitchFamily="34" charset="-122"/>
+                <a:cs typeface="Calibri" pitchFamily="34" charset="-120"/>
+              </a:rPr>
+              <a:t>Im Test sollst du die Säulen nennen </a:t>
+            </a:r>
+            <a:pPr indent="0" marL="0">
+              <a:buNone/>
+            </a:pPr>
+            <a:r>
+              <a:rPr lang="en-US" sz="1900" b="1" dirty="0">
+                <a:solidFill>
+                  <a:srgbClr val="1E2761"/>
+                </a:solidFill>
+                <a:latin typeface="Calibri" pitchFamily="34" charset="0"/>
+                <a:ea typeface="Calibri" pitchFamily="34" charset="-122"/>
+                <a:cs typeface="Calibri" pitchFamily="34" charset="-120"/>
+              </a:rPr>
+              <a:t>und</a:t>
+            </a:r>
+            <a:pPr indent="0" marL="0">
+              <a:buNone/>
+            </a:pPr>
+            <a:r>
+              <a:rPr lang="en-US" sz="1900" dirty="0">
+                <a:solidFill>
+                  <a:srgbClr val="1E2761"/>
+                </a:solidFill>
+                <a:latin typeface="Calibri" pitchFamily="34" charset="0"/>
+                <a:ea typeface="Calibri" pitchFamily="34" charset="-122"/>
+                <a:cs typeface="Calibri" pitchFamily="34" charset="-120"/>
+              </a:rPr>
+              <a:t> erklären, wie der König damit seine Macht sichert.</a:t>
+            </a:r>
+            <a:endParaRPr lang="en-US" sz="1900" dirty="0"/>
+          </a:p>
+        </p:txBody>
+      </p:sp>
+      <p:sp>
+        <p:nvSpPr>
+          <p:cNvPr id="11" name="Shape 9"/>
+          <p:cNvSpPr/>
+          <p:nvPr/>
+        </p:nvSpPr>
+        <p:spPr>
+          <a:xfrm>
+            <a:off x="6217920" y="4069080"/>
+            <a:ext cx="5440680" cy="1645920"/>
+          </a:xfrm>
+          <a:prstGeom prst="roundRect">
+            <a:avLst>
+              <a:gd name="adj" fmla="val 4444"/>
+            </a:avLst>
+          </a:prstGeom>
+          <a:solidFill>
+            <a:srgbClr val="F4F7FD"/>
+          </a:solidFill>
+          <a:ln/>
+        </p:spPr>
+      </p:sp>
+      <p:sp>
+        <p:nvSpPr>
+          <p:cNvPr id="12" name="Text 10"/>
+          <p:cNvSpPr txBox="1"/>
+          <p:nvPr/>
+        </p:nvSpPr>
+        <p:spPr>
+          <a:xfrm>
+            <a:off x="6446520" y="4187952"/>
+            <a:ext cx="4983480" cy="365760"/>
+          </a:xfrm>
+          <a:prstGeom prst="rect">
+            <a:avLst/>
+          </a:prstGeom>
+          <a:noFill/>
+          <a:ln/>
+        </p:spPr>
+        <p:txBody>
+          <a:bodyPr wrap="square" lIns="0" tIns="0" rIns="0" bIns="0" rtlCol="0" anchor="t"/>
+          <a:lstStyle/>
+          <a:p>
+            <a:pPr indent="0" marL="0">
+              <a:buNone/>
+            </a:pPr>
+            <a:r>
+              <a:rPr lang="en-US" sz="1900" b="1" dirty="0">
+                <a:solidFill>
+                  <a:srgbClr val="D9534F"/>
+                </a:solidFill>
+                <a:latin typeface="Cambria" pitchFamily="34" charset="0"/>
+                <a:ea typeface="Cambria" pitchFamily="34" charset="-122"/>
+                <a:cs typeface="Cambria" pitchFamily="34" charset="-120"/>
+              </a:rPr>
+              <a:t>Test</a:t>
+            </a:r>
+            <a:endParaRPr lang="en-US" sz="1900" dirty="0"/>
+          </a:p>
+        </p:txBody>
+      </p:sp>
+      <p:sp>
+        <p:nvSpPr>
+          <p:cNvPr id="13" name="Text 11"/>
+          <p:cNvSpPr txBox="1"/>
+          <p:nvPr/>
+        </p:nvSpPr>
+        <p:spPr>
+          <a:xfrm>
+            <a:off x="6446520" y="4572000"/>
+            <a:ext cx="4983480" cy="1051560"/>
+          </a:xfrm>
+          <a:prstGeom prst="rect">
+            <a:avLst/>
+          </a:prstGeom>
+          <a:noFill/>
+          <a:ln/>
+        </p:spPr>
+        <p:txBody>
+          <a:bodyPr wrap="square" lIns="0" tIns="0" rIns="0" bIns="0" rtlCol="0" anchor="t"/>
+          <a:lstStyle/>
+          <a:p>
+            <a:pPr indent="0" marL="0">
+              <a:buNone/>
+            </a:pPr>
+            <a:r>
+              <a:rPr lang="en-US" sz="1900" dirty="0">
+                <a:solidFill>
+                  <a:srgbClr val="1E2761"/>
+                </a:solidFill>
+                <a:latin typeface="Calibri" pitchFamily="34" charset="0"/>
+                <a:ea typeface="Calibri" pitchFamily="34" charset="-122"/>
+                <a:cs typeface="Calibri" pitchFamily="34" charset="-120"/>
+              </a:rPr>
+              <a:t>Bei jeder Säule fragen: </a:t>
+            </a:r>
+            <a:pPr indent="0" marL="0">
+              <a:buNone/>
+            </a:pPr>
+            <a:r>
+              <a:rPr lang="en-US" sz="1900" b="1" dirty="0">
+                <a:solidFill>
+                  <a:srgbClr val="1E2761"/>
+                </a:solidFill>
+                <a:latin typeface="Calibri" pitchFamily="34" charset="0"/>
+                <a:ea typeface="Calibri" pitchFamily="34" charset="-122"/>
+                <a:cs typeface="Calibri" pitchFamily="34" charset="-120"/>
+              </a:rPr>
+              <a:t>Was sichert der König damit?</a:t>
+            </a:r>
+            <a:endParaRPr lang="en-US" sz="1900" dirty="0"/>
+          </a:p>
+        </p:txBody>
+      </p:sp>
+      <p:sp>
+        <p:nvSpPr>
+          <p:cNvPr id="14" name="Shape 12"/>
+          <p:cNvSpPr/>
+          <p:nvPr/>
+        </p:nvSpPr>
+        <p:spPr>
+          <a:xfrm>
+            <a:off x="548640" y="5897880"/>
+            <a:ext cx="11109960" cy="548640"/>
+          </a:xfrm>
+          <a:prstGeom prst="roundRect">
+            <a:avLst>
+              <a:gd name="adj" fmla="val 13333"/>
+            </a:avLst>
+          </a:prstGeom>
+          <a:solidFill>
+            <a:srgbClr val="1E2761"/>
+          </a:solidFill>
+          <a:ln/>
+        </p:spPr>
+      </p:sp>
+      <p:sp>
+        <p:nvSpPr>
+          <p:cNvPr id="15" name="Text 13"/>
+          <p:cNvSpPr txBox="1"/>
+          <p:nvPr/>
+        </p:nvSpPr>
+        <p:spPr>
+          <a:xfrm>
+            <a:off x="822960" y="5897880"/>
+            <a:ext cx="10607040" cy="548640"/>
+          </a:xfrm>
+          <a:prstGeom prst="rect">
+            <a:avLst/>
+          </a:prstGeom>
+          <a:noFill/>
+          <a:ln/>
+        </p:spPr>
+        <p:txBody>
+          <a:bodyPr wrap="square" lIns="0" tIns="0" rIns="0" bIns="0" rtlCol="0" anchor="ctr"/>
+          <a:lstStyle/>
+          <a:p>
+            <a:pPr indent="0" marL="0">
+              <a:buNone/>
+            </a:pPr>
+            <a:r>
+              <a:rPr lang="en-US" sz="1700" b="1" dirty="0">
+                <a:solidFill>
+                  <a:srgbClr val="FFFFFF"/>
+                </a:solidFill>
+                <a:latin typeface="Calibri" pitchFamily="34" charset="0"/>
+                <a:ea typeface="Calibri" pitchFamily="34" charset="-122"/>
+                <a:cs typeface="Calibri" pitchFamily="34" charset="-120"/>
+              </a:rPr>
+              <a:t>Jetzt: </a:t>
+            </a:r>
+            <a:pPr indent="0" marL="0">
+              <a:buNone/>
+            </a:pPr>
+            <a:r>
+              <a:rPr lang="en-US" sz="1700" dirty="0">
+                <a:solidFill>
+                  <a:srgbClr val="FFFFFF"/>
+                </a:solidFill>
+                <a:latin typeface="Calibri" pitchFamily="34" charset="0"/>
+                <a:ea typeface="Calibri" pitchFamily="34" charset="-122"/>
+                <a:cs typeface="Calibri" pitchFamily="34" charset="-120"/>
+              </a:rPr>
+              <a:t>Schreibe den Merksatz mit Beispiel ab und rahme ihn rot ein.      </a:t>
+            </a:r>
+            <a:pPr indent="0" marL="0">
+              <a:buNone/>
+            </a:pPr>
+            <a:r>
+              <a:rPr lang="en-US" sz="1700" i="1" dirty="0">
+                <a:solidFill>
+                  <a:srgbClr val="CADCFC"/>
+                </a:solidFill>
+                <a:latin typeface="Calibri" pitchFamily="34" charset="0"/>
+                <a:ea typeface="Calibri" pitchFamily="34" charset="-122"/>
+                <a:cs typeface="Calibri" pitchFamily="34" charset="-120"/>
+              </a:rPr>
+              <a:t>Fertig? Stift hinlegen.</a:t>
+            </a:r>
+            <a:endParaRPr lang="en-US" sz="1700" dirty="0"/>
+          </a:p>
+        </p:txBody>
+      </p:sp>
+      <p:sp>
+        <p:nvSpPr>
+          <p:cNvPr id="16" name="Text 14"/>
+          <p:cNvSpPr txBox="1"/>
+          <p:nvPr/>
+        </p:nvSpPr>
+        <p:spPr>
+          <a:xfrm>
+            <a:off x="548640" y="6510528"/>
+            <a:ext cx="5486400" cy="228600"/>
+          </a:xfrm>
+          <a:prstGeom prst="rect">
+            <a:avLst/>
+          </a:prstGeom>
+          <a:noFill/>
+          <a:ln/>
+        </p:spPr>
+        <p:txBody>
+          <a:bodyPr wrap="square" lIns="0" tIns="0" rIns="0" bIns="0" rtlCol="0" anchor="t"/>
+          <a:lstStyle/>
+          <a:p>
+            <a:pPr indent="0" marL="0">
+              <a:buNone/>
+            </a:pPr>
+            <a:r>
+              <a:rPr lang="en-US" sz="1000" dirty="0">
+                <a:solidFill>
+                  <a:srgbClr val="5B6B8C"/>
+                </a:solidFill>
+                <a:latin typeface="Calibri" pitchFamily="34" charset="0"/>
+                <a:ea typeface="Calibri" pitchFamily="34" charset="-122"/>
+                <a:cs typeface="Calibri" pitchFamily="34" charset="-120"/>
+              </a:rPr>
+              <a:t>Absolutismus · Wiederholung · Geschichte 8</a:t>
+            </a:r>
+            <a:endParaRPr lang="en-US" sz="1000" dirty="0"/>
+          </a:p>
+        </p:txBody>
+      </p:sp>
+      <p:sp>
+        <p:nvSpPr>
+          <p:cNvPr id="17" name="Text 15"/>
+          <p:cNvSpPr txBox="1"/>
+          <p:nvPr/>
+        </p:nvSpPr>
+        <p:spPr>
+          <a:xfrm>
+            <a:off x="11155680" y="6510528"/>
+            <a:ext cx="457200" cy="228600"/>
+          </a:xfrm>
+          <a:prstGeom prst="rect">
+            <a:avLst/>
+          </a:prstGeom>
+          <a:noFill/>
+          <a:ln/>
+        </p:spPr>
+        <p:txBody>
+          <a:bodyPr wrap="square" lIns="0" tIns="0" rIns="0" bIns="0" rtlCol="0" anchor="t"/>
+          <a:lstStyle/>
+          <a:p>
+            <a:pPr algn="r" indent="0" marL="0">
+              <a:buNone/>
+            </a:pPr>
+            <a:r>
+              <a:rPr lang="en-US" sz="1000" dirty="0">
+                <a:solidFill>
+                  <a:srgbClr val="5B6B8C"/>
+                </a:solidFill>
+                <a:latin typeface="Calibri" pitchFamily="34" charset="0"/>
+                <a:ea typeface="Calibri" pitchFamily="34" charset="-122"/>
+                <a:cs typeface="Calibri" pitchFamily="34" charset="-120"/>
+              </a:rPr>
+              <a:t>3</a:t>
+            </a:r>
+            <a:endParaRPr lang="en-US" sz="1000" dirty="0"/>
           </a:p>
         </p:txBody>
       </p:sp>
@@ -5994,7 +5875,7 @@
         <p:spPr>
           <a:xfrm>
             <a:off x="548640" y="320040"/>
-            <a:ext cx="9144000" cy="274320"/>
+            <a:ext cx="7315200" cy="274320"/>
           </a:xfrm>
           <a:prstGeom prst="rect">
             <a:avLst/>
@@ -6012,13 +5893,13 @@
             <a:r>
               <a:rPr lang="en-US" sz="1300" b="1" spc="200" kern="0" dirty="0">
                 <a:solidFill>
-                  <a:srgbClr val="D9534F"/>
-                </a:solidFill>
-                <a:latin typeface="Calibri" pitchFamily="34" charset="0"/>
-                <a:ea typeface="Calibri" pitchFamily="34" charset="-122"/>
-                <a:cs typeface="Calibri" pitchFamily="34" charset="-120"/>
-              </a:rPr>
-              <a:t>MERKSATZ 1 · ABSCHREIBEN UND ROT UMRAHMEN</a:t>
+                  <a:srgbClr val="5B6B8C"/>
+                </a:solidFill>
+                <a:latin typeface="Calibri" pitchFamily="34" charset="0"/>
+                <a:ea typeface="Calibri" pitchFamily="34" charset="-122"/>
+                <a:cs typeface="Calibri" pitchFamily="34" charset="-120"/>
+              </a:rPr>
+              <a:t>ÜBUNG 1 · ARBEITSBLATT</a:t>
             </a:r>
             <a:endParaRPr lang="en-US" sz="1300" dirty="0"/>
           </a:p>
@@ -6057,7 +5938,7 @@
                 <a:ea typeface="Cambria" pitchFamily="34" charset="-122"/>
                 <a:cs typeface="Cambria" pitchFamily="34" charset="-120"/>
               </a:rPr>
-              <a:t>Absolutismus</a:t>
+              <a:t>Lückentext: Die fünf Säulen</a:t>
             </a:r>
             <a:endParaRPr lang="en-US" sz="3400" dirty="0"/>
           </a:p>
@@ -6072,34 +5953,49 @@
         <p:spPr>
           <a:xfrm>
             <a:off x="548640" y="1417320"/>
-            <a:ext cx="11109960" cy="1828800"/>
+            <a:ext cx="11109960" cy="1975104"/>
           </a:xfrm>
           <a:prstGeom prst="roundRect">
             <a:avLst>
-              <a:gd name="adj" fmla="val 4000"/>
+              <a:gd name="adj" fmla="val 3704"/>
             </a:avLst>
           </a:prstGeom>
           <a:solidFill>
-            <a:srgbClr val="FFFFFF"/>
-          </a:solidFill>
-          <a:ln w="38100">
-            <a:solidFill>
-              <a:srgbClr val="D9534F"/>
-            </a:solidFill>
-            <a:prstDash val="solid"/>
-          </a:ln>
-        </p:spPr>
-      </p:sp>
-      <p:sp>
-        <p:nvSpPr>
-          <p:cNvPr id="5" name="Text 3"/>
-          <p:cNvSpPr txBox="1"/>
-          <p:nvPr/>
-        </p:nvSpPr>
-        <p:spPr>
-          <a:xfrm>
-            <a:off x="868680" y="1508760"/>
-            <a:ext cx="10469880" cy="1645920"/>
+            <a:srgbClr val="EAF0FA"/>
+          </a:solidFill>
+          <a:ln/>
+        </p:spPr>
+      </p:sp>
+      <p:sp>
+        <p:nvSpPr>
+          <p:cNvPr id="5" name="Shape 3"/>
+          <p:cNvSpPr/>
+          <p:nvPr/>
+        </p:nvSpPr>
+        <p:spPr>
+          <a:xfrm>
+            <a:off x="731520" y="1568196"/>
+            <a:ext cx="384048" cy="384048"/>
+          </a:xfrm>
+          <a:prstGeom prst="ellipse">
+            <a:avLst/>
+          </a:prstGeom>
+          <a:solidFill>
+            <a:srgbClr val="1E2761"/>
+          </a:solidFill>
+          <a:ln/>
+        </p:spPr>
+      </p:sp>
+      <p:sp>
+        <p:nvSpPr>
+          <p:cNvPr id="6" name="Text 4"/>
+          <p:cNvSpPr txBox="1"/>
+          <p:nvPr/>
+        </p:nvSpPr>
+        <p:spPr>
+          <a:xfrm>
+            <a:off x="731520" y="1568196"/>
+            <a:ext cx="384048" cy="384048"/>
           </a:xfrm>
           <a:prstGeom prst="rect">
             <a:avLst/>
@@ -6111,6 +6007,45 @@
           <a:bodyPr wrap="square" lIns="0" tIns="0" rIns="0" bIns="0" rtlCol="0" anchor="ctr"/>
           <a:lstStyle/>
           <a:p>
+            <a:pPr algn="ctr" indent="0" marL="0">
+              <a:buNone/>
+            </a:pPr>
+            <a:r>
+              <a:rPr lang="en-US" sz="1800" b="1" dirty="0">
+                <a:solidFill>
+                  <a:srgbClr val="FFFFFF"/>
+                </a:solidFill>
+                <a:latin typeface="Calibri" pitchFamily="34" charset="0"/>
+                <a:ea typeface="Calibri" pitchFamily="34" charset="-122"/>
+                <a:cs typeface="Calibri" pitchFamily="34" charset="-120"/>
+              </a:rPr>
+              <a:t>1</a:t>
+            </a:r>
+            <a:endParaRPr lang="en-US" sz="1800" dirty="0"/>
+          </a:p>
+        </p:txBody>
+      </p:sp>
+      <p:sp>
+        <p:nvSpPr>
+          <p:cNvPr id="7" name="Text 5"/>
+          <p:cNvSpPr txBox="1"/>
+          <p:nvPr/>
+        </p:nvSpPr>
+        <p:spPr>
+          <a:xfrm>
+            <a:off x="1280160" y="1554480"/>
+            <a:ext cx="10241280" cy="411480"/>
+          </a:xfrm>
+          <a:prstGeom prst="rect">
+            <a:avLst/>
+          </a:prstGeom>
+          <a:noFill/>
+          <a:ln/>
+        </p:spPr>
+        <p:txBody>
+          <a:bodyPr wrap="square" lIns="0" tIns="0" rIns="0" bIns="0" rtlCol="0" anchor="t"/>
+          <a:lstStyle/>
+          <a:p>
             <a:pPr indent="0" marL="0">
               <a:buNone/>
             </a:pPr>
@@ -6119,26 +6054,194 @@
                 <a:solidFill>
                   <a:srgbClr val="1E2761"/>
                 </a:solidFill>
-                <a:latin typeface="Cambria" pitchFamily="34" charset="0"/>
-                <a:ea typeface="Cambria" pitchFamily="34" charset="-122"/>
-                <a:cs typeface="Cambria" pitchFamily="34" charset="-120"/>
-              </a:rPr>
-              <a:t>Absolutismus</a:t>
-            </a:r>
-            <a:pPr indent="0" marL="0">
-              <a:buNone/>
-            </a:pPr>
-            <a:r>
-              <a:rPr lang="en-US" sz="2100" dirty="0">
+                <a:latin typeface="Calibri" pitchFamily="34" charset="0"/>
+                <a:ea typeface="Calibri" pitchFamily="34" charset="-122"/>
+                <a:cs typeface="Calibri" pitchFamily="34" charset="-120"/>
+              </a:rPr>
+              <a:t>Schreibe Ü1 oben auf das Arbeitsblatt.</a:t>
+            </a:r>
+            <a:endParaRPr lang="en-US" sz="2100" dirty="0"/>
+          </a:p>
+        </p:txBody>
+      </p:sp>
+      <p:sp>
+        <p:nvSpPr>
+          <p:cNvPr id="8" name="Shape 6"/>
+          <p:cNvSpPr/>
+          <p:nvPr/>
+        </p:nvSpPr>
+        <p:spPr>
+          <a:xfrm>
+            <a:off x="731520" y="2052828"/>
+            <a:ext cx="384048" cy="384048"/>
+          </a:xfrm>
+          <a:prstGeom prst="ellipse">
+            <a:avLst/>
+          </a:prstGeom>
+          <a:solidFill>
+            <a:srgbClr val="1E2761"/>
+          </a:solidFill>
+          <a:ln/>
+        </p:spPr>
+      </p:sp>
+      <p:sp>
+        <p:nvSpPr>
+          <p:cNvPr id="9" name="Text 7"/>
+          <p:cNvSpPr txBox="1"/>
+          <p:nvPr/>
+        </p:nvSpPr>
+        <p:spPr>
+          <a:xfrm>
+            <a:off x="731520" y="2052828"/>
+            <a:ext cx="384048" cy="384048"/>
+          </a:xfrm>
+          <a:prstGeom prst="rect">
+            <a:avLst/>
+          </a:prstGeom>
+          <a:noFill/>
+          <a:ln/>
+        </p:spPr>
+        <p:txBody>
+          <a:bodyPr wrap="square" lIns="0" tIns="0" rIns="0" bIns="0" rtlCol="0" anchor="ctr"/>
+          <a:lstStyle/>
+          <a:p>
+            <a:pPr algn="ctr" indent="0" marL="0">
+              <a:buNone/>
+            </a:pPr>
+            <a:r>
+              <a:rPr lang="en-US" sz="1800" b="1" dirty="0">
+                <a:solidFill>
+                  <a:srgbClr val="FFFFFF"/>
+                </a:solidFill>
+                <a:latin typeface="Calibri" pitchFamily="34" charset="0"/>
+                <a:ea typeface="Calibri" pitchFamily="34" charset="-122"/>
+                <a:cs typeface="Calibri" pitchFamily="34" charset="-120"/>
+              </a:rPr>
+              <a:t>2</a:t>
+            </a:r>
+            <a:endParaRPr lang="en-US" sz="1800" dirty="0"/>
+          </a:p>
+        </p:txBody>
+      </p:sp>
+      <p:sp>
+        <p:nvSpPr>
+          <p:cNvPr id="10" name="Text 8"/>
+          <p:cNvSpPr txBox="1"/>
+          <p:nvPr/>
+        </p:nvSpPr>
+        <p:spPr>
+          <a:xfrm>
+            <a:off x="1280160" y="2039112"/>
+            <a:ext cx="10241280" cy="731520"/>
+          </a:xfrm>
+          <a:prstGeom prst="rect">
+            <a:avLst/>
+          </a:prstGeom>
+          <a:noFill/>
+          <a:ln/>
+        </p:spPr>
+        <p:txBody>
+          <a:bodyPr wrap="square" lIns="0" tIns="0" rIns="0" bIns="0" rtlCol="0" anchor="t"/>
+          <a:lstStyle/>
+          <a:p>
+            <a:pPr indent="0" marL="0">
+              <a:buNone/>
+            </a:pPr>
+            <a:r>
+              <a:rPr lang="en-US" sz="2100" b="1" dirty="0">
                 <a:solidFill>
                   <a:srgbClr val="1E2761"/>
                 </a:solidFill>
-                <a:latin typeface="Cambria" pitchFamily="34" charset="0"/>
-                <a:ea typeface="Cambria" pitchFamily="34" charset="-122"/>
-                <a:cs typeface="Cambria" pitchFamily="34" charset="-120"/>
-              </a:rPr>
-              <a:t> war eine Herrschaftsform in Europa im </a:t>
-            </a:r>
+                <a:latin typeface="Calibri" pitchFamily="34" charset="0"/>
+                <a:ea typeface="Calibri" pitchFamily="34" charset="-122"/>
+                <a:cs typeface="Calibri" pitchFamily="34" charset="-120"/>
+              </a:rPr>
+              <a:t>Lies den Text einmal ganz. Ergänze dann die 12 Lücken mit dem Wortspeicher.</a:t>
+            </a:r>
+            <a:endParaRPr lang="en-US" sz="2100" dirty="0"/>
+          </a:p>
+        </p:txBody>
+      </p:sp>
+      <p:sp>
+        <p:nvSpPr>
+          <p:cNvPr id="11" name="Shape 9"/>
+          <p:cNvSpPr/>
+          <p:nvPr/>
+        </p:nvSpPr>
+        <p:spPr>
+          <a:xfrm>
+            <a:off x="731520" y="2857500"/>
+            <a:ext cx="384048" cy="384048"/>
+          </a:xfrm>
+          <a:prstGeom prst="ellipse">
+            <a:avLst/>
+          </a:prstGeom>
+          <a:solidFill>
+            <a:srgbClr val="1E2761"/>
+          </a:solidFill>
+          <a:ln/>
+        </p:spPr>
+      </p:sp>
+      <p:sp>
+        <p:nvSpPr>
+          <p:cNvPr id="12" name="Text 10"/>
+          <p:cNvSpPr txBox="1"/>
+          <p:nvPr/>
+        </p:nvSpPr>
+        <p:spPr>
+          <a:xfrm>
+            <a:off x="731520" y="2857500"/>
+            <a:ext cx="384048" cy="384048"/>
+          </a:xfrm>
+          <a:prstGeom prst="rect">
+            <a:avLst/>
+          </a:prstGeom>
+          <a:noFill/>
+          <a:ln/>
+        </p:spPr>
+        <p:txBody>
+          <a:bodyPr wrap="square" lIns="0" tIns="0" rIns="0" bIns="0" rtlCol="0" anchor="ctr"/>
+          <a:lstStyle/>
+          <a:p>
+            <a:pPr algn="ctr" indent="0" marL="0">
+              <a:buNone/>
+            </a:pPr>
+            <a:r>
+              <a:rPr lang="en-US" sz="1800" b="1" dirty="0">
+                <a:solidFill>
+                  <a:srgbClr val="FFFFFF"/>
+                </a:solidFill>
+                <a:latin typeface="Calibri" pitchFamily="34" charset="0"/>
+                <a:ea typeface="Calibri" pitchFamily="34" charset="-122"/>
+                <a:cs typeface="Calibri" pitchFamily="34" charset="-120"/>
+              </a:rPr>
+              <a:t>3</a:t>
+            </a:r>
+            <a:endParaRPr lang="en-US" sz="1800" dirty="0"/>
+          </a:p>
+        </p:txBody>
+      </p:sp>
+      <p:sp>
+        <p:nvSpPr>
+          <p:cNvPr id="13" name="Text 11"/>
+          <p:cNvSpPr txBox="1"/>
+          <p:nvPr/>
+        </p:nvSpPr>
+        <p:spPr>
+          <a:xfrm>
+            <a:off x="1280160" y="2843784"/>
+            <a:ext cx="10241280" cy="411480"/>
+          </a:xfrm>
+          <a:prstGeom prst="rect">
+            <a:avLst/>
+          </a:prstGeom>
+          <a:noFill/>
+          <a:ln/>
+        </p:spPr>
+        <p:txBody>
+          <a:bodyPr wrap="square" lIns="0" tIns="0" rIns="0" bIns="0" rtlCol="0" anchor="t"/>
+          <a:lstStyle/>
+          <a:p>
             <a:pPr indent="0" marL="0">
               <a:buNone/>
             </a:pPr>
@@ -6147,53 +6250,11 @@
                 <a:solidFill>
                   <a:srgbClr val="1E2761"/>
                 </a:solidFill>
-                <a:latin typeface="Cambria" pitchFamily="34" charset="0"/>
-                <a:ea typeface="Cambria" pitchFamily="34" charset="-122"/>
-                <a:cs typeface="Cambria" pitchFamily="34" charset="-120"/>
-              </a:rPr>
-              <a:t>17. und 18. Jahrhundert</a:t>
-            </a:r>
-            <a:pPr indent="0" marL="0">
-              <a:buNone/>
-            </a:pPr>
-            <a:r>
-              <a:rPr lang="en-US" sz="2100" dirty="0">
-                <a:solidFill>
-                  <a:srgbClr val="1E2761"/>
-                </a:solidFill>
-                <a:latin typeface="Cambria" pitchFamily="34" charset="0"/>
-                <a:ea typeface="Cambria" pitchFamily="34" charset="-122"/>
-                <a:cs typeface="Cambria" pitchFamily="34" charset="-120"/>
-              </a:rPr>
-              <a:t>, in der ein einzelner Monarch (König oder Fürst) </a:t>
-            </a:r>
-            <a:pPr indent="0" marL="0">
-              <a:buNone/>
-            </a:pPr>
-            <a:r>
-              <a:rPr lang="en-US" sz="2100" b="1" dirty="0">
-                <a:solidFill>
-                  <a:srgbClr val="1E2761"/>
-                </a:solidFill>
-                <a:latin typeface="Cambria" pitchFamily="34" charset="0"/>
-                <a:ea typeface="Cambria" pitchFamily="34" charset="-122"/>
-                <a:cs typeface="Cambria" pitchFamily="34" charset="-120"/>
-              </a:rPr>
-              <a:t>uneingeschränkt (absolut)</a:t>
-            </a:r>
-            <a:pPr indent="0" marL="0">
-              <a:buNone/>
-            </a:pPr>
-            <a:r>
-              <a:rPr lang="en-US" sz="2100" dirty="0">
-                <a:solidFill>
-                  <a:srgbClr val="1E2761"/>
-                </a:solidFill>
-                <a:latin typeface="Cambria" pitchFamily="34" charset="0"/>
-                <a:ea typeface="Cambria" pitchFamily="34" charset="-122"/>
-                <a:cs typeface="Cambria" pitchFamily="34" charset="-120"/>
-              </a:rPr>
-              <a:t> herrschte.</a:t>
+                <a:latin typeface="Calibri" pitchFamily="34" charset="0"/>
+                <a:ea typeface="Calibri" pitchFamily="34" charset="-122"/>
+                <a:cs typeface="Calibri" pitchFamily="34" charset="-120"/>
+              </a:rPr>
+              <a:t>Streiche jedes benutzte Wort durch. Zwei Wörter passen nicht.</a:t>
             </a:r>
             <a:endParaRPr lang="en-US" sz="2100" dirty="0"/>
           </a:p>
@@ -6201,13 +6262,13 @@
       </p:sp>
       <p:sp>
         <p:nvSpPr>
-          <p:cNvPr id="6" name="Shape 4"/>
+          <p:cNvPr id="14" name="Shape 12"/>
           <p:cNvSpPr/>
           <p:nvPr/>
         </p:nvSpPr>
         <p:spPr>
           <a:xfrm>
-            <a:off x="548640" y="3383280"/>
+            <a:off x="548640" y="5897880"/>
             <a:ext cx="11109960" cy="548640"/>
           </a:xfrm>
           <a:prstGeom prst="roundRect">
@@ -6216,20 +6277,20 @@
             </a:avLst>
           </a:prstGeom>
           <a:solidFill>
-            <a:srgbClr val="EAF0FA"/>
-          </a:solidFill>
-          <a:ln/>
-        </p:spPr>
-      </p:sp>
-      <p:sp>
-        <p:nvSpPr>
-          <p:cNvPr id="7" name="Text 5"/>
-          <p:cNvSpPr txBox="1"/>
-          <p:nvPr/>
-        </p:nvSpPr>
-        <p:spPr>
-          <a:xfrm>
-            <a:off x="822960" y="3383280"/>
+            <a:srgbClr val="1E2761"/>
+          </a:solidFill>
+          <a:ln/>
+        </p:spPr>
+      </p:sp>
+      <p:sp>
+        <p:nvSpPr>
+          <p:cNvPr id="15" name="Text 13"/>
+          <p:cNvSpPr txBox="1"/>
+          <p:nvPr/>
+        </p:nvSpPr>
+        <p:spPr>
+          <a:xfrm>
+            <a:off x="822960" y="5897880"/>
             <a:ext cx="10607040" cy="548640"/>
           </a:xfrm>
           <a:prstGeom prst="rect">
@@ -6248,64 +6309,195 @@
             <a:r>
               <a:rPr lang="en-US" sz="1700" b="1" dirty="0">
                 <a:solidFill>
+                  <a:srgbClr val="FFFFFF"/>
+                </a:solidFill>
+                <a:latin typeface="Calibri" pitchFamily="34" charset="0"/>
+                <a:ea typeface="Calibri" pitchFamily="34" charset="-122"/>
+                <a:cs typeface="Calibri" pitchFamily="34" charset="-120"/>
+              </a:rPr>
+              <a:t>Zeit: </a:t>
+            </a:r>
+            <a:pPr indent="0" marL="0">
+              <a:buNone/>
+            </a:pPr>
+            <a:r>
+              <a:rPr lang="en-US" sz="1700" dirty="0">
+                <a:solidFill>
+                  <a:srgbClr val="FFFFFF"/>
+                </a:solidFill>
+                <a:latin typeface="Calibri" pitchFamily="34" charset="0"/>
+                <a:ea typeface="Calibri" pitchFamily="34" charset="-122"/>
+                <a:cs typeface="Calibri" pitchFamily="34" charset="-120"/>
+              </a:rPr>
+              <a:t>6 Minuten · allein · leise      </a:t>
+            </a:r>
+            <a:pPr indent="0" marL="0">
+              <a:buNone/>
+            </a:pPr>
+            <a:r>
+              <a:rPr lang="en-US" sz="1700" i="1" dirty="0">
+                <a:solidFill>
+                  <a:srgbClr val="CADCFC"/>
+                </a:solidFill>
+                <a:latin typeface="Calibri" pitchFamily="34" charset="0"/>
+                <a:ea typeface="Calibri" pitchFamily="34" charset="-122"/>
+                <a:cs typeface="Calibri" pitchFamily="34" charset="-120"/>
+              </a:rPr>
+              <a:t>Fertig? Stift hinlegen. Schnelle: ★-Aufgabe.</a:t>
+            </a:r>
+            <a:endParaRPr lang="en-US" sz="1700" dirty="0"/>
+          </a:p>
+        </p:txBody>
+      </p:sp>
+      <p:sp>
+        <p:nvSpPr>
+          <p:cNvPr id="16" name="Text 14"/>
+          <p:cNvSpPr txBox="1"/>
+          <p:nvPr/>
+        </p:nvSpPr>
+        <p:spPr>
+          <a:xfrm>
+            <a:off x="548640" y="6510528"/>
+            <a:ext cx="5486400" cy="228600"/>
+          </a:xfrm>
+          <a:prstGeom prst="rect">
+            <a:avLst/>
+          </a:prstGeom>
+          <a:noFill/>
+          <a:ln/>
+        </p:spPr>
+        <p:txBody>
+          <a:bodyPr wrap="square" lIns="0" tIns="0" rIns="0" bIns="0" rtlCol="0" anchor="t"/>
+          <a:lstStyle/>
+          <a:p>
+            <a:pPr indent="0" marL="0">
+              <a:buNone/>
+            </a:pPr>
+            <a:r>
+              <a:rPr lang="en-US" sz="1000" dirty="0">
+                <a:solidFill>
                   <a:srgbClr val="5B6B8C"/>
                 </a:solidFill>
                 <a:latin typeface="Calibri" pitchFamily="34" charset="0"/>
                 <a:ea typeface="Calibri" pitchFamily="34" charset="-122"/>
                 <a:cs typeface="Calibri" pitchFamily="34" charset="-120"/>
               </a:rPr>
-              <a:t>Beispiel:   </a:t>
-            </a:r>
-            <a:pPr indent="0" marL="0">
-              <a:buNone/>
-            </a:pPr>
-            <a:r>
-              <a:rPr lang="en-US" sz="1900" dirty="0">
-                <a:solidFill>
-                  <a:srgbClr val="1E2761"/>
+              <a:t>Absolutismus · Wiederholung · Geschichte 8</a:t>
+            </a:r>
+            <a:endParaRPr lang="en-US" sz="1000" dirty="0"/>
+          </a:p>
+        </p:txBody>
+      </p:sp>
+      <p:sp>
+        <p:nvSpPr>
+          <p:cNvPr id="17" name="Text 15"/>
+          <p:cNvSpPr txBox="1"/>
+          <p:nvPr/>
+        </p:nvSpPr>
+        <p:spPr>
+          <a:xfrm>
+            <a:off x="11155680" y="6510528"/>
+            <a:ext cx="457200" cy="228600"/>
+          </a:xfrm>
+          <a:prstGeom prst="rect">
+            <a:avLst/>
+          </a:prstGeom>
+          <a:noFill/>
+          <a:ln/>
+        </p:spPr>
+        <p:txBody>
+          <a:bodyPr wrap="square" lIns="0" tIns="0" rIns="0" bIns="0" rtlCol="0" anchor="t"/>
+          <a:lstStyle/>
+          <a:p>
+            <a:pPr algn="r" indent="0" marL="0">
+              <a:buNone/>
+            </a:pPr>
+            <a:r>
+              <a:rPr lang="en-US" sz="1000" dirty="0">
+                <a:solidFill>
+                  <a:srgbClr val="5B6B8C"/>
+                </a:solidFill>
+                <a:latin typeface="Calibri" pitchFamily="34" charset="0"/>
+                <a:ea typeface="Calibri" pitchFamily="34" charset="-122"/>
+                <a:cs typeface="Calibri" pitchFamily="34" charset="-120"/>
+              </a:rPr>
+              <a:t>4</a:t>
+            </a:r>
+            <a:endParaRPr lang="en-US" sz="1000" dirty="0"/>
+          </a:p>
+        </p:txBody>
+      </p:sp>
+      <p:sp>
+        <p:nvSpPr>
+          <p:cNvPr id="19" name="Shape 16"/>
+          <p:cNvSpPr/>
+          <p:nvPr/>
+        </p:nvSpPr>
+        <p:spPr>
+          <a:xfrm>
+            <a:off x="548640" y="3758184"/>
+            <a:ext cx="11109960" cy="1463040"/>
+          </a:xfrm>
+          <a:prstGeom prst="roundRect">
+            <a:avLst>
+              <a:gd name="adj" fmla="val 5000"/>
+            </a:avLst>
+          </a:prstGeom>
+          <a:solidFill>
+            <a:srgbClr val="F4F7FD"/>
+          </a:solidFill>
+          <a:ln/>
+        </p:spPr>
+      </p:sp>
+      <p:sp>
+        <p:nvSpPr>
+          <p:cNvPr id="20" name="Text 17"/>
+          <p:cNvSpPr txBox="1"/>
+          <p:nvPr/>
+        </p:nvSpPr>
+        <p:spPr>
+          <a:xfrm>
+            <a:off x="822960" y="3867912"/>
+            <a:ext cx="3657600" cy="320040"/>
+          </a:xfrm>
+          <a:prstGeom prst="rect">
+            <a:avLst/>
+          </a:prstGeom>
+          <a:noFill/>
+          <a:ln/>
+        </p:spPr>
+        <p:txBody>
+          <a:bodyPr wrap="square" lIns="0" tIns="0" rIns="0" bIns="0" rtlCol="0" anchor="t"/>
+          <a:lstStyle/>
+          <a:p>
+            <a:pPr indent="0" marL="0">
+              <a:buNone/>
+            </a:pPr>
+            <a:r>
+              <a:rPr lang="en-US" sz="1700" b="1" dirty="0">
+                <a:solidFill>
+                  <a:srgbClr val="D9534F"/>
                 </a:solidFill>
                 <a:latin typeface="Cambria" pitchFamily="34" charset="0"/>
                 <a:ea typeface="Cambria" pitchFamily="34" charset="-122"/>
                 <a:cs typeface="Cambria" pitchFamily="34" charset="-120"/>
               </a:rPr>
-              <a:t>Ludwig XIV. verkündet 1661: „Ich regiere jetzt selbst.“</a:t>
-            </a:r>
-            <a:endParaRPr lang="en-US" sz="1900" dirty="0"/>
-          </a:p>
-        </p:txBody>
-      </p:sp>
-      <p:sp>
-        <p:nvSpPr>
-          <p:cNvPr id="8" name="Shape 6"/>
-          <p:cNvSpPr/>
-          <p:nvPr/>
-        </p:nvSpPr>
-        <p:spPr>
-          <a:xfrm>
-            <a:off x="548640" y="4069080"/>
-            <a:ext cx="5440680" cy="1645920"/>
-          </a:xfrm>
-          <a:prstGeom prst="roundRect">
-            <a:avLst>
-              <a:gd name="adj" fmla="val 4444"/>
-            </a:avLst>
-          </a:prstGeom>
-          <a:solidFill>
-            <a:srgbClr val="F4F7FD"/>
-          </a:solidFill>
-          <a:ln/>
-        </p:spPr>
-      </p:sp>
-      <p:sp>
-        <p:nvSpPr>
-          <p:cNvPr id="9" name="Text 7"/>
-          <p:cNvSpPr txBox="1"/>
-          <p:nvPr/>
-        </p:nvSpPr>
-        <p:spPr>
-          <a:xfrm>
-            <a:off x="777240" y="4187952"/>
-            <a:ext cx="4983480" cy="365760"/>
+              <a:t>Wortspeicher</a:t>
+            </a:r>
+            <a:endParaRPr lang="en-US" sz="1700" dirty="0"/>
+          </a:p>
+        </p:txBody>
+      </p:sp>
+      <p:sp>
+        <p:nvSpPr>
+          <p:cNvPr id="21" name="Text 18"/>
+          <p:cNvSpPr txBox="1"/>
+          <p:nvPr/>
+        </p:nvSpPr>
+        <p:spPr>
+          <a:xfrm>
+            <a:off x="822960" y="4233672"/>
+            <a:ext cx="10607040" cy="914400"/>
           </a:xfrm>
           <a:prstGeom prst="rect">
             <a:avLst/>
@@ -6321,351 +6513,17 @@
               <a:buNone/>
             </a:pPr>
             <a:r>
-              <a:rPr lang="en-US" sz="1900" b="1" dirty="0">
-                <a:solidFill>
-                  <a:srgbClr val="D9534F"/>
+              <a:rPr lang="en-US" sz="2000" dirty="0">
+                <a:solidFill>
+                  <a:srgbClr val="1E2761"/>
                 </a:solidFill>
                 <a:latin typeface="Cambria" pitchFamily="34" charset="0"/>
                 <a:ea typeface="Cambria" pitchFamily="34" charset="-122"/>
                 <a:cs typeface="Cambria" pitchFamily="34" charset="-120"/>
               </a:rPr>
-              <a:t>Wofür brauche ich das?</a:t>
-            </a:r>
-            <a:endParaRPr lang="en-US" sz="1900" dirty="0"/>
-          </a:p>
-        </p:txBody>
-      </p:sp>
-      <p:sp>
-        <p:nvSpPr>
-          <p:cNvPr id="10" name="Text 8"/>
-          <p:cNvSpPr txBox="1"/>
-          <p:nvPr/>
-        </p:nvSpPr>
-        <p:spPr>
-          <a:xfrm>
-            <a:off x="777240" y="4572000"/>
-            <a:ext cx="4983480" cy="1051560"/>
-          </a:xfrm>
-          <a:prstGeom prst="rect">
-            <a:avLst/>
-          </a:prstGeom>
-          <a:noFill/>
-          <a:ln/>
-        </p:spPr>
-        <p:txBody>
-          <a:bodyPr wrap="square" lIns="0" tIns="0" rIns="0" bIns="0" rtlCol="0" anchor="t"/>
-          <a:lstStyle/>
-          <a:p>
-            <a:pPr indent="0" marL="0">
-              <a:buNone/>
-            </a:pPr>
-            <a:r>
-              <a:rPr lang="en-US" sz="1900" dirty="0">
-                <a:solidFill>
-                  <a:srgbClr val="1E2761"/>
-                </a:solidFill>
-                <a:latin typeface="Calibri" pitchFamily="34" charset="0"/>
-                <a:ea typeface="Calibri" pitchFamily="34" charset="-122"/>
-                <a:cs typeface="Calibri" pitchFamily="34" charset="-120"/>
-              </a:rPr>
-              <a:t>Der Begriff ordnet eine ganze Epoche ein und ist im Test die Grundlage für alle weiteren Fragen.</a:t>
-            </a:r>
-            <a:endParaRPr lang="en-US" sz="1900" dirty="0"/>
-          </a:p>
-        </p:txBody>
-      </p:sp>
-      <p:sp>
-        <p:nvSpPr>
-          <p:cNvPr id="11" name="Shape 9"/>
-          <p:cNvSpPr/>
-          <p:nvPr/>
-        </p:nvSpPr>
-        <p:spPr>
-          <a:xfrm>
-            <a:off x="6217920" y="4069080"/>
-            <a:ext cx="5440680" cy="1645920"/>
-          </a:xfrm>
-          <a:prstGeom prst="roundRect">
-            <a:avLst>
-              <a:gd name="adj" fmla="val 4444"/>
-            </a:avLst>
-          </a:prstGeom>
-          <a:solidFill>
-            <a:srgbClr val="F4F7FD"/>
-          </a:solidFill>
-          <a:ln/>
-        </p:spPr>
-      </p:sp>
-      <p:sp>
-        <p:nvSpPr>
-          <p:cNvPr id="12" name="Text 10"/>
-          <p:cNvSpPr txBox="1"/>
-          <p:nvPr/>
-        </p:nvSpPr>
-        <p:spPr>
-          <a:xfrm>
-            <a:off x="6446520" y="4187952"/>
-            <a:ext cx="4983480" cy="365760"/>
-          </a:xfrm>
-          <a:prstGeom prst="rect">
-            <a:avLst/>
-          </a:prstGeom>
-          <a:noFill/>
-          <a:ln/>
-        </p:spPr>
-        <p:txBody>
-          <a:bodyPr wrap="square" lIns="0" tIns="0" rIns="0" bIns="0" rtlCol="0" anchor="t"/>
-          <a:lstStyle/>
-          <a:p>
-            <a:pPr indent="0" marL="0">
-              <a:buNone/>
-            </a:pPr>
-            <a:r>
-              <a:rPr lang="en-US" sz="1900" b="1" dirty="0">
-                <a:solidFill>
-                  <a:srgbClr val="D9534F"/>
-                </a:solidFill>
-                <a:latin typeface="Cambria" pitchFamily="34" charset="0"/>
-                <a:ea typeface="Cambria" pitchFamily="34" charset="-122"/>
-                <a:cs typeface="Cambria" pitchFamily="34" charset="-120"/>
-              </a:rPr>
-              <a:t>Test</a:t>
-            </a:r>
-            <a:endParaRPr lang="en-US" sz="1900" dirty="0"/>
-          </a:p>
-        </p:txBody>
-      </p:sp>
-      <p:sp>
-        <p:nvSpPr>
-          <p:cNvPr id="13" name="Text 11"/>
-          <p:cNvSpPr txBox="1"/>
-          <p:nvPr/>
-        </p:nvSpPr>
-        <p:spPr>
-          <a:xfrm>
-            <a:off x="6446520" y="4572000"/>
-            <a:ext cx="4983480" cy="1051560"/>
-          </a:xfrm>
-          <a:prstGeom prst="rect">
-            <a:avLst/>
-          </a:prstGeom>
-          <a:noFill/>
-          <a:ln/>
-        </p:spPr>
-        <p:txBody>
-          <a:bodyPr wrap="square" lIns="0" tIns="0" rIns="0" bIns="0" rtlCol="0" anchor="t"/>
-          <a:lstStyle/>
-          <a:p>
-            <a:pPr indent="0" marL="0">
-              <a:buNone/>
-            </a:pPr>
-            <a:r>
-              <a:rPr lang="en-US" sz="1900" dirty="0">
-                <a:solidFill>
-                  <a:srgbClr val="1E2761"/>
-                </a:solidFill>
-                <a:latin typeface="Calibri" pitchFamily="34" charset="0"/>
-                <a:ea typeface="Calibri" pitchFamily="34" charset="-122"/>
-                <a:cs typeface="Calibri" pitchFamily="34" charset="-120"/>
-              </a:rPr>
-              <a:t>Kann jemand den König stoppen (Parlament, Verfassung, Stände)? </a:t>
-            </a:r>
-            <a:pPr indent="0" marL="0">
-              <a:buNone/>
-            </a:pPr>
-            <a:r>
-              <a:rPr lang="en-US" sz="1900" b="1" dirty="0">
-                <a:solidFill>
-                  <a:srgbClr val="1E2761"/>
-                </a:solidFill>
-                <a:latin typeface="Calibri" pitchFamily="34" charset="0"/>
-                <a:ea typeface="Calibri" pitchFamily="34" charset="-122"/>
-                <a:cs typeface="Calibri" pitchFamily="34" charset="-120"/>
-              </a:rPr>
-              <a:t>Nein</a:t>
-            </a:r>
-            <a:pPr indent="0" marL="0">
-              <a:buNone/>
-            </a:pPr>
-            <a:r>
-              <a:rPr lang="en-US" sz="1900" dirty="0">
-                <a:solidFill>
-                  <a:srgbClr val="1E2761"/>
-                </a:solidFill>
-                <a:latin typeface="Calibri" pitchFamily="34" charset="0"/>
-                <a:ea typeface="Calibri" pitchFamily="34" charset="-122"/>
-                <a:cs typeface="Calibri" pitchFamily="34" charset="-120"/>
-              </a:rPr>
-              <a:t> → Absolutismus.</a:t>
-            </a:r>
-            <a:endParaRPr lang="en-US" sz="1900" dirty="0"/>
-          </a:p>
-        </p:txBody>
-      </p:sp>
-      <p:sp>
-        <p:nvSpPr>
-          <p:cNvPr id="14" name="Shape 12"/>
-          <p:cNvSpPr/>
-          <p:nvPr/>
-        </p:nvSpPr>
-        <p:spPr>
-          <a:xfrm>
-            <a:off x="548640" y="5897880"/>
-            <a:ext cx="11109960" cy="548640"/>
-          </a:xfrm>
-          <a:prstGeom prst="roundRect">
-            <a:avLst>
-              <a:gd name="adj" fmla="val 13333"/>
-            </a:avLst>
-          </a:prstGeom>
-          <a:solidFill>
-            <a:srgbClr val="1E2761"/>
-          </a:solidFill>
-          <a:ln/>
-        </p:spPr>
-      </p:sp>
-      <p:sp>
-        <p:nvSpPr>
-          <p:cNvPr id="15" name="Text 13"/>
-          <p:cNvSpPr txBox="1"/>
-          <p:nvPr/>
-        </p:nvSpPr>
-        <p:spPr>
-          <a:xfrm>
-            <a:off x="822960" y="5897880"/>
-            <a:ext cx="10607040" cy="548640"/>
-          </a:xfrm>
-          <a:prstGeom prst="rect">
-            <a:avLst/>
-          </a:prstGeom>
-          <a:noFill/>
-          <a:ln/>
-        </p:spPr>
-        <p:txBody>
-          <a:bodyPr wrap="square" lIns="0" tIns="0" rIns="0" bIns="0" rtlCol="0" anchor="ctr"/>
-          <a:lstStyle/>
-          <a:p>
-            <a:pPr indent="0" marL="0">
-              <a:buNone/>
-            </a:pPr>
-            <a:r>
-              <a:rPr lang="en-US" sz="1700" b="1" dirty="0">
-                <a:solidFill>
-                  <a:srgbClr val="FFFFFF"/>
-                </a:solidFill>
-                <a:latin typeface="Calibri" pitchFamily="34" charset="0"/>
-                <a:ea typeface="Calibri" pitchFamily="34" charset="-122"/>
-                <a:cs typeface="Calibri" pitchFamily="34" charset="-120"/>
-              </a:rPr>
-              <a:t>Jetzt: </a:t>
-            </a:r>
-            <a:pPr indent="0" marL="0">
-              <a:buNone/>
-            </a:pPr>
-            <a:r>
-              <a:rPr lang="en-US" sz="1700" dirty="0">
-                <a:solidFill>
-                  <a:srgbClr val="FFFFFF"/>
-                </a:solidFill>
-                <a:latin typeface="Calibri" pitchFamily="34" charset="0"/>
-                <a:ea typeface="Calibri" pitchFamily="34" charset="-122"/>
-                <a:cs typeface="Calibri" pitchFamily="34" charset="-120"/>
-              </a:rPr>
-              <a:t>Schreibe den Merksatz mit Beispiel ab und rahme ihn rot ein.      </a:t>
-            </a:r>
-            <a:pPr indent="0" marL="0">
-              <a:buNone/>
-            </a:pPr>
-            <a:r>
-              <a:rPr lang="en-US" sz="1700" i="1" dirty="0">
-                <a:solidFill>
-                  <a:srgbClr val="CADCFC"/>
-                </a:solidFill>
-                <a:latin typeface="Calibri" pitchFamily="34" charset="0"/>
-                <a:ea typeface="Calibri" pitchFamily="34" charset="-122"/>
-                <a:cs typeface="Calibri" pitchFamily="34" charset="-120"/>
-              </a:rPr>
-              <a:t>Fertig? Stift hinlegen.</a:t>
-            </a:r>
-            <a:endParaRPr lang="en-US" sz="1700" dirty="0"/>
-          </a:p>
-        </p:txBody>
-      </p:sp>
-      <p:sp>
-        <p:nvSpPr>
-          <p:cNvPr id="16" name="Text 14"/>
-          <p:cNvSpPr txBox="1"/>
-          <p:nvPr/>
-        </p:nvSpPr>
-        <p:spPr>
-          <a:xfrm>
-            <a:off x="548640" y="6510528"/>
-            <a:ext cx="5486400" cy="228600"/>
-          </a:xfrm>
-          <a:prstGeom prst="rect">
-            <a:avLst/>
-          </a:prstGeom>
-          <a:noFill/>
-          <a:ln/>
-        </p:spPr>
-        <p:txBody>
-          <a:bodyPr wrap="square" lIns="0" tIns="0" rIns="0" bIns="0" rtlCol="0" anchor="t"/>
-          <a:lstStyle/>
-          <a:p>
-            <a:pPr indent="0" marL="0">
-              <a:buNone/>
-            </a:pPr>
-            <a:r>
-              <a:rPr lang="en-US" sz="1000" dirty="0">
-                <a:solidFill>
-                  <a:srgbClr val="5B6B8C"/>
-                </a:solidFill>
-                <a:latin typeface="Calibri" pitchFamily="34" charset="0"/>
-                <a:ea typeface="Calibri" pitchFamily="34" charset="-122"/>
-                <a:cs typeface="Calibri" pitchFamily="34" charset="-120"/>
-              </a:rPr>
-              <a:t>Absolutismus · Wiederholung · Geschichte 8</a:t>
-            </a:r>
-            <a:endParaRPr lang="en-US" sz="1000" dirty="0"/>
-          </a:p>
-        </p:txBody>
-      </p:sp>
-      <p:sp>
-        <p:nvSpPr>
-          <p:cNvPr id="17" name="Text 15"/>
-          <p:cNvSpPr txBox="1"/>
-          <p:nvPr/>
-        </p:nvSpPr>
-        <p:spPr>
-          <a:xfrm>
-            <a:off x="11155680" y="6510528"/>
-            <a:ext cx="457200" cy="228600"/>
-          </a:xfrm>
-          <a:prstGeom prst="rect">
-            <a:avLst/>
-          </a:prstGeom>
-          <a:noFill/>
-          <a:ln/>
-        </p:spPr>
-        <p:txBody>
-          <a:bodyPr wrap="square" lIns="0" tIns="0" rIns="0" bIns="0" rtlCol="0" anchor="t"/>
-          <a:lstStyle/>
-          <a:p>
-            <a:pPr algn="r" indent="0" marL="0">
-              <a:buNone/>
-            </a:pPr>
-            <a:r>
-              <a:rPr lang="en-US" sz="1000" dirty="0">
-                <a:solidFill>
-                  <a:srgbClr val="5B6B8C"/>
-                </a:solidFill>
-                <a:latin typeface="Calibri" pitchFamily="34" charset="0"/>
-                <a:ea typeface="Calibri" pitchFamily="34" charset="-122"/>
-                <a:cs typeface="Calibri" pitchFamily="34" charset="-120"/>
-              </a:rPr>
-              <a:t>4</a:t>
-            </a:r>
-            <a:endParaRPr lang="en-US" sz="1000" dirty="0"/>
+              <a:t>Beamte · Glaube · Söldner · Merkantilismus · Gottesgnadentum · Versailles · Steuerfreiheit · Zölle · stehendes · 400.000 · Drittel · absoluter · Intendanten · Parlament</a:t>
+            </a:r>
+            <a:endParaRPr lang="en-US" sz="2000" dirty="0"/>
           </a:p>
         </p:txBody>
       </p:sp>
@@ -6734,7 +6592,7 @@
                 <a:ea typeface="Calibri" pitchFamily="34" charset="-122"/>
                 <a:cs typeface="Calibri" pitchFamily="34" charset="-120"/>
               </a:rPr>
-              <a:t>ÜBUNG 1</a:t>
+              <a:t>EINSTIEG · OHNE HEFT</a:t>
             </a:r>
             <a:endParaRPr lang="en-US" sz="1300" dirty="0"/>
           </a:p>
@@ -6773,7 +6631,7 @@
                 <a:ea typeface="Cambria" pitchFamily="34" charset="-122"/>
                 <a:cs typeface="Cambria" pitchFamily="34" charset="-120"/>
               </a:rPr>
-              <a:t>Absolutismus – ja oder nein?</a:t>
+              <a:t>Wahr oder falsch?</a:t>
             </a:r>
             <a:endParaRPr lang="en-US" sz="3400" dirty="0"/>
           </a:p>
@@ -6893,7 +6751,7 @@
                 <a:ea typeface="Calibri" pitchFamily="34" charset="-122"/>
                 <a:cs typeface="Calibri" pitchFamily="34" charset="-120"/>
               </a:rPr>
-              <a:t>Schreibe Ü1 an den Rand.</a:t>
+              <a:t>Lies die vier Behauptungen. Entscheide still: wahr oder falsch?</a:t>
             </a:r>
             <a:endParaRPr lang="en-US" sz="2100" dirty="0"/>
           </a:p>
@@ -6991,7 +6849,7 @@
                 <a:ea typeface="Calibri" pitchFamily="34" charset="-122"/>
                 <a:cs typeface="Calibri" pitchFamily="34" charset="-120"/>
               </a:rPr>
-              <a:t>Schreibe Nummer + „Absolutismus“ oder „kein Absolutismus“.</a:t>
+              <a:t>Melde dich: Nenne deine Entscheidung und begründe sie.</a:t>
             </a:r>
             <a:endParaRPr lang="en-US" sz="2100" dirty="0"/>
           </a:p>
@@ -7089,7 +6947,7 @@
                 <a:ea typeface="Calibri" pitchFamily="34" charset="-122"/>
                 <a:cs typeface="Calibri" pitchFamily="34" charset="-120"/>
               </a:rPr>
-              <a:t>Begründe mit dem Test: Kann jemand den König stoppen?</a:t>
+              <a:t>Bei „falsch“: Verbessere die Aussage.</a:t>
             </a:r>
             <a:endParaRPr lang="en-US" sz="2100" dirty="0"/>
           </a:p>
@@ -7164,7 +7022,7 @@
                 <a:ea typeface="Calibri" pitchFamily="34" charset="-122"/>
                 <a:cs typeface="Calibri" pitchFamily="34" charset="-120"/>
               </a:rPr>
-              <a:t>4 Minuten · allein · leise      </a:t>
+              <a:t>4 Minuten · gemeinsam · mündlich      </a:t>
             </a:r>
             <a:pPr indent="0" marL="0">
               <a:buNone/>
@@ -7178,7 +7036,7 @@
                 <a:ea typeface="Calibri" pitchFamily="34" charset="-122"/>
                 <a:cs typeface="Calibri" pitchFamily="34" charset="-120"/>
               </a:rPr>
-              <a:t>Fertig? Stift hinlegen und noch einmal durchlesen.</a:t>
+              <a:t>Wer begründet, bekommt das Wort.</a:t>
             </a:r>
             <a:endParaRPr lang="en-US" sz="1700" dirty="0"/>
           </a:p>
@@ -7376,7 +7234,7 @@
                 <a:ea typeface="Cambria" pitchFamily="34" charset="-122"/>
                 <a:cs typeface="Cambria" pitchFamily="34" charset="-120"/>
               </a:rPr>
-              <a:t>Der König entscheidet allein über Gesetze, Krieg und Steuern.</a:t>
+              <a:t>Der Dritte Stand war mit Abstand der größte Stand.</a:t>
             </a:r>
             <a:endParaRPr lang="en-US" sz="2200" dirty="0"/>
           </a:p>
@@ -7496,7 +7354,7 @@
                 <a:ea typeface="Cambria" pitchFamily="34" charset="-122"/>
                 <a:cs typeface="Cambria" pitchFamily="34" charset="-120"/>
               </a:rPr>
-              <a:t>Ein Parlament kann Steuererhöhungen des Königs verbieten.</a:t>
+              <a:t>Der Adel musste hohe Steuern an den König zahlen.</a:t>
             </a:r>
             <a:endParaRPr lang="en-US" sz="2200" dirty="0"/>
           </a:p>
@@ -7616,7 +7474,7 @@
                 <a:ea typeface="Cambria" pitchFamily="34" charset="-122"/>
                 <a:cs typeface="Cambria" pitchFamily="34" charset="-120"/>
               </a:rPr>
-              <a:t>Beamte handeln im Namen des Königs und müssen ihm gehorchen.</a:t>
+              <a:t>Ludwig XIV. verzichtete auf Söldner und baute ein stehendes Heer auf.</a:t>
             </a:r>
             <a:endParaRPr lang="en-US" sz="2200" dirty="0"/>
           </a:p>
@@ -7736,7 +7594,7 @@
                 <a:ea typeface="Cambria" pitchFamily="34" charset="-122"/>
                 <a:cs typeface="Cambria" pitchFamily="34" charset="-120"/>
               </a:rPr>
-              <a:t>Die Bürger wählen alle vier Jahre ihre Regierung.</a:t>
+              <a:t>Ludwig XIV. erlaubte den Protestanten die freie Religionsausübung.</a:t>
             </a:r>
             <a:endParaRPr lang="en-US" sz="2200" dirty="0"/>
           </a:p>
@@ -7846,7 +7704,7 @@
                 <a:ea typeface="Cambria" pitchFamily="34" charset="-122"/>
                 <a:cs typeface="Cambria" pitchFamily="34" charset="-120"/>
               </a:rPr>
-              <a:t>Die fünf Säulen des Absolutismus</a:t>
+              <a:t>Absolutismus</a:t>
             </a:r>
             <a:endParaRPr lang="en-US" sz="3400" dirty="0"/>
           </a:p>
@@ -7904,7 +7762,7 @@
               <a:buNone/>
             </a:pPr>
             <a:r>
-              <a:rPr lang="en-US" sz="2000" dirty="0">
+              <a:rPr lang="en-US" sz="2100" b="1" dirty="0">
                 <a:solidFill>
                   <a:srgbClr val="1E2761"/>
                 </a:solidFill>
@@ -7912,13 +7770,13 @@
                 <a:ea typeface="Cambria" pitchFamily="34" charset="-122"/>
                 <a:cs typeface="Cambria" pitchFamily="34" charset="-120"/>
               </a:rPr>
-              <a:t>Ludwig XIV. sicherte seine Macht auf </a:t>
-            </a:r>
-            <a:pPr indent="0" marL="0">
-              <a:buNone/>
-            </a:pPr>
-            <a:r>
-              <a:rPr lang="en-US" sz="2000" b="1" dirty="0">
+              <a:t>Absolutismus</a:t>
+            </a:r>
+            <a:pPr indent="0" marL="0">
+              <a:buNone/>
+            </a:pPr>
+            <a:r>
+              <a:rPr lang="en-US" sz="2100" dirty="0">
                 <a:solidFill>
                   <a:srgbClr val="1E2761"/>
                 </a:solidFill>
@@ -7926,13 +7784,13 @@
                 <a:ea typeface="Cambria" pitchFamily="34" charset="-122"/>
                 <a:cs typeface="Cambria" pitchFamily="34" charset="-120"/>
               </a:rPr>
-              <a:t>fünf Säulen</a:t>
-            </a:r>
-            <a:pPr indent="0" marL="0">
-              <a:buNone/>
-            </a:pPr>
-            <a:r>
-              <a:rPr lang="en-US" sz="2000" dirty="0">
+              <a:t> war eine Herrschaftsform in Europa im </a:t>
+            </a:r>
+            <a:pPr indent="0" marL="0">
+              <a:buNone/>
+            </a:pPr>
+            <a:r>
+              <a:rPr lang="en-US" sz="2100" b="1" dirty="0">
                 <a:solidFill>
                   <a:srgbClr val="1E2761"/>
                 </a:solidFill>
@@ -7940,13 +7798,13 @@
                 <a:ea typeface="Cambria" pitchFamily="34" charset="-122"/>
                 <a:cs typeface="Cambria" pitchFamily="34" charset="-120"/>
               </a:rPr>
-              <a:t>: </a:t>
-            </a:r>
-            <a:pPr indent="0" marL="0">
-              <a:buNone/>
-            </a:pPr>
-            <a:r>
-              <a:rPr lang="en-US" sz="2000" b="1" dirty="0">
+              <a:t>17. und 18. Jahrhundert</a:t>
+            </a:r>
+            <a:pPr indent="0" marL="0">
+              <a:buNone/>
+            </a:pPr>
+            <a:r>
+              <a:rPr lang="en-US" sz="2100" dirty="0">
                 <a:solidFill>
                   <a:srgbClr val="1E2761"/>
                 </a:solidFill>
@@ -7954,13 +7812,13 @@
                 <a:ea typeface="Cambria" pitchFamily="34" charset="-122"/>
                 <a:cs typeface="Cambria" pitchFamily="34" charset="-120"/>
               </a:rPr>
-              <a:t>1</a:t>
-            </a:r>
-            <a:pPr indent="0" marL="0">
-              <a:buNone/>
-            </a:pPr>
-            <a:r>
-              <a:rPr lang="en-US" sz="2000" dirty="0">
+              <a:t>, in der ein einzelner Monarch (König oder Fürst) </a:t>
+            </a:r>
+            <a:pPr indent="0" marL="0">
+              <a:buNone/>
+            </a:pPr>
+            <a:r>
+              <a:rPr lang="en-US" sz="2100" b="1" dirty="0">
                 <a:solidFill>
                   <a:srgbClr val="1E2761"/>
                 </a:solidFill>
@@ -7968,13 +7826,13 @@
                 <a:ea typeface="Cambria" pitchFamily="34" charset="-122"/>
                 <a:cs typeface="Cambria" pitchFamily="34" charset="-120"/>
               </a:rPr>
-              <a:t> Verwaltung und Justiz · </a:t>
-            </a:r>
-            <a:pPr indent="0" marL="0">
-              <a:buNone/>
-            </a:pPr>
-            <a:r>
-              <a:rPr lang="en-US" sz="2000" b="1" dirty="0">
+              <a:t>uneingeschränkt (absolut)</a:t>
+            </a:r>
+            <a:pPr indent="0" marL="0">
+              <a:buNone/>
+            </a:pPr>
+            <a:r>
+              <a:rPr lang="en-US" sz="2100" dirty="0">
                 <a:solidFill>
                   <a:srgbClr val="1E2761"/>
                 </a:solidFill>
@@ -7982,107 +7840,9 @@
                 <a:ea typeface="Cambria" pitchFamily="34" charset="-122"/>
                 <a:cs typeface="Cambria" pitchFamily="34" charset="-120"/>
               </a:rPr>
-              <a:t>2</a:t>
-            </a:r>
-            <a:pPr indent="0" marL="0">
-              <a:buNone/>
-            </a:pPr>
-            <a:r>
-              <a:rPr lang="en-US" sz="2000" dirty="0">
-                <a:solidFill>
-                  <a:srgbClr val="1E2761"/>
-                </a:solidFill>
-                <a:latin typeface="Cambria" pitchFamily="34" charset="0"/>
-                <a:ea typeface="Cambria" pitchFamily="34" charset="-122"/>
-                <a:cs typeface="Cambria" pitchFamily="34" charset="-120"/>
-              </a:rPr>
-              <a:t> Adel und Hof von Versailles · </a:t>
-            </a:r>
-            <a:pPr indent="0" marL="0">
-              <a:buNone/>
-            </a:pPr>
-            <a:r>
-              <a:rPr lang="en-US" sz="2000" b="1" dirty="0">
-                <a:solidFill>
-                  <a:srgbClr val="1E2761"/>
-                </a:solidFill>
-                <a:latin typeface="Cambria" pitchFamily="34" charset="0"/>
-                <a:ea typeface="Cambria" pitchFamily="34" charset="-122"/>
-                <a:cs typeface="Cambria" pitchFamily="34" charset="-120"/>
-              </a:rPr>
-              <a:t>3</a:t>
-            </a:r>
-            <a:pPr indent="0" marL="0">
-              <a:buNone/>
-            </a:pPr>
-            <a:r>
-              <a:rPr lang="en-US" sz="2000" dirty="0">
-                <a:solidFill>
-                  <a:srgbClr val="1E2761"/>
-                </a:solidFill>
-                <a:latin typeface="Cambria" pitchFamily="34" charset="0"/>
-                <a:ea typeface="Cambria" pitchFamily="34" charset="-122"/>
-                <a:cs typeface="Cambria" pitchFamily="34" charset="-120"/>
-              </a:rPr>
-              <a:t> Wirtschaft (Merkantilismus) · </a:t>
-            </a:r>
-            <a:pPr indent="0" marL="0">
-              <a:buNone/>
-            </a:pPr>
-            <a:r>
-              <a:rPr lang="en-US" sz="2000" b="1" dirty="0">
-                <a:solidFill>
-                  <a:srgbClr val="1E2761"/>
-                </a:solidFill>
-                <a:latin typeface="Cambria" pitchFamily="34" charset="0"/>
-                <a:ea typeface="Cambria" pitchFamily="34" charset="-122"/>
-                <a:cs typeface="Cambria" pitchFamily="34" charset="-120"/>
-              </a:rPr>
-              <a:t>4</a:t>
-            </a:r>
-            <a:pPr indent="0" marL="0">
-              <a:buNone/>
-            </a:pPr>
-            <a:r>
-              <a:rPr lang="en-US" sz="2000" dirty="0">
-                <a:solidFill>
-                  <a:srgbClr val="1E2761"/>
-                </a:solidFill>
-                <a:latin typeface="Cambria" pitchFamily="34" charset="0"/>
-                <a:ea typeface="Cambria" pitchFamily="34" charset="-122"/>
-                <a:cs typeface="Cambria" pitchFamily="34" charset="-120"/>
-              </a:rPr>
-              <a:t> Religion (Gottesgnadentum) · </a:t>
-            </a:r>
-            <a:pPr indent="0" marL="0">
-              <a:buNone/>
-            </a:pPr>
-            <a:r>
-              <a:rPr lang="en-US" sz="2000" b="1" dirty="0">
-                <a:solidFill>
-                  <a:srgbClr val="1E2761"/>
-                </a:solidFill>
-                <a:latin typeface="Cambria" pitchFamily="34" charset="0"/>
-                <a:ea typeface="Cambria" pitchFamily="34" charset="-122"/>
-                <a:cs typeface="Cambria" pitchFamily="34" charset="-120"/>
-              </a:rPr>
-              <a:t>5</a:t>
-            </a:r>
-            <a:pPr indent="0" marL="0">
-              <a:buNone/>
-            </a:pPr>
-            <a:r>
-              <a:rPr lang="en-US" sz="2000" dirty="0">
-                <a:solidFill>
-                  <a:srgbClr val="1E2761"/>
-                </a:solidFill>
-                <a:latin typeface="Cambria" pitchFamily="34" charset="0"/>
-                <a:ea typeface="Cambria" pitchFamily="34" charset="-122"/>
-                <a:cs typeface="Cambria" pitchFamily="34" charset="-120"/>
-              </a:rPr>
-              <a:t> Heer (stehendes Heer).</a:t>
-            </a:r>
-            <a:endParaRPr lang="en-US" sz="2000" dirty="0"/>
+              <a:t> herrschte.</a:t>
+            </a:r>
+            <a:endParaRPr lang="en-US" sz="2100" dirty="0"/>
           </a:p>
         </p:txBody>
       </p:sp>
@@ -8147,141 +7907,15 @@
               <a:buNone/>
             </a:pPr>
             <a:r>
-              <a:rPr lang="en-US" sz="1900" b="1" dirty="0">
-                <a:solidFill>
-                  <a:srgbClr val="D9534F"/>
+              <a:rPr lang="en-US" sz="1900" dirty="0">
+                <a:solidFill>
+                  <a:srgbClr val="1E2761"/>
                 </a:solidFill>
                 <a:latin typeface="Cambria" pitchFamily="34" charset="0"/>
                 <a:ea typeface="Cambria" pitchFamily="34" charset="-122"/>
                 <a:cs typeface="Cambria" pitchFamily="34" charset="-120"/>
               </a:rPr>
-              <a:t>Verwaltung</a:t>
-            </a:r>
-            <a:pPr indent="0" marL="0">
-              <a:buNone/>
-            </a:pPr>
-            <a:r>
-              <a:rPr lang="en-US" sz="1900" dirty="0">
-                <a:solidFill>
-                  <a:srgbClr val="1E2761"/>
-                </a:solidFill>
-                <a:latin typeface="Cambria" pitchFamily="34" charset="0"/>
-                <a:ea typeface="Cambria" pitchFamily="34" charset="-122"/>
-                <a:cs typeface="Cambria" pitchFamily="34" charset="-120"/>
-              </a:rPr>
-              <a:t> kontrolliert das Land · </a:t>
-            </a:r>
-            <a:pPr indent="0" marL="0">
-              <a:buNone/>
-            </a:pPr>
-            <a:r>
-              <a:rPr lang="en-US" sz="1900" b="1" dirty="0">
-                <a:solidFill>
-                  <a:srgbClr val="D9534F"/>
-                </a:solidFill>
-                <a:latin typeface="Cambria" pitchFamily="34" charset="0"/>
-                <a:ea typeface="Cambria" pitchFamily="34" charset="-122"/>
-                <a:cs typeface="Cambria" pitchFamily="34" charset="-120"/>
-              </a:rPr>
-              <a:t>Hof</a:t>
-            </a:r>
-            <a:pPr indent="0" marL="0">
-              <a:buNone/>
-            </a:pPr>
-            <a:r>
-              <a:rPr lang="en-US" sz="1900" dirty="0">
-                <a:solidFill>
-                  <a:srgbClr val="1E2761"/>
-                </a:solidFill>
-                <a:latin typeface="Cambria" pitchFamily="34" charset="0"/>
-                <a:ea typeface="Cambria" pitchFamily="34" charset="-122"/>
-                <a:cs typeface="Cambria" pitchFamily="34" charset="-120"/>
-              </a:rPr>
-              <a:t> bindet den Adel · </a:t>
-            </a:r>
-            <a:pPr indent="0" marL="0">
-              <a:buNone/>
-            </a:pPr>
-            <a:r>
-              <a:rPr lang="en-US" sz="1900" b="1" dirty="0">
-                <a:solidFill>
-                  <a:srgbClr val="D9534F"/>
-                </a:solidFill>
-                <a:latin typeface="Cambria" pitchFamily="34" charset="0"/>
-                <a:ea typeface="Cambria" pitchFamily="34" charset="-122"/>
-                <a:cs typeface="Cambria" pitchFamily="34" charset="-120"/>
-              </a:rPr>
-              <a:t>Wirtschaft</a:t>
-            </a:r>
-            <a:pPr indent="0" marL="0">
-              <a:buNone/>
-            </a:pPr>
-            <a:r>
-              <a:rPr lang="en-US" sz="1900" dirty="0">
-                <a:solidFill>
-                  <a:srgbClr val="1E2761"/>
-                </a:solidFill>
-                <a:latin typeface="Cambria" pitchFamily="34" charset="0"/>
-                <a:ea typeface="Cambria" pitchFamily="34" charset="-122"/>
-                <a:cs typeface="Cambria" pitchFamily="34" charset="-120"/>
-              </a:rPr>
-              <a:t> liefert Geld · </a:t>
-            </a:r>
-            <a:pPr indent="0" marL="0">
-              <a:buNone/>
-            </a:pPr>
-            <a:r>
-              <a:rPr lang="en-US" sz="1900" b="1" dirty="0">
-                <a:solidFill>
-                  <a:srgbClr val="D9534F"/>
-                </a:solidFill>
-                <a:latin typeface="Cambria" pitchFamily="34" charset="0"/>
-                <a:ea typeface="Cambria" pitchFamily="34" charset="-122"/>
-                <a:cs typeface="Cambria" pitchFamily="34" charset="-120"/>
-              </a:rPr>
-              <a:t>Religion</a:t>
-            </a:r>
-            <a:pPr indent="0" marL="0">
-              <a:buNone/>
-            </a:pPr>
-            <a:r>
-              <a:rPr lang="en-US" sz="1900" dirty="0">
-                <a:solidFill>
-                  <a:srgbClr val="1E2761"/>
-                </a:solidFill>
-                <a:latin typeface="Cambria" pitchFamily="34" charset="0"/>
-                <a:ea typeface="Cambria" pitchFamily="34" charset="-122"/>
-                <a:cs typeface="Cambria" pitchFamily="34" charset="-120"/>
-              </a:rPr>
-              <a:t> begründet die Macht · </a:t>
-            </a:r>
-            <a:pPr indent="0" marL="0">
-              <a:buNone/>
-            </a:pPr>
-            <a:r>
-              <a:rPr lang="en-US" sz="1900" b="1" dirty="0">
-                <a:solidFill>
-                  <a:srgbClr val="D9534F"/>
-                </a:solidFill>
-                <a:latin typeface="Cambria" pitchFamily="34" charset="0"/>
-                <a:ea typeface="Cambria" pitchFamily="34" charset="-122"/>
-                <a:cs typeface="Cambria" pitchFamily="34" charset="-120"/>
-              </a:rPr>
-              <a:t>Heer</a:t>
-            </a:r>
-            <a:pPr indent="0" marL="0">
-              <a:buNone/>
-            </a:pPr>
-            <a:r>
-              <a:rPr lang="en-US" sz="1900" dirty="0">
-                <a:solidFill>
-                  <a:srgbClr val="1E2761"/>
-                </a:solidFill>
-                <a:latin typeface="Cambria" pitchFamily="34" charset="0"/>
-                <a:ea typeface="Cambria" pitchFamily="34" charset="-122"/>
-                <a:cs typeface="Cambria" pitchFamily="34" charset="-120"/>
-              </a:rPr>
-              <a:t> setzt sie durch</a:t>
+              <a:t>Ludwig XIV. verkündet 1661: „Ich regiere jetzt selbst.“</a:t>
             </a:r>
             <a:endParaRPr lang="en-US" sz="1900" dirty="0"/>
           </a:p>
@@ -8381,35 +8015,7 @@
                 <a:ea typeface="Calibri" pitchFamily="34" charset="-122"/>
                 <a:cs typeface="Calibri" pitchFamily="34" charset="-120"/>
               </a:rPr>
-              <a:t>Im Test sollst du die Säulen nennen </a:t>
-            </a:r>
-            <a:pPr indent="0" marL="0">
-              <a:buNone/>
-            </a:pPr>
-            <a:r>
-              <a:rPr lang="en-US" sz="1900" b="1" dirty="0">
-                <a:solidFill>
-                  <a:srgbClr val="1E2761"/>
-                </a:solidFill>
-                <a:latin typeface="Calibri" pitchFamily="34" charset="0"/>
-                <a:ea typeface="Calibri" pitchFamily="34" charset="-122"/>
-                <a:cs typeface="Calibri" pitchFamily="34" charset="-120"/>
-              </a:rPr>
-              <a:t>und</a:t>
-            </a:r>
-            <a:pPr indent="0" marL="0">
-              <a:buNone/>
-            </a:pPr>
-            <a:r>
-              <a:rPr lang="en-US" sz="1900" dirty="0">
-                <a:solidFill>
-                  <a:srgbClr val="1E2761"/>
-                </a:solidFill>
-                <a:latin typeface="Calibri" pitchFamily="34" charset="0"/>
-                <a:ea typeface="Calibri" pitchFamily="34" charset="-122"/>
-                <a:cs typeface="Calibri" pitchFamily="34" charset="-120"/>
-              </a:rPr>
-              <a:t> erklären, wie der König damit seine Macht sichert.</a:t>
+              <a:t>Der Begriff ordnet eine ganze Epoche ein und ist im Test die Grundlage für alle weiteren Fragen.</a:t>
             </a:r>
             <a:endParaRPr lang="en-US" sz="1900" dirty="0"/>
           </a:p>
@@ -8509,7 +8115,7 @@
                 <a:ea typeface="Calibri" pitchFamily="34" charset="-122"/>
                 <a:cs typeface="Calibri" pitchFamily="34" charset="-120"/>
               </a:rPr>
-              <a:t>Bei jeder Säule fragen: </a:t>
+              <a:t>Kann jemand den König stoppen (Parlament, Verfassung, Stände)? </a:t>
             </a:r>
             <a:pPr indent="0" marL="0">
               <a:buNone/>
@@ -8523,7 +8129,21 @@
                 <a:ea typeface="Calibri" pitchFamily="34" charset="-122"/>
                 <a:cs typeface="Calibri" pitchFamily="34" charset="-120"/>
               </a:rPr>
-              <a:t>Was sichert der König damit?</a:t>
+              <a:t>Nein</a:t>
+            </a:r>
+            <a:pPr indent="0" marL="0">
+              <a:buNone/>
+            </a:pPr>
+            <a:r>
+              <a:rPr lang="en-US" sz="1900" dirty="0">
+                <a:solidFill>
+                  <a:srgbClr val="1E2761"/>
+                </a:solidFill>
+                <a:latin typeface="Calibri" pitchFamily="34" charset="0"/>
+                <a:ea typeface="Calibri" pitchFamily="34" charset="-122"/>
+                <a:cs typeface="Calibri" pitchFamily="34" charset="-120"/>
+              </a:rPr>
+              <a:t> → Absolutismus.</a:t>
             </a:r>
             <a:endParaRPr lang="en-US" sz="1900" dirty="0"/>
           </a:p>
@@ -8761,7 +8381,7 @@
                 <a:ea typeface="Calibri" pitchFamily="34" charset="-122"/>
                 <a:cs typeface="Calibri" pitchFamily="34" charset="-120"/>
               </a:rPr>
-              <a:t>ÜBUNG 2 · ARBEITSBLATT</a:t>
+              <a:t>ÜBUNG 2</a:t>
             </a:r>
             <a:endParaRPr lang="en-US" sz="1300" dirty="0"/>
           </a:p>
@@ -8800,7 +8420,7 @@
                 <a:ea typeface="Cambria" pitchFamily="34" charset="-122"/>
                 <a:cs typeface="Cambria" pitchFamily="34" charset="-120"/>
               </a:rPr>
-              <a:t>Lückentext: Die fünf Säulen</a:t>
+              <a:t>Absolutismus – ja oder nein?</a:t>
             </a:r>
             <a:endParaRPr lang="en-US" sz="3400" dirty="0"/>
           </a:p>
@@ -8815,11 +8435,11 @@
         <p:spPr>
           <a:xfrm>
             <a:off x="548640" y="1417320"/>
-            <a:ext cx="11109960" cy="1975104"/>
+            <a:ext cx="11109960" cy="1655064"/>
           </a:xfrm>
           <a:prstGeom prst="roundRect">
             <a:avLst>
-              <a:gd name="adj" fmla="val 3704"/>
+              <a:gd name="adj" fmla="val 4420"/>
             </a:avLst>
           </a:prstGeom>
           <a:solidFill>
@@ -8920,7 +8540,7 @@
                 <a:ea typeface="Calibri" pitchFamily="34" charset="-122"/>
                 <a:cs typeface="Calibri" pitchFamily="34" charset="-120"/>
               </a:rPr>
-              <a:t>Schreibe Ü2 oben auf das Arbeitsblatt.</a:t>
+              <a:t>Schreibe Ü2 an den Rand.</a:t>
             </a:r>
             <a:endParaRPr lang="en-US" sz="2100" dirty="0"/>
           </a:p>
@@ -8994,7 +8614,7 @@
         <p:spPr>
           <a:xfrm>
             <a:off x="1280160" y="2039112"/>
-            <a:ext cx="10241280" cy="731520"/>
+            <a:ext cx="10241280" cy="411480"/>
           </a:xfrm>
           <a:prstGeom prst="rect">
             <a:avLst/>
@@ -9018,7 +8638,7 @@
                 <a:ea typeface="Calibri" pitchFamily="34" charset="-122"/>
                 <a:cs typeface="Calibri" pitchFamily="34" charset="-120"/>
               </a:rPr>
-              <a:t>Lies den Text einmal ganz. Ergänze dann die 12 Lücken mit dem Wortspeicher.</a:t>
+              <a:t>Schreibe Nummer + „Absolutismus“ oder „kein Absolutismus“.</a:t>
             </a:r>
             <a:endParaRPr lang="en-US" sz="2100" dirty="0"/>
           </a:p>
@@ -9032,7 +8652,7 @@
         </p:nvSpPr>
         <p:spPr>
           <a:xfrm>
-            <a:off x="731520" y="2857500"/>
+            <a:off x="731520" y="2537460"/>
             <a:ext cx="384048" cy="384048"/>
           </a:xfrm>
           <a:prstGeom prst="ellipse">
@@ -9052,7 +8672,7 @@
         </p:nvSpPr>
         <p:spPr>
           <a:xfrm>
-            <a:off x="731520" y="2857500"/>
+            <a:off x="731520" y="2537460"/>
             <a:ext cx="384048" cy="384048"/>
           </a:xfrm>
           <a:prstGeom prst="rect">
@@ -9091,7 +8711,7 @@
         </p:nvSpPr>
         <p:spPr>
           <a:xfrm>
-            <a:off x="1280160" y="2843784"/>
+            <a:off x="1280160" y="2523744"/>
             <a:ext cx="10241280" cy="411480"/>
           </a:xfrm>
           <a:prstGeom prst="rect">
@@ -9116,7 +8736,7 @@
                 <a:ea typeface="Calibri" pitchFamily="34" charset="-122"/>
                 <a:cs typeface="Calibri" pitchFamily="34" charset="-120"/>
               </a:rPr>
-              <a:t>Streiche jedes benutzte Wort durch. Zwei Wörter passen nicht.</a:t>
+              <a:t>Begründe mit dem Test: Kann jemand den König stoppen?</a:t>
             </a:r>
             <a:endParaRPr lang="en-US" sz="2100" dirty="0"/>
           </a:p>
@@ -9191,7 +8811,7 @@
                 <a:ea typeface="Calibri" pitchFamily="34" charset="-122"/>
                 <a:cs typeface="Calibri" pitchFamily="34" charset="-120"/>
               </a:rPr>
-              <a:t>6 Minuten · allein · leise      </a:t>
+              <a:t>4 Minuten · allein · leise      </a:t>
             </a:r>
             <a:pPr indent="0" marL="0">
               <a:buNone/>
@@ -9205,7 +8825,7 @@
                 <a:ea typeface="Calibri" pitchFamily="34" charset="-122"/>
                 <a:cs typeface="Calibri" pitchFamily="34" charset="-120"/>
               </a:rPr>
-              <a:t>Fertig? Stift hinlegen. Schnelle: ★-Aufgabe.</a:t>
+              <a:t>Fertig? Stift hinlegen und noch einmal durchlesen.</a:t>
             </a:r>
             <a:endParaRPr lang="en-US" sz="1700" dirty="0"/>
           </a:p>
@@ -9297,12 +8917,12 @@
         </p:nvSpPr>
         <p:spPr>
           <a:xfrm>
-            <a:off x="548640" y="3758184"/>
-            <a:ext cx="11109960" cy="1463040"/>
+            <a:off x="548640" y="3346704"/>
+            <a:ext cx="11109960" cy="530352"/>
           </a:xfrm>
           <a:prstGeom prst="roundRect">
             <a:avLst>
-              <a:gd name="adj" fmla="val 5000"/>
+              <a:gd name="adj" fmla="val 13793"/>
             </a:avLst>
           </a:prstGeom>
           <a:solidFill>
@@ -9313,69 +8933,209 @@
       </p:sp>
       <p:sp>
         <p:nvSpPr>
-          <p:cNvPr id="20" name="Text 17"/>
-          <p:cNvSpPr txBox="1"/>
-          <p:nvPr/>
-        </p:nvSpPr>
-        <p:spPr>
-          <a:xfrm>
-            <a:off x="822960" y="3867912"/>
-            <a:ext cx="3657600" cy="320040"/>
-          </a:xfrm>
-          <a:prstGeom prst="rect">
-            <a:avLst/>
-          </a:prstGeom>
-          <a:noFill/>
-          <a:ln/>
-        </p:spPr>
-        <p:txBody>
-          <a:bodyPr wrap="square" lIns="0" tIns="0" rIns="0" bIns="0" rtlCol="0" anchor="t"/>
-          <a:lstStyle/>
-          <a:p>
-            <a:pPr indent="0" marL="0">
-              <a:buNone/>
-            </a:pPr>
-            <a:r>
-              <a:rPr lang="en-US" sz="1700" b="1" dirty="0">
-                <a:solidFill>
-                  <a:srgbClr val="D9534F"/>
+          <p:cNvPr id="20" name="Shape 17"/>
+          <p:cNvSpPr/>
+          <p:nvPr/>
+        </p:nvSpPr>
+        <p:spPr>
+          <a:xfrm>
+            <a:off x="685800" y="3429000"/>
+            <a:ext cx="365760" cy="365760"/>
+          </a:xfrm>
+          <a:prstGeom prst="ellipse">
+            <a:avLst/>
+          </a:prstGeom>
+          <a:solidFill>
+            <a:srgbClr val="D9534F"/>
+          </a:solidFill>
+          <a:ln/>
+        </p:spPr>
+      </p:sp>
+      <p:sp>
+        <p:nvSpPr>
+          <p:cNvPr id="21" name="Text 18"/>
+          <p:cNvSpPr txBox="1"/>
+          <p:nvPr/>
+        </p:nvSpPr>
+        <p:spPr>
+          <a:xfrm>
+            <a:off x="685800" y="3429000"/>
+            <a:ext cx="365760" cy="365760"/>
+          </a:xfrm>
+          <a:prstGeom prst="rect">
+            <a:avLst/>
+          </a:prstGeom>
+          <a:noFill/>
+          <a:ln/>
+        </p:spPr>
+        <p:txBody>
+          <a:bodyPr wrap="square" lIns="0" tIns="0" rIns="0" bIns="0" rtlCol="0" anchor="ctr"/>
+          <a:lstStyle/>
+          <a:p>
+            <a:pPr algn="ctr" indent="0" marL="0">
+              <a:buNone/>
+            </a:pPr>
+            <a:r>
+              <a:rPr lang="en-US" sz="1800" b="1" dirty="0">
+                <a:solidFill>
+                  <a:srgbClr val="FFFFFF"/>
+                </a:solidFill>
+                <a:latin typeface="Calibri" pitchFamily="34" charset="0"/>
+                <a:ea typeface="Calibri" pitchFamily="34" charset="-122"/>
+                <a:cs typeface="Calibri" pitchFamily="34" charset="-120"/>
+              </a:rPr>
+              <a:t>1</a:t>
+            </a:r>
+            <a:endParaRPr lang="en-US" sz="1800" dirty="0"/>
+          </a:p>
+        </p:txBody>
+      </p:sp>
+      <p:sp>
+        <p:nvSpPr>
+          <p:cNvPr id="22" name="Text 19"/>
+          <p:cNvSpPr txBox="1"/>
+          <p:nvPr/>
+        </p:nvSpPr>
+        <p:spPr>
+          <a:xfrm>
+            <a:off x="1280160" y="3346704"/>
+            <a:ext cx="10241280" cy="530352"/>
+          </a:xfrm>
+          <a:prstGeom prst="rect">
+            <a:avLst/>
+          </a:prstGeom>
+          <a:noFill/>
+          <a:ln/>
+        </p:spPr>
+        <p:txBody>
+          <a:bodyPr wrap="square" lIns="0" tIns="0" rIns="0" bIns="0" rtlCol="0" anchor="ctr"/>
+          <a:lstStyle/>
+          <a:p>
+            <a:pPr indent="0" marL="0">
+              <a:buNone/>
+            </a:pPr>
+            <a:r>
+              <a:rPr lang="en-US" sz="2200" dirty="0">
+                <a:solidFill>
+                  <a:srgbClr val="1E2761"/>
                 </a:solidFill>
                 <a:latin typeface="Cambria" pitchFamily="34" charset="0"/>
                 <a:ea typeface="Cambria" pitchFamily="34" charset="-122"/>
                 <a:cs typeface="Cambria" pitchFamily="34" charset="-120"/>
               </a:rPr>
-              <a:t>Wortspeicher</a:t>
-            </a:r>
-            <a:endParaRPr lang="en-US" sz="1700" dirty="0"/>
-          </a:p>
-        </p:txBody>
-      </p:sp>
-      <p:sp>
-        <p:nvSpPr>
-          <p:cNvPr id="21" name="Text 18"/>
-          <p:cNvSpPr txBox="1"/>
-          <p:nvPr/>
-        </p:nvSpPr>
-        <p:spPr>
-          <a:xfrm>
-            <a:off x="822960" y="4233672"/>
-            <a:ext cx="10607040" cy="914400"/>
-          </a:xfrm>
-          <a:prstGeom prst="rect">
-            <a:avLst/>
-          </a:prstGeom>
-          <a:noFill/>
-          <a:ln/>
-        </p:spPr>
-        <p:txBody>
-          <a:bodyPr wrap="square" lIns="0" tIns="0" rIns="0" bIns="0" rtlCol="0" anchor="t"/>
-          <a:lstStyle/>
-          <a:p>
-            <a:pPr indent="0" marL="0">
-              <a:buNone/>
-            </a:pPr>
-            <a:r>
-              <a:rPr lang="en-US" sz="2000" dirty="0">
+              <a:t>Der König entscheidet allein über Gesetze, Krieg und Steuern.</a:t>
+            </a:r>
+            <a:endParaRPr lang="en-US" sz="2200" dirty="0"/>
+          </a:p>
+        </p:txBody>
+      </p:sp>
+      <p:sp>
+        <p:nvSpPr>
+          <p:cNvPr id="23" name="Shape 20"/>
+          <p:cNvSpPr/>
+          <p:nvPr/>
+        </p:nvSpPr>
+        <p:spPr>
+          <a:xfrm>
+            <a:off x="548640" y="3950208"/>
+            <a:ext cx="11109960" cy="530352"/>
+          </a:xfrm>
+          <a:prstGeom prst="roundRect">
+            <a:avLst>
+              <a:gd name="adj" fmla="val 13793"/>
+            </a:avLst>
+          </a:prstGeom>
+          <a:solidFill>
+            <a:srgbClr val="F4F7FD"/>
+          </a:solidFill>
+          <a:ln/>
+        </p:spPr>
+      </p:sp>
+      <p:sp>
+        <p:nvSpPr>
+          <p:cNvPr id="24" name="Shape 21"/>
+          <p:cNvSpPr/>
+          <p:nvPr/>
+        </p:nvSpPr>
+        <p:spPr>
+          <a:xfrm>
+            <a:off x="685800" y="4032504"/>
+            <a:ext cx="365760" cy="365760"/>
+          </a:xfrm>
+          <a:prstGeom prst="ellipse">
+            <a:avLst/>
+          </a:prstGeom>
+          <a:solidFill>
+            <a:srgbClr val="D9534F"/>
+          </a:solidFill>
+          <a:ln/>
+        </p:spPr>
+      </p:sp>
+      <p:sp>
+        <p:nvSpPr>
+          <p:cNvPr id="25" name="Text 22"/>
+          <p:cNvSpPr txBox="1"/>
+          <p:nvPr/>
+        </p:nvSpPr>
+        <p:spPr>
+          <a:xfrm>
+            <a:off x="685800" y="4032504"/>
+            <a:ext cx="365760" cy="365760"/>
+          </a:xfrm>
+          <a:prstGeom prst="rect">
+            <a:avLst/>
+          </a:prstGeom>
+          <a:noFill/>
+          <a:ln/>
+        </p:spPr>
+        <p:txBody>
+          <a:bodyPr wrap="square" lIns="0" tIns="0" rIns="0" bIns="0" rtlCol="0" anchor="ctr"/>
+          <a:lstStyle/>
+          <a:p>
+            <a:pPr algn="ctr" indent="0" marL="0">
+              <a:buNone/>
+            </a:pPr>
+            <a:r>
+              <a:rPr lang="en-US" sz="1800" b="1" dirty="0">
+                <a:solidFill>
+                  <a:srgbClr val="FFFFFF"/>
+                </a:solidFill>
+                <a:latin typeface="Calibri" pitchFamily="34" charset="0"/>
+                <a:ea typeface="Calibri" pitchFamily="34" charset="-122"/>
+                <a:cs typeface="Calibri" pitchFamily="34" charset="-120"/>
+              </a:rPr>
+              <a:t>2</a:t>
+            </a:r>
+            <a:endParaRPr lang="en-US" sz="1800" dirty="0"/>
+          </a:p>
+        </p:txBody>
+      </p:sp>
+      <p:sp>
+        <p:nvSpPr>
+          <p:cNvPr id="26" name="Text 23"/>
+          <p:cNvSpPr txBox="1"/>
+          <p:nvPr/>
+        </p:nvSpPr>
+        <p:spPr>
+          <a:xfrm>
+            <a:off x="1280160" y="3950208"/>
+            <a:ext cx="10241280" cy="530352"/>
+          </a:xfrm>
+          <a:prstGeom prst="rect">
+            <a:avLst/>
+          </a:prstGeom>
+          <a:noFill/>
+          <a:ln/>
+        </p:spPr>
+        <p:txBody>
+          <a:bodyPr wrap="square" lIns="0" tIns="0" rIns="0" bIns="0" rtlCol="0" anchor="ctr"/>
+          <a:lstStyle/>
+          <a:p>
+            <a:pPr indent="0" marL="0">
+              <a:buNone/>
+            </a:pPr>
+            <a:r>
+              <a:rPr lang="en-US" sz="2200" dirty="0">
                 <a:solidFill>
                   <a:srgbClr val="1E2761"/>
                 </a:solidFill>
@@ -9383,9 +9143,249 @@
                 <a:ea typeface="Cambria" pitchFamily="34" charset="-122"/>
                 <a:cs typeface="Cambria" pitchFamily="34" charset="-120"/>
               </a:rPr>
-              <a:t>Beamte · Glaube · Söldner · Merkantilismus · Gottesgnadentum · Versailles · Steuerfreiheit · Zölle · stehendes · 400.000 · Drittel · absoluter · Intendanten · Parlament</a:t>
-            </a:r>
-            <a:endParaRPr lang="en-US" sz="2000" dirty="0"/>
+              <a:t>Ein Parlament kann Steuererhöhungen des Königs verbieten.</a:t>
+            </a:r>
+            <a:endParaRPr lang="en-US" sz="2200" dirty="0"/>
+          </a:p>
+        </p:txBody>
+      </p:sp>
+      <p:sp>
+        <p:nvSpPr>
+          <p:cNvPr id="27" name="Shape 24"/>
+          <p:cNvSpPr/>
+          <p:nvPr/>
+        </p:nvSpPr>
+        <p:spPr>
+          <a:xfrm>
+            <a:off x="548640" y="4553712"/>
+            <a:ext cx="11109960" cy="530352"/>
+          </a:xfrm>
+          <a:prstGeom prst="roundRect">
+            <a:avLst>
+              <a:gd name="adj" fmla="val 13793"/>
+            </a:avLst>
+          </a:prstGeom>
+          <a:solidFill>
+            <a:srgbClr val="F4F7FD"/>
+          </a:solidFill>
+          <a:ln/>
+        </p:spPr>
+      </p:sp>
+      <p:sp>
+        <p:nvSpPr>
+          <p:cNvPr id="28" name="Shape 25"/>
+          <p:cNvSpPr/>
+          <p:nvPr/>
+        </p:nvSpPr>
+        <p:spPr>
+          <a:xfrm>
+            <a:off x="685800" y="4636008"/>
+            <a:ext cx="365760" cy="365760"/>
+          </a:xfrm>
+          <a:prstGeom prst="ellipse">
+            <a:avLst/>
+          </a:prstGeom>
+          <a:solidFill>
+            <a:srgbClr val="D9534F"/>
+          </a:solidFill>
+          <a:ln/>
+        </p:spPr>
+      </p:sp>
+      <p:sp>
+        <p:nvSpPr>
+          <p:cNvPr id="29" name="Text 26"/>
+          <p:cNvSpPr txBox="1"/>
+          <p:nvPr/>
+        </p:nvSpPr>
+        <p:spPr>
+          <a:xfrm>
+            <a:off x="685800" y="4636008"/>
+            <a:ext cx="365760" cy="365760"/>
+          </a:xfrm>
+          <a:prstGeom prst="rect">
+            <a:avLst/>
+          </a:prstGeom>
+          <a:noFill/>
+          <a:ln/>
+        </p:spPr>
+        <p:txBody>
+          <a:bodyPr wrap="square" lIns="0" tIns="0" rIns="0" bIns="0" rtlCol="0" anchor="ctr"/>
+          <a:lstStyle/>
+          <a:p>
+            <a:pPr algn="ctr" indent="0" marL="0">
+              <a:buNone/>
+            </a:pPr>
+            <a:r>
+              <a:rPr lang="en-US" sz="1800" b="1" dirty="0">
+                <a:solidFill>
+                  <a:srgbClr val="FFFFFF"/>
+                </a:solidFill>
+                <a:latin typeface="Calibri" pitchFamily="34" charset="0"/>
+                <a:ea typeface="Calibri" pitchFamily="34" charset="-122"/>
+                <a:cs typeface="Calibri" pitchFamily="34" charset="-120"/>
+              </a:rPr>
+              <a:t>3</a:t>
+            </a:r>
+            <a:endParaRPr lang="en-US" sz="1800" dirty="0"/>
+          </a:p>
+        </p:txBody>
+      </p:sp>
+      <p:sp>
+        <p:nvSpPr>
+          <p:cNvPr id="30" name="Text 27"/>
+          <p:cNvSpPr txBox="1"/>
+          <p:nvPr/>
+        </p:nvSpPr>
+        <p:spPr>
+          <a:xfrm>
+            <a:off x="1280160" y="4553712"/>
+            <a:ext cx="10241280" cy="530352"/>
+          </a:xfrm>
+          <a:prstGeom prst="rect">
+            <a:avLst/>
+          </a:prstGeom>
+          <a:noFill/>
+          <a:ln/>
+        </p:spPr>
+        <p:txBody>
+          <a:bodyPr wrap="square" lIns="0" tIns="0" rIns="0" bIns="0" rtlCol="0" anchor="ctr"/>
+          <a:lstStyle/>
+          <a:p>
+            <a:pPr indent="0" marL="0">
+              <a:buNone/>
+            </a:pPr>
+            <a:r>
+              <a:rPr lang="en-US" sz="2200" dirty="0">
+                <a:solidFill>
+                  <a:srgbClr val="1E2761"/>
+                </a:solidFill>
+                <a:latin typeface="Cambria" pitchFamily="34" charset="0"/>
+                <a:ea typeface="Cambria" pitchFamily="34" charset="-122"/>
+                <a:cs typeface="Cambria" pitchFamily="34" charset="-120"/>
+              </a:rPr>
+              <a:t>Beamte handeln im Namen des Königs und müssen ihm gehorchen.</a:t>
+            </a:r>
+            <a:endParaRPr lang="en-US" sz="2200" dirty="0"/>
+          </a:p>
+        </p:txBody>
+      </p:sp>
+      <p:sp>
+        <p:nvSpPr>
+          <p:cNvPr id="31" name="Shape 28"/>
+          <p:cNvSpPr/>
+          <p:nvPr/>
+        </p:nvSpPr>
+        <p:spPr>
+          <a:xfrm>
+            <a:off x="548640" y="5157216"/>
+            <a:ext cx="11109960" cy="530352"/>
+          </a:xfrm>
+          <a:prstGeom prst="roundRect">
+            <a:avLst>
+              <a:gd name="adj" fmla="val 13793"/>
+            </a:avLst>
+          </a:prstGeom>
+          <a:solidFill>
+            <a:srgbClr val="F4F7FD"/>
+          </a:solidFill>
+          <a:ln/>
+        </p:spPr>
+      </p:sp>
+      <p:sp>
+        <p:nvSpPr>
+          <p:cNvPr id="32" name="Shape 29"/>
+          <p:cNvSpPr/>
+          <p:nvPr/>
+        </p:nvSpPr>
+        <p:spPr>
+          <a:xfrm>
+            <a:off x="685800" y="5239512"/>
+            <a:ext cx="365760" cy="365760"/>
+          </a:xfrm>
+          <a:prstGeom prst="ellipse">
+            <a:avLst/>
+          </a:prstGeom>
+          <a:solidFill>
+            <a:srgbClr val="D9534F"/>
+          </a:solidFill>
+          <a:ln/>
+        </p:spPr>
+      </p:sp>
+      <p:sp>
+        <p:nvSpPr>
+          <p:cNvPr id="33" name="Text 30"/>
+          <p:cNvSpPr txBox="1"/>
+          <p:nvPr/>
+        </p:nvSpPr>
+        <p:spPr>
+          <a:xfrm>
+            <a:off x="685800" y="5239512"/>
+            <a:ext cx="365760" cy="365760"/>
+          </a:xfrm>
+          <a:prstGeom prst="rect">
+            <a:avLst/>
+          </a:prstGeom>
+          <a:noFill/>
+          <a:ln/>
+        </p:spPr>
+        <p:txBody>
+          <a:bodyPr wrap="square" lIns="0" tIns="0" rIns="0" bIns="0" rtlCol="0" anchor="ctr"/>
+          <a:lstStyle/>
+          <a:p>
+            <a:pPr algn="ctr" indent="0" marL="0">
+              <a:buNone/>
+            </a:pPr>
+            <a:r>
+              <a:rPr lang="en-US" sz="1800" b="1" dirty="0">
+                <a:solidFill>
+                  <a:srgbClr val="FFFFFF"/>
+                </a:solidFill>
+                <a:latin typeface="Calibri" pitchFamily="34" charset="0"/>
+                <a:ea typeface="Calibri" pitchFamily="34" charset="-122"/>
+                <a:cs typeface="Calibri" pitchFamily="34" charset="-120"/>
+              </a:rPr>
+              <a:t>4</a:t>
+            </a:r>
+            <a:endParaRPr lang="en-US" sz="1800" dirty="0"/>
+          </a:p>
+        </p:txBody>
+      </p:sp>
+      <p:sp>
+        <p:nvSpPr>
+          <p:cNvPr id="34" name="Text 31"/>
+          <p:cNvSpPr txBox="1"/>
+          <p:nvPr/>
+        </p:nvSpPr>
+        <p:spPr>
+          <a:xfrm>
+            <a:off x="1280160" y="5157216"/>
+            <a:ext cx="10241280" cy="530352"/>
+          </a:xfrm>
+          <a:prstGeom prst="rect">
+            <a:avLst/>
+          </a:prstGeom>
+          <a:noFill/>
+          <a:ln/>
+        </p:spPr>
+        <p:txBody>
+          <a:bodyPr wrap="square" lIns="0" tIns="0" rIns="0" bIns="0" rtlCol="0" anchor="ctr"/>
+          <a:lstStyle/>
+          <a:p>
+            <a:pPr indent="0" marL="0">
+              <a:buNone/>
+            </a:pPr>
+            <a:r>
+              <a:rPr lang="en-US" sz="2200" dirty="0">
+                <a:solidFill>
+                  <a:srgbClr val="1E2761"/>
+                </a:solidFill>
+                <a:latin typeface="Cambria" pitchFamily="34" charset="0"/>
+                <a:ea typeface="Cambria" pitchFamily="34" charset="-122"/>
+                <a:cs typeface="Cambria" pitchFamily="34" charset="-120"/>
+              </a:rPr>
+              <a:t>Die Bürger wählen alle vier Jahre ihre Regierung.</a:t>
+            </a:r>
+            <a:endParaRPr lang="en-US" sz="2200" dirty="0"/>
           </a:p>
         </p:txBody>
       </p:sp>

</xml_diff>

<commit_message>
Geschichte 8: Lückentext ohne überzählige Wörter
Co-Authored-By: Claude Sonnet 5.5 <noreply@anthropic.com>
Claude-Session: https://claude.ai/code/session_01CtRuNVyt8v9M882BKEmgNb
</commit_message>
<xml_diff>
--- a/Geschichte_8/Absolutismus_Wiederholung/Praesentation_Absolutismus_Wiederholung.pptx
+++ b/Geschichte_8/Absolutismus_Wiederholung/Praesentation_Absolutismus_Wiederholung.pptx
@@ -2018,7 +2018,7 @@
           <a:p>
             <a:r>
               <a:rPr lang="en-US" dirty="0"/>
-              <a:t>Lösung: 1 absoluter · 2 Beamte · 3 Intendanten · 4 Steuerfreiheit · 5 Versailles · 6 Merkantilismus · 7 Zölle · 8 Gottesgnadentum · 9 Glaube · 10 stehendes · 11 400.000 · 12 Drittel. Nicht passend: Söldner, Parlament. Kontrolle: „Wer drankommt, liest einen Absatz vor. Alle prüfen mit.“ Dann „Vergleicht und verbessert mit Grün.“ Schnelle machen die ★-Aufgabe (wichtigste Säule begründen).</a:t>
+              <a:t>Lösung: 1 absoluter · 2 Beamte · 3 Intendanten · 4 Steuerfreiheit · 5 Versailles · 6 Merkantilismus · 7 Zölle · 8 Gottesgnadentum · 9 Glaube · 10 stehendes · 11 400.000 · 12 Drittel. Kontrolle: „Wer drankommt, liest einen Absatz vor. Alle prüfen mit.“ Dann „Vergleicht und verbessert mit Grün.“ Schnelle machen die ★-Aufgabe (wichtigste Säule begründen).</a:t>
             </a:r>
             <a:endParaRPr lang="en-US" dirty="0"/>
           </a:p>
@@ -14347,7 +14347,7 @@
                 <a:ea typeface="Calibri" pitchFamily="34" charset="-122"/>
                 <a:cs typeface="Calibri" pitchFamily="34" charset="-120"/>
               </a:rPr>
-              <a:t>Streiche jedes benutzte Wort durch. Zwei Wörter passen nicht.</a:t>
+              <a:t>Streiche jedes benutzte Wort durch.</a:t>
             </a:r>
             <a:endParaRPr lang="en-US" sz="2100" dirty="0"/>
           </a:p>
@@ -14614,7 +14614,7 @@
                 <a:ea typeface="Cambria" pitchFamily="34" charset="-122"/>
                 <a:cs typeface="Cambria" pitchFamily="34" charset="-120"/>
               </a:rPr>
-              <a:t>Beamte · Glaube · Söldner · Merkantilismus · Gottesgnadentum · Versailles · Steuerfreiheit · Zölle · stehendes · 400.000 · Drittel · absoluter · Intendanten · Parlament</a:t>
+              <a:t>Beamte · Glaube · Merkantilismus · Gottesgnadentum · Versailles · Steuerfreiheit · Zölle · stehendes · 400.000 · Drittel · absoluter · Intendanten</a:t>
             </a:r>
             <a:endParaRPr lang="en-US" sz="2000" dirty="0"/>
           </a:p>

</xml_diff>